<commit_message>
fix(demo-day): replace empty text slides with real product screenshots
Slide 2 (El problema) now shows the actual cold-start app state next
to the headline, and slide 10 (Cierre) drops the redundant demo/repo
links (already in the document header) in favor of the full product
screenshot, so no slide is text-only anymore.
</commit_message>
<xml_diff>
--- a/evidence/2026-08-22-demo-day/Nahui - Pitch Demo Day.pptx
+++ b/evidence/2026-08-22-demo-day/Nahui - Pitch Demo Day.pptx
@@ -3328,7 +3328,7 @@
         </p:nvSpPr>
         <p:spPr>
           <a:xfrm>
-            <a:off x="822960" y="1828800"/>
+            <a:off x="822960" y="2697480"/>
             <a:ext cx="9144000" cy="1463040"/>
           </a:xfrm>
           <a:prstGeom prst="rect">
@@ -3359,84 +3359,30 @@
           </a:p>
         </p:txBody>
       </p:sp>
-      <p:sp>
-        <p:nvSpPr>
-          <p:cNvPr id="4" name="TextBox 3"/>
-          <p:cNvSpPr txBox="1"/>
+      <p:pic>
+        <p:nvPicPr>
+          <p:cNvPr id="4" name="Picture 3" descr="00-hook-full.png"/>
+          <p:cNvPicPr>
+            <a:picLocks noChangeAspect="1"/>
+          </p:cNvPicPr>
           <p:nvPr/>
-        </p:nvSpPr>
-        <p:spPr>
-          <a:xfrm>
-            <a:off x="868680" y="3657600"/>
-            <a:ext cx="9144000" cy="548640"/>
+        </p:nvPicPr>
+        <p:blipFill>
+          <a:blip r:embed="rId2"/>
+          <a:stretch>
+            <a:fillRect/>
+          </a:stretch>
+        </p:blipFill>
+        <p:spPr>
+          <a:xfrm>
+            <a:off x="8753081" y="548640"/>
+            <a:ext cx="2615654" cy="5669280"/>
           </a:xfrm>
           <a:prstGeom prst="rect">
             <a:avLst/>
           </a:prstGeom>
-          <a:noFill/>
-        </p:spPr>
-        <p:txBody>
-          <a:bodyPr wrap="square" anchor="t">
-            <a:spAutoFit/>
-          </a:bodyPr>
-          <a:lstStyle/>
-          <a:p>
-            <a:pPr algn="l">
-              <a:lnSpc>
-                <a:spcPct val="100000"/>
-              </a:lnSpc>
-            </a:pPr>
-            <a:r>
-              <a:rPr sz="2200" b="1" i="0">
-                <a:solidFill>
-                  <a:srgbClr val="E8836A"/>
-                </a:solidFill>
-                <a:latin typeface="Inter"/>
-              </a:rPr>
-              <a:t>Demo en vivo:  demo.nahui.app</a:t>
-            </a:r>
-          </a:p>
-        </p:txBody>
-      </p:sp>
-      <p:sp>
-        <p:nvSpPr>
-          <p:cNvPr id="5" name="TextBox 4"/>
-          <p:cNvSpPr txBox="1"/>
-          <p:nvPr/>
-        </p:nvSpPr>
-        <p:spPr>
-          <a:xfrm>
-            <a:off x="868680" y="4206240"/>
-            <a:ext cx="9144000" cy="548640"/>
-          </a:xfrm>
-          <a:prstGeom prst="rect">
-            <a:avLst/>
-          </a:prstGeom>
-          <a:noFill/>
-        </p:spPr>
-        <p:txBody>
-          <a:bodyPr wrap="square" anchor="t">
-            <a:spAutoFit/>
-          </a:bodyPr>
-          <a:lstStyle/>
-          <a:p>
-            <a:pPr algn="l">
-              <a:lnSpc>
-                <a:spcPct val="100000"/>
-              </a:lnSpc>
-            </a:pPr>
-            <a:r>
-              <a:rPr sz="2200" b="1" i="0">
-                <a:solidFill>
-                  <a:srgbClr val="E8836A"/>
-                </a:solidFill>
-                <a:latin typeface="Inter"/>
-              </a:rPr>
-              <a:t>Repositorio:  github.com/claudiafalcon/nahui</a:t>
-            </a:r>
-          </a:p>
-        </p:txBody>
-      </p:sp>
+        </p:spPr>
+      </p:pic>
     </p:spTree>
   </p:cSld>
   <p:clrMapOvr>
@@ -3508,7 +3454,7 @@
         <p:spPr>
           <a:xfrm>
             <a:off x="822960" y="1554480"/>
-            <a:ext cx="10515600" cy="2926080"/>
+            <a:ext cx="7315200" cy="2926080"/>
           </a:xfrm>
           <a:prstGeom prst="rect">
             <a:avLst/>
@@ -3547,8 +3493,8 @@
         </p:nvSpPr>
         <p:spPr>
           <a:xfrm>
-            <a:off x="868680" y="4480560"/>
-            <a:ext cx="9601200" cy="1188720"/>
+            <a:off x="868680" y="4937760"/>
+            <a:ext cx="7000000" cy="1097280"/>
           </a:xfrm>
           <a:prstGeom prst="rect">
             <a:avLst/>
@@ -3579,6 +3525,30 @@
           </a:p>
         </p:txBody>
       </p:sp>
+      <p:pic>
+        <p:nvPicPr>
+          <p:cNvPr id="5" name="Picture 4" descr="image.png"/>
+          <p:cNvPicPr>
+            <a:picLocks noChangeAspect="1"/>
+          </p:cNvPicPr>
+          <p:nvPr/>
+        </p:nvPicPr>
+        <p:blipFill>
+          <a:blip r:embed="rId2"/>
+          <a:stretch>
+            <a:fillRect/>
+          </a:stretch>
+        </p:blipFill>
+        <p:spPr>
+          <a:xfrm>
+            <a:off x="7894015" y="2203420"/>
+            <a:ext cx="3474720" cy="2451159"/>
+          </a:xfrm>
+          <a:prstGeom prst="rect">
+            <a:avLst/>
+          </a:prstGeom>
+        </p:spPr>
+      </p:pic>
     </p:spTree>
   </p:cSld>
   <p:clrMapOvr>

</xml_diff>

<commit_message>
fix(demo-day): add real Vercel evidence to campaign results slide
Slide 6 now shows the actual traffic chart (583 visitors over the
campaign window) and the demo funnel events breakdown, cropped from
the real Vercel Analytics screenshots, instead of numbers alone.
</commit_message>
<xml_diff>
--- a/evidence/2026-08-22-demo-day/Nahui - Pitch Demo Day.pptx
+++ b/evidence/2026-08-22-demo-day/Nahui - Pitch Demo Day.pptx
@@ -4114,7 +4114,7 @@
         </p:nvSpPr>
         <p:spPr>
           <a:xfrm>
-            <a:off x="822960" y="914400"/>
+            <a:off x="822960" y="685800"/>
             <a:ext cx="3474720" cy="1645920"/>
           </a:xfrm>
           <a:prstGeom prst="rect">
@@ -4153,7 +4153,7 @@
         </p:nvSpPr>
         <p:spPr>
           <a:xfrm>
-            <a:off x="868680" y="2514600"/>
+            <a:off x="868680" y="2286000"/>
             <a:ext cx="3474720" cy="548640"/>
           </a:xfrm>
           <a:prstGeom prst="rect">
@@ -4192,7 +4192,7 @@
         </p:nvSpPr>
         <p:spPr>
           <a:xfrm>
-            <a:off x="4480560" y="914400"/>
+            <a:off x="4480560" y="685800"/>
             <a:ext cx="3474720" cy="1645920"/>
           </a:xfrm>
           <a:prstGeom prst="rect">
@@ -4231,7 +4231,7 @@
         </p:nvSpPr>
         <p:spPr>
           <a:xfrm>
-            <a:off x="4526280" y="2514600"/>
+            <a:off x="4526280" y="2286000"/>
             <a:ext cx="3474720" cy="548640"/>
           </a:xfrm>
           <a:prstGeom prst="rect">
@@ -4270,7 +4270,7 @@
         </p:nvSpPr>
         <p:spPr>
           <a:xfrm>
-            <a:off x="8138160" y="914400"/>
+            <a:off x="8138160" y="685800"/>
             <a:ext cx="3474720" cy="1645920"/>
           </a:xfrm>
           <a:prstGeom prst="rect">
@@ -4309,7 +4309,7 @@
         </p:nvSpPr>
         <p:spPr>
           <a:xfrm>
-            <a:off x="8183879" y="2514600"/>
+            <a:off x="8183879" y="2286000"/>
             <a:ext cx="3474720" cy="548640"/>
           </a:xfrm>
           <a:prstGeom prst="rect">
@@ -4348,7 +4348,7 @@
         </p:nvSpPr>
         <p:spPr>
           <a:xfrm>
-            <a:off x="868680" y="4937760"/>
+            <a:off x="868680" y="5250000"/>
             <a:ext cx="9601200" cy="1097280"/>
           </a:xfrm>
           <a:prstGeom prst="rect">
@@ -4379,6 +4379,54 @@
           </a:p>
         </p:txBody>
       </p:sp>
+      <p:pic>
+        <p:nvPicPr>
+          <p:cNvPr id="10" name="Picture 9" descr="vercel1-chart.png"/>
+          <p:cNvPicPr>
+            <a:picLocks noChangeAspect="1"/>
+          </p:cNvPicPr>
+          <p:nvPr/>
+        </p:nvPicPr>
+        <p:blipFill>
+          <a:blip r:embed="rId2"/>
+          <a:stretch>
+            <a:fillRect/>
+          </a:stretch>
+        </p:blipFill>
+        <p:spPr>
+          <a:xfrm>
+            <a:off x="1093960" y="3000000"/>
+            <a:ext cx="5040588" cy="2050000"/>
+          </a:xfrm>
+          <a:prstGeom prst="rect">
+            <a:avLst/>
+          </a:prstGeom>
+        </p:spPr>
+      </p:pic>
+      <p:pic>
+        <p:nvPicPr>
+          <p:cNvPr id="11" name="Picture 10" descr="vercel2-events.png"/>
+          <p:cNvPicPr>
+            <a:picLocks noChangeAspect="1"/>
+          </p:cNvPicPr>
+          <p:nvPr/>
+        </p:nvPicPr>
+        <p:blipFill>
+          <a:blip r:embed="rId3"/>
+          <a:stretch>
+            <a:fillRect/>
+          </a:stretch>
+        </p:blipFill>
+        <p:spPr>
+          <a:xfrm>
+            <a:off x="6434548" y="3000000"/>
+            <a:ext cx="4663186" cy="2050000"/>
+          </a:xfrm>
+          <a:prstGeom prst="rect">
+            <a:avLst/>
+          </a:prstGeom>
+        </p:spPr>
+      </p:pic>
     </p:spTree>
   </p:cSld>
   <p:clrMapOvr>

</xml_diff>

<commit_message>
redesign(demo-day): full-bleed diagrams and varied layouts for pitch deck
Slides 7-9 (equipo/ciclo/timeline) were three crops of the same shared
HTML sheet, cream background, tiny box, huge dead space below - felt
like the same image repeated. Rebuilt each as its own full-bleed
1280x720 design: equipo stays a light org-chart tree, ciclo becomes a
dark radial wheel (Hallazgo real as the hub), timeline becomes a
two-column light layout. Also broke up slides 3-5 (three identical
cream-bg, image-right screenshots) by alternating background and
image side per slide.
</commit_message>
<xml_diff>
--- a/evidence/2026-08-22-demo-day/Nahui - Pitch Demo Day.pptx
+++ b/evidence/2026-08-22-demo-day/Nahui - Pitch Demo Day.pptx
@@ -3747,7 +3747,7 @@
             <a:avLst/>
           </a:prstGeom>
           <a:solidFill>
-            <a:srgbClr val="FAF9F5"/>
+            <a:srgbClr val="141413"/>
           </a:solidFill>
           <a:ln>
             <a:noFill/>
@@ -3784,7 +3784,7 @@
         </p:nvSpPr>
         <p:spPr>
           <a:xfrm>
-            <a:off x="822960" y="1463040"/>
+            <a:off x="6126480" y="1463040"/>
             <a:ext cx="3931920" cy="2194560"/>
           </a:xfrm>
           <a:prstGeom prst="rect">
@@ -3806,7 +3806,7 @@
             <a:r>
               <a:rPr sz="5200" b="1" i="0">
                 <a:solidFill>
-                  <a:srgbClr val="C13F26"/>
+                  <a:srgbClr val="FFFFFF"/>
                 </a:solidFill>
                 <a:latin typeface="Fredoka"/>
               </a:rPr>
@@ -3824,7 +3824,7 @@
         </p:nvSpPr>
         <p:spPr>
           <a:xfrm>
-            <a:off x="868680" y="3383280"/>
+            <a:off x="6172200" y="3383280"/>
             <a:ext cx="3840480" cy="1280160"/>
           </a:xfrm>
           <a:prstGeom prst="rect">
@@ -3846,7 +3846,7 @@
             <a:r>
               <a:rPr sz="1600" b="0" i="0">
                 <a:solidFill>
-                  <a:srgbClr val="6B6B67"/>
+                  <a:srgbClr val="C7C5C0"/>
                 </a:solidFill>
                 <a:latin typeface="Inter"/>
               </a:rPr>
@@ -3871,7 +3871,7 @@
         </p:blipFill>
         <p:spPr>
           <a:xfrm>
-            <a:off x="6126480" y="548640"/>
+            <a:off x="822960" y="548640"/>
             <a:ext cx="4220064" cy="5669280"/>
           </a:xfrm>
           <a:prstGeom prst="rect">
@@ -3949,7 +3949,7 @@
         </p:nvSpPr>
         <p:spPr>
           <a:xfrm>
-            <a:off x="822960" y="1463040"/>
+            <a:off x="7300000" y="1463040"/>
             <a:ext cx="3931920" cy="2194560"/>
           </a:xfrm>
           <a:prstGeom prst="rect">
@@ -3989,7 +3989,7 @@
         </p:nvSpPr>
         <p:spPr>
           <a:xfrm>
-            <a:off x="868680" y="3383280"/>
+            <a:off x="7345720" y="3383280"/>
             <a:ext cx="3840480" cy="1280160"/>
           </a:xfrm>
           <a:prstGeom prst="rect">
@@ -4036,7 +4036,7 @@
         </p:blipFill>
         <p:spPr>
           <a:xfrm>
-            <a:off x="6400800" y="548640"/>
+            <a:off x="822960" y="548640"/>
             <a:ext cx="6229447" cy="5669280"/>
           </a:xfrm>
           <a:prstGeom prst="rect">
@@ -4491,67 +4491,28 @@
       </p:sp>
       <p:pic>
         <p:nvPicPr>
-          <p:cNvPr id="3" name="Picture 2" descr="anexo-1-agentes.png"/>
+          <p:cNvPr id="3" name="Picture 2" descr="equipo-v2.png"/>
           <p:cNvPicPr>
             <a:picLocks noChangeAspect="1"/>
           </p:cNvPicPr>
           <p:nvPr/>
         </p:nvPicPr>
         <p:blipFill>
-          <a:blip r:embed="rId2"/>
+          <a:blip r:embed="rId3"/>
           <a:stretch>
             <a:fillRect/>
           </a:stretch>
         </p:blipFill>
         <p:spPr>
           <a:xfrm>
-            <a:off x="548640" y="914400"/>
-            <a:ext cx="11064240" cy="3382082"/>
+            <a:off x="0" y="0"/>
+            <a:ext cx="12191695" cy="6858000"/>
           </a:xfrm>
           <a:prstGeom prst="rect">
             <a:avLst/>
           </a:prstGeom>
         </p:spPr>
       </p:pic>
-      <p:sp>
-        <p:nvSpPr>
-          <p:cNvPr id="4" name="TextBox 3"/>
-          <p:cNvSpPr txBox="1"/>
-          <p:nvPr/>
-        </p:nvSpPr>
-        <p:spPr>
-          <a:xfrm>
-            <a:off x="822960" y="6035040"/>
-            <a:ext cx="10515600" cy="640080"/>
-          </a:xfrm>
-          <a:prstGeom prst="rect">
-            <a:avLst/>
-          </a:prstGeom>
-          <a:noFill/>
-        </p:spPr>
-        <p:txBody>
-          <a:bodyPr wrap="square" anchor="t">
-            <a:spAutoFit/>
-          </a:bodyPr>
-          <a:lstStyle/>
-          <a:p>
-            <a:pPr algn="l">
-              <a:lnSpc>
-                <a:spcPct val="100000"/>
-              </a:lnSpc>
-            </a:pPr>
-            <a:r>
-              <a:rPr sz="1800" b="0" i="0">
-                <a:solidFill>
-                  <a:srgbClr val="6B6B67"/>
-                </a:solidFill>
-                <a:latin typeface="Inter"/>
-              </a:rPr>
-              <a:t>Un equipo de agentes de IA, no una sola IA generalista. Cada uno con su propia autoridad.</a:t>
-            </a:r>
-          </a:p>
-        </p:txBody>
-      </p:sp>
     </p:spTree>
   </p:cSld>
   <p:clrMapOvr>
@@ -4616,67 +4577,28 @@
       </p:sp>
       <p:pic>
         <p:nvPicPr>
-          <p:cNvPr id="3" name="Picture 2" descr="anexo-3-ciclo.png"/>
+          <p:cNvPr id="3" name="Picture 2" descr="ciclo-v2.png"/>
           <p:cNvPicPr>
             <a:picLocks noChangeAspect="1"/>
           </p:cNvPicPr>
           <p:nvPr/>
         </p:nvPicPr>
         <p:blipFill>
-          <a:blip r:embed="rId2"/>
+          <a:blip r:embed="rId3"/>
           <a:stretch>
             <a:fillRect/>
           </a:stretch>
         </p:blipFill>
         <p:spPr>
           <a:xfrm>
-            <a:off x="1280160" y="1097280"/>
-            <a:ext cx="9601200" cy="2201148"/>
+            <a:off x="0" y="0"/>
+            <a:ext cx="12191695" cy="6858000"/>
           </a:xfrm>
           <a:prstGeom prst="rect">
             <a:avLst/>
           </a:prstGeom>
         </p:spPr>
       </p:pic>
-      <p:sp>
-        <p:nvSpPr>
-          <p:cNvPr id="4" name="TextBox 3"/>
-          <p:cNvSpPr txBox="1"/>
-          <p:nvPr/>
-        </p:nvSpPr>
-        <p:spPr>
-          <a:xfrm>
-            <a:off x="822960" y="5669280"/>
-            <a:ext cx="10515600" cy="640080"/>
-          </a:xfrm>
-          <a:prstGeom prst="rect">
-            <a:avLst/>
-          </a:prstGeom>
-          <a:noFill/>
-        </p:spPr>
-        <p:txBody>
-          <a:bodyPr wrap="square" anchor="t">
-            <a:spAutoFit/>
-          </a:bodyPr>
-          <a:lstStyle/>
-          <a:p>
-            <a:pPr algn="l">
-              <a:lnSpc>
-                <a:spcPct val="100000"/>
-              </a:lnSpc>
-            </a:pPr>
-            <a:r>
-              <a:rPr sz="1800" b="0" i="0">
-                <a:solidFill>
-                  <a:srgbClr val="6B6B67"/>
-                </a:solidFill>
-                <a:latin typeface="Inter"/>
-              </a:rPr>
-              <a:t>Nada se da por cerrado sin comprobarlo contra el producto real.</a:t>
-            </a:r>
-          </a:p>
-        </p:txBody>
-      </p:sp>
     </p:spTree>
   </p:cSld>
   <p:clrMapOvr>
@@ -4741,22 +4663,22 @@
       </p:sp>
       <p:pic>
         <p:nvPicPr>
-          <p:cNvPr id="3" name="Picture 2" descr="slide-timeline-full.png"/>
+          <p:cNvPr id="3" name="Picture 2" descr="timeline-v2.png"/>
           <p:cNvPicPr>
             <a:picLocks noChangeAspect="1"/>
           </p:cNvPicPr>
           <p:nvPr/>
         </p:nvPicPr>
         <p:blipFill>
-          <a:blip r:embed="rId3"/>
+          <a:blip r:embed="rId4"/>
           <a:stretch>
             <a:fillRect/>
           </a:stretch>
         </p:blipFill>
         <p:spPr>
           <a:xfrm>
-            <a:off x="548640" y="457200"/>
-            <a:ext cx="10972800" cy="5270777"/>
+            <a:off x="0" y="0"/>
+            <a:ext cx="12191695" cy="6858000"/>
           </a:xfrm>
           <a:prstGeom prst="rect">
             <a:avLst/>

</xml_diff>

<commit_message>
docs(demo-day): add 10-minute speaker script as presenter notes
Written in first person, one note per slide, sized for roughly 10
minutes of live delivery. Visible in PowerPoint's Presenter View.
</commit_message>
<xml_diff>
--- a/evidence/2026-08-22-demo-day/Nahui - Pitch Demo Day.pptx
+++ b/evidence/2026-08-22-demo-day/Nahui - Pitch Demo Day.pptx
@@ -114,6 +114,1128 @@
     </a:lvl9pPr>
   </p:defaultTextStyle>
 </p:presentation>
+</file>
+
+<file path=ppt/notesMasters/notesMaster1.xml><?xml version="1.0" encoding="utf-8"?>
+<p:notesMaster xmlns:a="http://schemas.openxmlformats.org/drawingml/2006/main" xmlns:p="http://schemas.openxmlformats.org/presentationml/2006/main" xmlns:r="http://schemas.openxmlformats.org/officeDocument/2006/relationships">
+  <p:cSld>
+    <p:bg>
+      <p:bgRef idx="1001">
+        <a:schemeClr val="bg1"/>
+      </p:bgRef>
+    </p:bg>
+    <p:spTree>
+      <p:nvGrpSpPr>
+        <p:cNvPr id="1" name=""/>
+        <p:cNvGrpSpPr/>
+        <p:nvPr/>
+      </p:nvGrpSpPr>
+      <p:grpSpPr>
+        <a:xfrm>
+          <a:off x="0" y="0"/>
+          <a:ext cx="0" cy="0"/>
+          <a:chOff x="0" y="0"/>
+          <a:chExt cx="0" cy="0"/>
+        </a:xfrm>
+      </p:grpSpPr>
+      <p:sp>
+        <p:nvSpPr>
+          <p:cNvPr id="2" name="Header Placeholder 1"/>
+          <p:cNvSpPr>
+            <a:spLocks noGrp="1"/>
+          </p:cNvSpPr>
+          <p:nvPr>
+            <p:ph type="hdr" sz="quarter"/>
+          </p:nvPr>
+        </p:nvSpPr>
+        <p:spPr>
+          <a:xfrm>
+            <a:off x="0" y="0"/>
+            <a:ext cx="2971800" cy="457200"/>
+          </a:xfrm>
+          <a:prstGeom prst="rect">
+            <a:avLst/>
+          </a:prstGeom>
+        </p:spPr>
+        <p:txBody>
+          <a:bodyPr vert="horz" lIns="91440" tIns="45720" rIns="91440" bIns="45720" rtlCol="0"/>
+          <a:lstStyle>
+            <a:lvl1pPr algn="l">
+              <a:defRPr sz="1200"/>
+            </a:lvl1pPr>
+          </a:lstStyle>
+          <a:p>
+            <a:endParaRPr lang="en-US"/>
+          </a:p>
+        </p:txBody>
+      </p:sp>
+      <p:sp>
+        <p:nvSpPr>
+          <p:cNvPr id="3" name="Date Placeholder 2"/>
+          <p:cNvSpPr>
+            <a:spLocks noGrp="1"/>
+          </p:cNvSpPr>
+          <p:nvPr>
+            <p:ph type="dt" idx="1"/>
+          </p:nvPr>
+        </p:nvSpPr>
+        <p:spPr>
+          <a:xfrm>
+            <a:off x="3884613" y="0"/>
+            <a:ext cx="2971800" cy="457200"/>
+          </a:xfrm>
+          <a:prstGeom prst="rect">
+            <a:avLst/>
+          </a:prstGeom>
+        </p:spPr>
+        <p:txBody>
+          <a:bodyPr vert="horz" lIns="91440" tIns="45720" rIns="91440" bIns="45720" rtlCol="0"/>
+          <a:lstStyle>
+            <a:lvl1pPr algn="r">
+              <a:defRPr sz="1200"/>
+            </a:lvl1pPr>
+          </a:lstStyle>
+          <a:p>
+            <a:fld id="{0F89C1C7-3DCD-1040-A9CF-14679D8B5DDD}" type="datetimeFigureOut">
+              <a:rPr lang="en-US" smtClean="0"/>
+              <a:t>10/17/16</a:t>
+            </a:fld>
+            <a:endParaRPr lang="en-US"/>
+          </a:p>
+        </p:txBody>
+      </p:sp>
+      <p:sp>
+        <p:nvSpPr>
+          <p:cNvPr id="4" name="Slide Image Placeholder 3"/>
+          <p:cNvSpPr>
+            <a:spLocks noGrp="1" noRot="1" noChangeAspect="1"/>
+          </p:cNvSpPr>
+          <p:nvPr>
+            <p:ph type="sldImg" idx="2"/>
+          </p:nvPr>
+        </p:nvSpPr>
+        <p:spPr>
+          <a:xfrm>
+            <a:off x="1143000" y="685800"/>
+            <a:ext cx="4572000" cy="3429000"/>
+          </a:xfrm>
+          <a:prstGeom prst="rect">
+            <a:avLst/>
+          </a:prstGeom>
+          <a:noFill/>
+          <a:ln w="12700">
+            <a:solidFill>
+              <a:prstClr val="black"/>
+            </a:solidFill>
+          </a:ln>
+        </p:spPr>
+        <p:txBody>
+          <a:bodyPr vert="horz" lIns="91440" tIns="45720" rIns="91440" bIns="45720" rtlCol="0" anchor="ctr"/>
+          <a:lstStyle/>
+          <a:p>
+            <a:endParaRPr lang="en-US"/>
+          </a:p>
+        </p:txBody>
+      </p:sp>
+      <p:sp>
+        <p:nvSpPr>
+          <p:cNvPr id="5" name="Notes Placeholder 4"/>
+          <p:cNvSpPr>
+            <a:spLocks noGrp="1"/>
+          </p:cNvSpPr>
+          <p:nvPr>
+            <p:ph type="body" sz="quarter" idx="3"/>
+          </p:nvPr>
+        </p:nvSpPr>
+        <p:spPr>
+          <a:xfrm>
+            <a:off x="685800" y="4343400"/>
+            <a:ext cx="5486400" cy="4114800"/>
+          </a:xfrm>
+          <a:prstGeom prst="rect">
+            <a:avLst/>
+          </a:prstGeom>
+        </p:spPr>
+        <p:txBody>
+          <a:bodyPr vert="horz" lIns="91440" tIns="45720" rIns="91440" bIns="45720" rtlCol="0"/>
+          <a:lstStyle/>
+          <a:p>
+            <a:pPr lvl="0"/>
+            <a:r>
+              <a:rPr lang="en-US" smtClean="0"/>
+              <a:t>Click to edit Master text styles</a:t>
+            </a:r>
+          </a:p>
+          <a:p>
+            <a:pPr lvl="1"/>
+            <a:r>
+              <a:rPr lang="en-US" smtClean="0"/>
+              <a:t>Second level</a:t>
+            </a:r>
+          </a:p>
+          <a:p>
+            <a:pPr lvl="2"/>
+            <a:r>
+              <a:rPr lang="en-US" smtClean="0"/>
+              <a:t>Third level</a:t>
+            </a:r>
+          </a:p>
+          <a:p>
+            <a:pPr lvl="3"/>
+            <a:r>
+              <a:rPr lang="en-US" smtClean="0"/>
+              <a:t>Fourth level</a:t>
+            </a:r>
+          </a:p>
+          <a:p>
+            <a:pPr lvl="4"/>
+            <a:r>
+              <a:rPr lang="en-US" smtClean="0"/>
+              <a:t>Fifth level</a:t>
+            </a:r>
+            <a:endParaRPr lang="en-US"/>
+          </a:p>
+        </p:txBody>
+      </p:sp>
+      <p:sp>
+        <p:nvSpPr>
+          <p:cNvPr id="6" name="Footer Placeholder 5"/>
+          <p:cNvSpPr>
+            <a:spLocks noGrp="1"/>
+          </p:cNvSpPr>
+          <p:nvPr>
+            <p:ph type="ftr" sz="quarter" idx="4"/>
+          </p:nvPr>
+        </p:nvSpPr>
+        <p:spPr>
+          <a:xfrm>
+            <a:off x="0" y="8685213"/>
+            <a:ext cx="2971800" cy="457200"/>
+          </a:xfrm>
+          <a:prstGeom prst="rect">
+            <a:avLst/>
+          </a:prstGeom>
+        </p:spPr>
+        <p:txBody>
+          <a:bodyPr vert="horz" lIns="91440" tIns="45720" rIns="91440" bIns="45720" rtlCol="0" anchor="b"/>
+          <a:lstStyle>
+            <a:lvl1pPr algn="l">
+              <a:defRPr sz="1200"/>
+            </a:lvl1pPr>
+          </a:lstStyle>
+          <a:p>
+            <a:endParaRPr lang="en-US"/>
+          </a:p>
+        </p:txBody>
+      </p:sp>
+      <p:sp>
+        <p:nvSpPr>
+          <p:cNvPr id="7" name="Slide Number Placeholder 6"/>
+          <p:cNvSpPr>
+            <a:spLocks noGrp="1"/>
+          </p:cNvSpPr>
+          <p:nvPr>
+            <p:ph type="sldNum" sz="quarter" idx="5"/>
+          </p:nvPr>
+        </p:nvSpPr>
+        <p:spPr>
+          <a:xfrm>
+            <a:off x="3884613" y="8685213"/>
+            <a:ext cx="2971800" cy="457200"/>
+          </a:xfrm>
+          <a:prstGeom prst="rect">
+            <a:avLst/>
+          </a:prstGeom>
+        </p:spPr>
+        <p:txBody>
+          <a:bodyPr vert="horz" lIns="91440" tIns="45720" rIns="91440" bIns="45720" rtlCol="0" anchor="b"/>
+          <a:lstStyle>
+            <a:lvl1pPr algn="r">
+              <a:defRPr sz="1200"/>
+            </a:lvl1pPr>
+          </a:lstStyle>
+          <a:p>
+            <a:fld id="{BB5E49A5-4136-284D-997B-48E1D791AD67}" type="slidenum">
+              <a:rPr lang="en-US" smtClean="0"/>
+              <a:t>‹#›</a:t>
+            </a:fld>
+            <a:endParaRPr lang="en-US"/>
+          </a:p>
+        </p:txBody>
+      </p:sp>
+    </p:spTree>
+    <p:extLst>
+      <p:ext uri="{BB962C8B-B14F-4D97-AF65-F5344CB8AC3E}">
+        <p14:creationId xmlns:p14="http://schemas.microsoft.com/office/powerpoint/2010/main" val="2623252185"/>
+      </p:ext>
+    </p:extLst>
+  </p:cSld>
+  <p:clrMap bg1="lt1" tx1="dk1" bg2="lt2" tx2="dk2" accent1="accent1" accent2="accent2" accent3="accent3" accent4="accent4" accent5="accent5" accent6="accent6" hlink="hlink" folHlink="folHlink"/>
+  <p:notesStyle>
+    <a:lvl1pPr marL="0" algn="l" defTabSz="457200" rtl="0" eaLnBrk="1" latinLnBrk="0" hangingPunct="1">
+      <a:defRPr sz="1200" kern="1200">
+        <a:solidFill>
+          <a:schemeClr val="tx1"/>
+        </a:solidFill>
+        <a:latin typeface="+mn-lt"/>
+        <a:ea typeface="+mn-ea"/>
+        <a:cs typeface="+mn-cs"/>
+      </a:defRPr>
+    </a:lvl1pPr>
+    <a:lvl2pPr marL="457200" algn="l" defTabSz="457200" rtl="0" eaLnBrk="1" latinLnBrk="0" hangingPunct="1">
+      <a:defRPr sz="1200" kern="1200">
+        <a:solidFill>
+          <a:schemeClr val="tx1"/>
+        </a:solidFill>
+        <a:latin typeface="+mn-lt"/>
+        <a:ea typeface="+mn-ea"/>
+        <a:cs typeface="+mn-cs"/>
+      </a:defRPr>
+    </a:lvl2pPr>
+    <a:lvl3pPr marL="914400" algn="l" defTabSz="457200" rtl="0" eaLnBrk="1" latinLnBrk="0" hangingPunct="1">
+      <a:defRPr sz="1200" kern="1200">
+        <a:solidFill>
+          <a:schemeClr val="tx1"/>
+        </a:solidFill>
+        <a:latin typeface="+mn-lt"/>
+        <a:ea typeface="+mn-ea"/>
+        <a:cs typeface="+mn-cs"/>
+      </a:defRPr>
+    </a:lvl3pPr>
+    <a:lvl4pPr marL="1371600" algn="l" defTabSz="457200" rtl="0" eaLnBrk="1" latinLnBrk="0" hangingPunct="1">
+      <a:defRPr sz="1200" kern="1200">
+        <a:solidFill>
+          <a:schemeClr val="tx1"/>
+        </a:solidFill>
+        <a:latin typeface="+mn-lt"/>
+        <a:ea typeface="+mn-ea"/>
+        <a:cs typeface="+mn-cs"/>
+      </a:defRPr>
+    </a:lvl4pPr>
+    <a:lvl5pPr marL="1828800" algn="l" defTabSz="457200" rtl="0" eaLnBrk="1" latinLnBrk="0" hangingPunct="1">
+      <a:defRPr sz="1200" kern="1200">
+        <a:solidFill>
+          <a:schemeClr val="tx1"/>
+        </a:solidFill>
+        <a:latin typeface="+mn-lt"/>
+        <a:ea typeface="+mn-ea"/>
+        <a:cs typeface="+mn-cs"/>
+      </a:defRPr>
+    </a:lvl5pPr>
+    <a:lvl6pPr marL="2286000" algn="l" defTabSz="457200" rtl="0" eaLnBrk="1" latinLnBrk="0" hangingPunct="1">
+      <a:defRPr sz="1200" kern="1200">
+        <a:solidFill>
+          <a:schemeClr val="tx1"/>
+        </a:solidFill>
+        <a:latin typeface="+mn-lt"/>
+        <a:ea typeface="+mn-ea"/>
+        <a:cs typeface="+mn-cs"/>
+      </a:defRPr>
+    </a:lvl6pPr>
+    <a:lvl7pPr marL="2743200" algn="l" defTabSz="457200" rtl="0" eaLnBrk="1" latinLnBrk="0" hangingPunct="1">
+      <a:defRPr sz="1200" kern="1200">
+        <a:solidFill>
+          <a:schemeClr val="tx1"/>
+        </a:solidFill>
+        <a:latin typeface="+mn-lt"/>
+        <a:ea typeface="+mn-ea"/>
+        <a:cs typeface="+mn-cs"/>
+      </a:defRPr>
+    </a:lvl7pPr>
+    <a:lvl8pPr marL="3200400" algn="l" defTabSz="457200" rtl="0" eaLnBrk="1" latinLnBrk="0" hangingPunct="1">
+      <a:defRPr sz="1200" kern="1200">
+        <a:solidFill>
+          <a:schemeClr val="tx1"/>
+        </a:solidFill>
+        <a:latin typeface="+mn-lt"/>
+        <a:ea typeface="+mn-ea"/>
+        <a:cs typeface="+mn-cs"/>
+      </a:defRPr>
+    </a:lvl8pPr>
+    <a:lvl9pPr marL="3657600" algn="l" defTabSz="457200" rtl="0" eaLnBrk="1" latinLnBrk="0" hangingPunct="1">
+      <a:defRPr sz="1200" kern="1200">
+        <a:solidFill>
+          <a:schemeClr val="tx1"/>
+        </a:solidFill>
+        <a:latin typeface="+mn-lt"/>
+        <a:ea typeface="+mn-ea"/>
+        <a:cs typeface="+mn-cs"/>
+      </a:defRPr>
+    </a:lvl9pPr>
+  </p:notesStyle>
+</p:notesMaster>
+</file>
+
+<file path=ppt/notesSlides/notesSlide1.xml><?xml version="1.0" encoding="utf-8"?>
+<p:notes xmlns:a="http://schemas.openxmlformats.org/drawingml/2006/main" xmlns:p="http://schemas.openxmlformats.org/presentationml/2006/main" xmlns:r="http://schemas.openxmlformats.org/officeDocument/2006/relationships">
+  <p:cSld>
+    <p:spTree>
+      <p:nvGrpSpPr>
+        <p:cNvPr id="1" name=""/>
+        <p:cNvGrpSpPr/>
+        <p:nvPr/>
+      </p:nvGrpSpPr>
+      <p:grpSpPr>
+        <a:xfrm>
+          <a:off x="0" y="0"/>
+          <a:ext cx="0" cy="0"/>
+          <a:chOff x="0" y="0"/>
+          <a:chExt cx="0" cy="0"/>
+        </a:xfrm>
+      </p:grpSpPr>
+      <p:sp>
+        <p:nvSpPr>
+          <p:cNvPr id="2" name="Slide Image Placeholder 1"/>
+          <p:cNvSpPr>
+            <a:spLocks noGrp="1"/>
+          </p:cNvSpPr>
+          <p:nvPr>
+            <p:ph type="sldImg" idx="2"/>
+          </p:nvPr>
+        </p:nvSpPr>
+        <p:spPr/>
+      </p:sp>
+      <p:sp>
+        <p:nvSpPr>
+          <p:cNvPr id="3" name="Notes Placeholder 2"/>
+          <p:cNvSpPr>
+            <a:spLocks noGrp="1"/>
+          </p:cNvSpPr>
+          <p:nvPr>
+            <p:ph type="body" idx="3" sz="quarter"/>
+          </p:nvPr>
+        </p:nvSpPr>
+        <p:spPr/>
+        <p:txBody>
+          <a:bodyPr/>
+          <a:lstStyle/>
+          <a:p>
+            <a:r>
+              <a:t>Buenas tardes, soy Claudia y esto es Nahui.</a:t>
+            </a:r>
+          </a:p>
+          <a:p/>
+          <a:p>
+            <a:r>
+              <a:t>Nahui es una app de registro de ventas e inteligencia de negocio para vendedoras ambulantes en México. La piloteamos con Ana, que vende ropa en bazares privados en el Estado de México.</a:t>
+            </a:r>
+          </a:p>
+          <a:p/>
+          <a:p>
+            <a:r>
+              <a:t>La promesa es simple: registrar una venta en menos de 3 segundos, sin perder el control del negocio. Les voy a enseñar qué tan real es esto hoy, y qué tan lejos estamos todavía.</a:t>
+            </a:r>
+          </a:p>
+        </p:txBody>
+      </p:sp>
+      <p:sp>
+        <p:nvSpPr>
+          <p:cNvPr id="4" name="Slide Number Placeholder 3"/>
+          <p:cNvSpPr>
+            <a:spLocks noGrp="1"/>
+          </p:cNvSpPr>
+          <p:nvPr>
+            <p:ph type="sldNum" idx="5" sz="quarter"/>
+          </p:nvPr>
+        </p:nvSpPr>
+        <p:spPr/>
+      </p:sp>
+    </p:spTree>
+  </p:cSld>
+  <p:clrMapOvr>
+    <a:masterClrMapping/>
+  </p:clrMapOvr>
+</p:notes>
+</file>
+
+<file path=ppt/notesSlides/notesSlide10.xml><?xml version="1.0" encoding="utf-8"?>
+<p:notes xmlns:a="http://schemas.openxmlformats.org/drawingml/2006/main" xmlns:p="http://schemas.openxmlformats.org/presentationml/2006/main" xmlns:r="http://schemas.openxmlformats.org/officeDocument/2006/relationships">
+  <p:cSld>
+    <p:spTree>
+      <p:nvGrpSpPr>
+        <p:cNvPr id="1" name=""/>
+        <p:cNvGrpSpPr/>
+        <p:nvPr/>
+      </p:nvGrpSpPr>
+      <p:grpSpPr>
+        <a:xfrm>
+          <a:off x="0" y="0"/>
+          <a:ext cx="0" cy="0"/>
+          <a:chOff x="0" y="0"/>
+          <a:chExt cx="0" cy="0"/>
+        </a:xfrm>
+      </p:grpSpPr>
+      <p:sp>
+        <p:nvSpPr>
+          <p:cNvPr id="2" name="Slide Image Placeholder 1"/>
+          <p:cNvSpPr>
+            <a:spLocks noGrp="1"/>
+          </p:cNvSpPr>
+          <p:nvPr>
+            <p:ph type="sldImg" idx="2"/>
+          </p:nvPr>
+        </p:nvSpPr>
+        <p:spPr/>
+      </p:sp>
+      <p:sp>
+        <p:nvSpPr>
+          <p:cNvPr id="3" name="Notes Placeholder 2"/>
+          <p:cNvSpPr>
+            <a:spLocks noGrp="1"/>
+          </p:cNvSpPr>
+          <p:nvPr>
+            <p:ph type="body" idx="3" sz="quarter"/>
+          </p:nvPr>
+        </p:nvSpPr>
+        <p:spPr/>
+        <p:txBody>
+          <a:bodyPr/>
+          <a:lstStyle/>
+          <a:p>
+            <a:r>
+              <a:t>Esto es Nahui hoy: un prototipo real, funcionando, probado, con una campaña real detrás que nos enseñó que el alcance no es el problema, la adopción sí. Y con un equipo de agentes que revisa, corrige y vuelve a comprobar cada cosa antes de darla por buena.</a:t>
+            </a:r>
+          </a:p>
+          <a:p/>
+          <a:p>
+            <a:r>
+              <a:t>Todavía no lo tenemos todo resuelto, y está bien decirlo así. Ahí les dejo el demo y el repositorio. Gracias.</a:t>
+            </a:r>
+          </a:p>
+        </p:txBody>
+      </p:sp>
+      <p:sp>
+        <p:nvSpPr>
+          <p:cNvPr id="4" name="Slide Number Placeholder 3"/>
+          <p:cNvSpPr>
+            <a:spLocks noGrp="1"/>
+          </p:cNvSpPr>
+          <p:nvPr>
+            <p:ph type="sldNum" idx="5" sz="quarter"/>
+          </p:nvPr>
+        </p:nvSpPr>
+        <p:spPr/>
+      </p:sp>
+    </p:spTree>
+  </p:cSld>
+  <p:clrMapOvr>
+    <a:masterClrMapping/>
+  </p:clrMapOvr>
+</p:notes>
+</file>
+
+<file path=ppt/notesSlides/notesSlide2.xml><?xml version="1.0" encoding="utf-8"?>
+<p:notes xmlns:a="http://schemas.openxmlformats.org/drawingml/2006/main" xmlns:p="http://schemas.openxmlformats.org/presentationml/2006/main" xmlns:r="http://schemas.openxmlformats.org/officeDocument/2006/relationships">
+  <p:cSld>
+    <p:spTree>
+      <p:nvGrpSpPr>
+        <p:cNvPr id="1" name=""/>
+        <p:cNvGrpSpPr/>
+        <p:nvPr/>
+      </p:nvGrpSpPr>
+      <p:grpSpPr>
+        <a:xfrm>
+          <a:off x="0" y="0"/>
+          <a:ext cx="0" cy="0"/>
+          <a:chOff x="0" y="0"/>
+          <a:chExt cx="0" cy="0"/>
+        </a:xfrm>
+      </p:grpSpPr>
+      <p:sp>
+        <p:nvSpPr>
+          <p:cNvPr id="2" name="Slide Image Placeholder 1"/>
+          <p:cNvSpPr>
+            <a:spLocks noGrp="1"/>
+          </p:cNvSpPr>
+          <p:nvPr>
+            <p:ph type="sldImg" idx="2"/>
+          </p:nvPr>
+        </p:nvSpPr>
+        <p:spPr/>
+      </p:sp>
+      <p:sp>
+        <p:nvSpPr>
+          <p:cNvPr id="3" name="Notes Placeholder 2"/>
+          <p:cNvSpPr>
+            <a:spLocks noGrp="1"/>
+          </p:cNvSpPr>
+          <p:nvPr>
+            <p:ph type="body" idx="3" sz="quarter"/>
+          </p:nvPr>
+        </p:nvSpPr>
+        <p:spPr/>
+        <p:txBody>
+          <a:bodyPr/>
+          <a:lstStyle/>
+          <a:p>
+            <a:r>
+              <a:t>El problema no es abstracto, es el de Ana. En un bazar el flujo de clientes es impredecible. Si registrar una venta le toma más de unos segundos, ese tiempo compite directamente con atender al cliente que sigue, y casi siempre pierde el registro, no el cliente.</a:t>
+            </a:r>
+          </a:p>
+          <a:p/>
+          <a:p>
+            <a:r>
+              <a:t>Esa fricción no es exclusiva de Ana, se repite en cualquier vendedora que atiende de pie, sin caja registradora, sin tiempo muerto entre un cliente y el siguiente.</a:t>
+            </a:r>
+          </a:p>
+          <a:p/>
+          <a:p>
+            <a:r>
+              <a:t>Por eso Ana limita su propio catálogo, para mantener control mental de lo que tiene. Y eso limita cuánto puede crecer.</a:t>
+            </a:r>
+          </a:p>
+        </p:txBody>
+      </p:sp>
+      <p:sp>
+        <p:nvSpPr>
+          <p:cNvPr id="4" name="Slide Number Placeholder 3"/>
+          <p:cNvSpPr>
+            <a:spLocks noGrp="1"/>
+          </p:cNvSpPr>
+          <p:nvPr>
+            <p:ph type="sldNum" idx="5" sz="quarter"/>
+          </p:nvPr>
+        </p:nvSpPr>
+        <p:spPr/>
+      </p:sp>
+    </p:spTree>
+  </p:cSld>
+  <p:clrMapOvr>
+    <a:masterClrMapping/>
+  </p:clrMapOvr>
+</p:notes>
+</file>
+
+<file path=ppt/notesSlides/notesSlide3.xml><?xml version="1.0" encoding="utf-8"?>
+<p:notes xmlns:a="http://schemas.openxmlformats.org/drawingml/2006/main" xmlns:p="http://schemas.openxmlformats.org/presentationml/2006/main" xmlns:r="http://schemas.openxmlformats.org/officeDocument/2006/relationships">
+  <p:cSld>
+    <p:spTree>
+      <p:nvGrpSpPr>
+        <p:cNvPr id="1" name=""/>
+        <p:cNvGrpSpPr/>
+        <p:nvPr/>
+      </p:nvGrpSpPr>
+      <p:grpSpPr>
+        <a:xfrm>
+          <a:off x="0" y="0"/>
+          <a:ext cx="0" cy="0"/>
+          <a:chOff x="0" y="0"/>
+          <a:chExt cx="0" cy="0"/>
+        </a:xfrm>
+      </p:grpSpPr>
+      <p:sp>
+        <p:nvSpPr>
+          <p:cNvPr id="2" name="Slide Image Placeholder 1"/>
+          <p:cNvSpPr>
+            <a:spLocks noGrp="1"/>
+          </p:cNvSpPr>
+          <p:nvPr>
+            <p:ph type="sldImg" idx="2"/>
+          </p:nvPr>
+        </p:nvSpPr>
+        <p:spPr/>
+      </p:sp>
+      <p:sp>
+        <p:nvSpPr>
+          <p:cNvPr id="3" name="Notes Placeholder 2"/>
+          <p:cNvSpPr>
+            <a:spLocks noGrp="1"/>
+          </p:cNvSpPr>
+          <p:nvPr>
+            <p:ph type="body" idx="3" sz="quarter"/>
+          </p:nvPr>
+        </p:nvSpPr>
+        <p:spPr/>
+        <p:txBody>
+          <a:bodyPr/>
+          <a:lstStyle/>
+          <a:p>
+            <a:r>
+              <a:t>Esto que ven aquí no es un mockup, es el prototipo real, funcionando, probado con Ana en persona. Este es el estado inicial: venta rápida, con las categorías que ella misma usa, playeras y blusas.</a:t>
+            </a:r>
+          </a:p>
+        </p:txBody>
+      </p:sp>
+      <p:sp>
+        <p:nvSpPr>
+          <p:cNvPr id="4" name="Slide Number Placeholder 3"/>
+          <p:cNvSpPr>
+            <a:spLocks noGrp="1"/>
+          </p:cNvSpPr>
+          <p:nvPr>
+            <p:ph type="sldNum" idx="5" sz="quarter"/>
+          </p:nvPr>
+        </p:nvSpPr>
+        <p:spPr/>
+      </p:sp>
+    </p:spTree>
+  </p:cSld>
+  <p:clrMapOvr>
+    <a:masterClrMapping/>
+  </p:clrMapOvr>
+</p:notes>
+</file>
+
+<file path=ppt/notesSlides/notesSlide4.xml><?xml version="1.0" encoding="utf-8"?>
+<p:notes xmlns:a="http://schemas.openxmlformats.org/drawingml/2006/main" xmlns:p="http://schemas.openxmlformats.org/presentationml/2006/main" xmlns:r="http://schemas.openxmlformats.org/officeDocument/2006/relationships">
+  <p:cSld>
+    <p:spTree>
+      <p:nvGrpSpPr>
+        <p:cNvPr id="1" name=""/>
+        <p:cNvGrpSpPr/>
+        <p:nvPr/>
+      </p:nvGrpSpPr>
+      <p:grpSpPr>
+        <a:xfrm>
+          <a:off x="0" y="0"/>
+          <a:ext cx="0" cy="0"/>
+          <a:chOff x="0" y="0"/>
+          <a:chExt cx="0" cy="0"/>
+        </a:xfrm>
+      </p:grpSpPr>
+      <p:sp>
+        <p:nvSpPr>
+          <p:cNvPr id="2" name="Slide Image Placeholder 1"/>
+          <p:cNvSpPr>
+            <a:spLocks noGrp="1"/>
+          </p:cNvSpPr>
+          <p:nvPr>
+            <p:ph type="sldImg" idx="2"/>
+          </p:nvPr>
+        </p:nvSpPr>
+        <p:spPr/>
+      </p:sp>
+      <p:sp>
+        <p:nvSpPr>
+          <p:cNvPr id="3" name="Notes Placeholder 2"/>
+          <p:cNvSpPr>
+            <a:spLocks noGrp="1"/>
+          </p:cNvSpPr>
+          <p:nvPr>
+            <p:ph type="body" idx="3" sz="quarter"/>
+          </p:nvPr>
+        </p:nvSpPr>
+        <p:spPr/>
+        <p:txBody>
+          <a:bodyPr/>
+          <a:lstStyle/>
+          <a:p>
+            <a:r>
+              <a:t>Así se registra una venta. Un toque por producto. El total se arma solo, en el momento exacto de la venta, sin que Ana tenga que hacer cuentas ni pausar para anotar nada.</a:t>
+            </a:r>
+          </a:p>
+        </p:txBody>
+      </p:sp>
+      <p:sp>
+        <p:nvSpPr>
+          <p:cNvPr id="4" name="Slide Number Placeholder 3"/>
+          <p:cNvSpPr>
+            <a:spLocks noGrp="1"/>
+          </p:cNvSpPr>
+          <p:nvPr>
+            <p:ph type="sldNum" idx="5" sz="quarter"/>
+          </p:nvPr>
+        </p:nvSpPr>
+        <p:spPr/>
+      </p:sp>
+    </p:spTree>
+  </p:cSld>
+  <p:clrMapOvr>
+    <a:masterClrMapping/>
+  </p:clrMapOvr>
+</p:notes>
+</file>
+
+<file path=ppt/notesSlides/notesSlide5.xml><?xml version="1.0" encoding="utf-8"?>
+<p:notes xmlns:a="http://schemas.openxmlformats.org/drawingml/2006/main" xmlns:p="http://schemas.openxmlformats.org/presentationml/2006/main" xmlns:r="http://schemas.openxmlformats.org/officeDocument/2006/relationships">
+  <p:cSld>
+    <p:spTree>
+      <p:nvGrpSpPr>
+        <p:cNvPr id="1" name=""/>
+        <p:cNvGrpSpPr/>
+        <p:nvPr/>
+      </p:nvGrpSpPr>
+      <p:grpSpPr>
+        <a:xfrm>
+          <a:off x="0" y="0"/>
+          <a:ext cx="0" cy="0"/>
+          <a:chOff x="0" y="0"/>
+          <a:chExt cx="0" cy="0"/>
+        </a:xfrm>
+      </p:grpSpPr>
+      <p:sp>
+        <p:nvSpPr>
+          <p:cNvPr id="2" name="Slide Image Placeholder 1"/>
+          <p:cNvSpPr>
+            <a:spLocks noGrp="1"/>
+          </p:cNvSpPr>
+          <p:nvPr>
+            <p:ph type="sldImg" idx="2"/>
+          </p:nvPr>
+        </p:nvSpPr>
+        <p:spPr/>
+      </p:sp>
+      <p:sp>
+        <p:nvSpPr>
+          <p:cNvPr id="3" name="Notes Placeholder 2"/>
+          <p:cNvSpPr>
+            <a:spLocks noGrp="1"/>
+          </p:cNvSpPr>
+          <p:nvPr>
+            <p:ph type="body" idx="3" sz="quarter"/>
+          </p:nvPr>
+        </p:nvSpPr>
+        <p:spPr/>
+        <p:txBody>
+          <a:bodyPr/>
+          <a:lstStyle/>
+          <a:p>
+            <a:r>
+              <a:t>Y aquí queda guardada. Recibo digital, venta finalizada, total confirmado. Nunca más se pierde el registro de una venta, aunque llegue el siguiente cliente sin avisar, que es exactamente lo que pasa todo el tiempo en un bazar real.</a:t>
+            </a:r>
+          </a:p>
+        </p:txBody>
+      </p:sp>
+      <p:sp>
+        <p:nvSpPr>
+          <p:cNvPr id="4" name="Slide Number Placeholder 3"/>
+          <p:cNvSpPr>
+            <a:spLocks noGrp="1"/>
+          </p:cNvSpPr>
+          <p:nvPr>
+            <p:ph type="sldNum" idx="5" sz="quarter"/>
+          </p:nvPr>
+        </p:nvSpPr>
+        <p:spPr/>
+      </p:sp>
+    </p:spTree>
+  </p:cSld>
+  <p:clrMapOvr>
+    <a:masterClrMapping/>
+  </p:clrMapOvr>
+</p:notes>
+</file>
+
+<file path=ppt/notesSlides/notesSlide6.xml><?xml version="1.0" encoding="utf-8"?>
+<p:notes xmlns:a="http://schemas.openxmlformats.org/drawingml/2006/main" xmlns:p="http://schemas.openxmlformats.org/presentationml/2006/main" xmlns:r="http://schemas.openxmlformats.org/officeDocument/2006/relationships">
+  <p:cSld>
+    <p:spTree>
+      <p:nvGrpSpPr>
+        <p:cNvPr id="1" name=""/>
+        <p:cNvGrpSpPr/>
+        <p:nvPr/>
+      </p:nvGrpSpPr>
+      <p:grpSpPr>
+        <a:xfrm>
+          <a:off x="0" y="0"/>
+          <a:ext cx="0" cy="0"/>
+          <a:chOff x="0" y="0"/>
+          <a:chExt cx="0" cy="0"/>
+        </a:xfrm>
+      </p:grpSpPr>
+      <p:sp>
+        <p:nvSpPr>
+          <p:cNvPr id="2" name="Slide Image Placeholder 1"/>
+          <p:cNvSpPr>
+            <a:spLocks noGrp="1"/>
+          </p:cNvSpPr>
+          <p:nvPr>
+            <p:ph type="sldImg" idx="2"/>
+          </p:nvPr>
+        </p:nvSpPr>
+        <p:spPr/>
+      </p:sp>
+      <p:sp>
+        <p:nvSpPr>
+          <p:cNvPr id="3" name="Notes Placeholder 2"/>
+          <p:cNvSpPr>
+            <a:spLocks noGrp="1"/>
+          </p:cNvSpPr>
+          <p:nvPr>
+            <p:ph type="body" idx="3" sz="quarter"/>
+          </p:nvPr>
+        </p:nvSpPr>
+        <p:spPr/>
+        <p:txBody>
+          <a:bodyPr/>
+          <a:lstStyle/>
+          <a:p>
+            <a:r>
+              <a:t>Esta es la diapositiva más difícil de todas, y también la más útil.</a:t>
+            </a:r>
+          </a:p>
+          <a:p/>
+          <a:p>
+            <a:r>
+              <a:t>Corrimos una campaña real de Meta del 17 al 20 de agosto, tres días, 569 pesos gastados, 731 visitas a la página a 78 centavos cada una. El alcance funciona, y es barato.</a:t>
+            </a:r>
+          </a:p>
+          <a:p/>
+          <a:p>
+            <a:r>
+              <a:t>Pero Vercel confirmó algo distinto: 583 visitantes reales llegaron al sitio, y solo 2 de ellos dispararon algún evento del recorrido del demo, registro, verificación, cuestionario. Eso es 0.34 por ciento.</a:t>
+            </a:r>
+          </a:p>
+          <a:p/>
+          <a:p>
+            <a:r>
+              <a:t>No lo descubrimos el primer día. La instrumentación para medir esto se terminó de construir a mitad de la campaña. El alcance no es el problema. La adopción real, todavía no la tenemos, y la causa exacta todavía no está confirmada.</a:t>
+            </a:r>
+          </a:p>
+        </p:txBody>
+      </p:sp>
+      <p:sp>
+        <p:nvSpPr>
+          <p:cNvPr id="4" name="Slide Number Placeholder 3"/>
+          <p:cNvSpPr>
+            <a:spLocks noGrp="1"/>
+          </p:cNvSpPr>
+          <p:nvPr>
+            <p:ph type="sldNum" idx="5" sz="quarter"/>
+          </p:nvPr>
+        </p:nvSpPr>
+        <p:spPr/>
+      </p:sp>
+    </p:spTree>
+  </p:cSld>
+  <p:clrMapOvr>
+    <a:masterClrMapping/>
+  </p:clrMapOvr>
+</p:notes>
+</file>
+
+<file path=ppt/notesSlides/notesSlide7.xml><?xml version="1.0" encoding="utf-8"?>
+<p:notes xmlns:a="http://schemas.openxmlformats.org/drawingml/2006/main" xmlns:p="http://schemas.openxmlformats.org/presentationml/2006/main" xmlns:r="http://schemas.openxmlformats.org/officeDocument/2006/relationships">
+  <p:cSld>
+    <p:spTree>
+      <p:nvGrpSpPr>
+        <p:cNvPr id="1" name=""/>
+        <p:cNvGrpSpPr/>
+        <p:nvPr/>
+      </p:nvGrpSpPr>
+      <p:grpSpPr>
+        <a:xfrm>
+          <a:off x="0" y="0"/>
+          <a:ext cx="0" cy="0"/>
+          <a:chOff x="0" y="0"/>
+          <a:chExt cx="0" cy="0"/>
+        </a:xfrm>
+      </p:grpSpPr>
+      <p:sp>
+        <p:nvSpPr>
+          <p:cNvPr id="2" name="Slide Image Placeholder 1"/>
+          <p:cNvSpPr>
+            <a:spLocks noGrp="1"/>
+          </p:cNvSpPr>
+          <p:nvPr>
+            <p:ph type="sldImg" idx="2"/>
+          </p:nvPr>
+        </p:nvSpPr>
+        <p:spPr/>
+      </p:sp>
+      <p:sp>
+        <p:nvSpPr>
+          <p:cNvPr id="3" name="Notes Placeholder 2"/>
+          <p:cNvSpPr>
+            <a:spLocks noGrp="1"/>
+          </p:cNvSpPr>
+          <p:nvPr>
+            <p:ph type="body" idx="3" sz="quarter"/>
+          </p:nvPr>
+        </p:nvSpPr>
+        <p:spPr/>
+        <p:txBody>
+          <a:bodyPr/>
+          <a:lstStyle/>
+          <a:p>
+            <a:r>
+              <a:t>Nahui no la construyo yo sola escribiendo código. La construye un equipo de agentes de inteligencia artificial especializados, no una sola IA generalista.</a:t>
+            </a:r>
+          </a:p>
+          <a:p/>
+          <a:p>
+            <a:r>
+              <a:t>Cada uno tiene una sola función y su propio límite de autoridad. Architect solo lee y opina sobre el modelo del negocio. Ux-designer y ui-designer diseñan y construyen. Ux-critic y reviewer revisan antes de que algo se dé por bueno.</a:t>
+            </a:r>
+          </a:p>
+          <a:p/>
+          <a:p>
+            <a:r>
+              <a:t>Y merchant-user-tester, el más importante de todos para mí, no tiene acceso a ningún archivo del proyecto, solo puede navegar el producto como lo haría una vendedora real que nunca lo ha visto. Main coordina y persiste todo esto, pero nunca decide en lugar de los demás.</a:t>
+            </a:r>
+          </a:p>
+        </p:txBody>
+      </p:sp>
+      <p:sp>
+        <p:nvSpPr>
+          <p:cNvPr id="4" name="Slide Number Placeholder 3"/>
+          <p:cNvSpPr>
+            <a:spLocks noGrp="1"/>
+          </p:cNvSpPr>
+          <p:nvPr>
+            <p:ph type="sldNum" idx="5" sz="quarter"/>
+          </p:nvPr>
+        </p:nvSpPr>
+        <p:spPr/>
+      </p:sp>
+    </p:spTree>
+  </p:cSld>
+  <p:clrMapOvr>
+    <a:masterClrMapping/>
+  </p:clrMapOvr>
+</p:notes>
+</file>
+
+<file path=ppt/notesSlides/notesSlide8.xml><?xml version="1.0" encoding="utf-8"?>
+<p:notes xmlns:a="http://schemas.openxmlformats.org/drawingml/2006/main" xmlns:p="http://schemas.openxmlformats.org/presentationml/2006/main" xmlns:r="http://schemas.openxmlformats.org/officeDocument/2006/relationships">
+  <p:cSld>
+    <p:spTree>
+      <p:nvGrpSpPr>
+        <p:cNvPr id="1" name=""/>
+        <p:cNvGrpSpPr/>
+        <p:nvPr/>
+      </p:nvGrpSpPr>
+      <p:grpSpPr>
+        <a:xfrm>
+          <a:off x="0" y="0"/>
+          <a:ext cx="0" cy="0"/>
+          <a:chOff x="0" y="0"/>
+          <a:chExt cx="0" cy="0"/>
+        </a:xfrm>
+      </p:grpSpPr>
+      <p:sp>
+        <p:nvSpPr>
+          <p:cNvPr id="2" name="Slide Image Placeholder 1"/>
+          <p:cNvSpPr>
+            <a:spLocks noGrp="1"/>
+          </p:cNvSpPr>
+          <p:nvPr>
+            <p:ph type="sldImg" idx="2"/>
+          </p:nvPr>
+        </p:nvSpPr>
+        <p:spPr/>
+      </p:sp>
+      <p:sp>
+        <p:nvSpPr>
+          <p:cNvPr id="3" name="Notes Placeholder 2"/>
+          <p:cNvSpPr>
+            <a:spLocks noGrp="1"/>
+          </p:cNvSpPr>
+          <p:nvPr>
+            <p:ph type="body" idx="3" sz="quarter"/>
+          </p:nvPr>
+        </p:nvSpPr>
+        <p:spPr/>
+        <p:txBody>
+          <a:bodyPr/>
+          <a:lstStyle/>
+          <a:p>
+            <a:r>
+              <a:t>Nada en Nahui se da por cerrado sin comprobarlo contra el producto real. Diseñamos, revisamos, construimos, y ahí es donde entra lo que de verdad importa: el hallazgo real. No una suposición, un hallazgo real, de una prueba con Ana o de una campaña de verdad.</a:t>
+            </a:r>
+          </a:p>
+          <a:p/>
+          <a:p>
+            <a:r>
+              <a:t>Ese hallazgo dispara una corrección, y la corrección se vuelve a validar contra el producto real antes de darse por cerrada. Nunca se confía sin comprobar.</a:t>
+            </a:r>
+          </a:p>
+        </p:txBody>
+      </p:sp>
+      <p:sp>
+        <p:nvSpPr>
+          <p:cNvPr id="4" name="Slide Number Placeholder 3"/>
+          <p:cNvSpPr>
+            <a:spLocks noGrp="1"/>
+          </p:cNvSpPr>
+          <p:nvPr>
+            <p:ph type="sldNum" idx="5" sz="quarter"/>
+          </p:nvPr>
+        </p:nvSpPr>
+        <p:spPr/>
+      </p:sp>
+    </p:spTree>
+  </p:cSld>
+  <p:clrMapOvr>
+    <a:masterClrMapping/>
+  </p:clrMapOvr>
+</p:notes>
+</file>
+
+<file path=ppt/notesSlides/notesSlide9.xml><?xml version="1.0" encoding="utf-8"?>
+<p:notes xmlns:a="http://schemas.openxmlformats.org/drawingml/2006/main" xmlns:p="http://schemas.openxmlformats.org/presentationml/2006/main" xmlns:r="http://schemas.openxmlformats.org/officeDocument/2006/relationships">
+  <p:cSld>
+    <p:spTree>
+      <p:nvGrpSpPr>
+        <p:cNvPr id="1" name=""/>
+        <p:cNvGrpSpPr/>
+        <p:nvPr/>
+      </p:nvGrpSpPr>
+      <p:grpSpPr>
+        <a:xfrm>
+          <a:off x="0" y="0"/>
+          <a:ext cx="0" cy="0"/>
+          <a:chOff x="0" y="0"/>
+          <a:chExt cx="0" cy="0"/>
+        </a:xfrm>
+      </p:grpSpPr>
+      <p:sp>
+        <p:nvSpPr>
+          <p:cNvPr id="2" name="Slide Image Placeholder 1"/>
+          <p:cNvSpPr>
+            <a:spLocks noGrp="1"/>
+          </p:cNvSpPr>
+          <p:nvPr>
+            <p:ph type="sldImg" idx="2"/>
+          </p:nvPr>
+        </p:nvSpPr>
+        <p:spPr/>
+      </p:sp>
+      <p:sp>
+        <p:nvSpPr>
+          <p:cNvPr id="3" name="Notes Placeholder 2"/>
+          <p:cNvSpPr>
+            <a:spLocks noGrp="1"/>
+          </p:cNvSpPr>
+          <p:nvPr>
+            <p:ph type="body" idx="3" sz="quarter"/>
+          </p:nvPr>
+        </p:nvSpPr>
+        <p:spPr/>
+        <p:txBody>
+          <a:bodyPr/>
+          <a:lstStyle/>
+          <a:p>
+            <a:r>
+              <a:t>Esta línea de tiempo no es una lista de entregables. Cada punto existe porque resolvió un problema real que apareció en el camino, no porque estuviera planeado desde el inicio.</a:t>
+            </a:r>
+          </a:p>
+          <a:p/>
+          <a:p>
+            <a:r>
+              <a:t>Y aquí quiero ser clara sobre algo: no soy experta en sistemas agénticos de inteligencia artificial, no sé optimizar el consumo de tokens con precisión técnica. Varias decisiones técnicas del camino tampoco las tomé sola, cambié de herramienta de diseño por recomendación directa de la maestra, y usar un equipo de agentes especializados en vez de una sola IA generalista fue algo que ella mencionó como mejor práctica. Entender cómo funciona realmente de fondo lo aprendí después, trabajando con mi propio equipo.</a:t>
+            </a:r>
+          </a:p>
+        </p:txBody>
+      </p:sp>
+      <p:sp>
+        <p:nvSpPr>
+          <p:cNvPr id="4" name="Slide Number Placeholder 3"/>
+          <p:cNvSpPr>
+            <a:spLocks noGrp="1"/>
+          </p:cNvSpPr>
+          <p:nvPr>
+            <p:ph type="sldNum" idx="5" sz="quarter"/>
+          </p:nvPr>
+        </p:nvSpPr>
+        <p:spPr/>
+      </p:sp>
+    </p:spTree>
+  </p:cSld>
+  <p:clrMapOvr>
+    <a:masterClrMapping/>
+  </p:clrMapOvr>
+</p:notes>
 </file>
 
 <file path=ppt/slideLayouts/slideLayout1.xml><?xml version="1.0" encoding="utf-8"?>
@@ -5011,4 +6133,324 @@
   </a:objectDefaults>
   <a:extraClrSchemeLst/>
 </a:theme>
+</file>
+
+<file path=ppt/theme/theme2.xml><?xml version="1.0" encoding="utf-8"?>
+<a:theme xmlns:a="http://schemas.openxmlformats.org/drawingml/2006/main" name="Office Theme">
+  <a:themeElements>
+    <a:clrScheme name="Office">
+      <a:dk1>
+        <a:sysClr val="windowText" lastClr="000000"/>
+      </a:dk1>
+      <a:lt1>
+        <a:sysClr val="window" lastClr="FFFFFF"/>
+      </a:lt1>
+      <a:dk2>
+        <a:srgbClr val="1F497D"/>
+      </a:dk2>
+      <a:lt2>
+        <a:srgbClr val="EEECE1"/>
+      </a:lt2>
+      <a:accent1>
+        <a:srgbClr val="4F81BD"/>
+      </a:accent1>
+      <a:accent2>
+        <a:srgbClr val="C0504D"/>
+      </a:accent2>
+      <a:accent3>
+        <a:srgbClr val="9BBB59"/>
+      </a:accent3>
+      <a:accent4>
+        <a:srgbClr val="8064A2"/>
+      </a:accent4>
+      <a:accent5>
+        <a:srgbClr val="4BACC6"/>
+      </a:accent5>
+      <a:accent6>
+        <a:srgbClr val="F79646"/>
+      </a:accent6>
+      <a:hlink>
+        <a:srgbClr val="0000FF"/>
+      </a:hlink>
+      <a:folHlink>
+        <a:srgbClr val="800080"/>
+      </a:folHlink>
+    </a:clrScheme>
+    <a:fontScheme name="Office">
+      <a:majorFont>
+        <a:latin typeface="Calibri"/>
+        <a:ea typeface=""/>
+        <a:cs typeface=""/>
+        <a:font script="Jpan" typeface="ＭＳ Ｐゴシック"/>
+        <a:font script="Hang" typeface="맑은 고딕"/>
+        <a:font script="Hans" typeface="宋体"/>
+        <a:font script="Hant" typeface="新細明體"/>
+        <a:font script="Arab" typeface="Times New Roman"/>
+        <a:font script="Hebr" typeface="Times New Roman"/>
+        <a:font script="Thai" typeface="Angsana New"/>
+        <a:font script="Ethi" typeface="Nyala"/>
+        <a:font script="Beng" typeface="Vrinda"/>
+        <a:font script="Gujr" typeface="Shruti"/>
+        <a:font script="Khmr" typeface="MoolBoran"/>
+        <a:font script="Knda" typeface="Tunga"/>
+        <a:font script="Guru" typeface="Raavi"/>
+        <a:font script="Cans" typeface="Euphemia"/>
+        <a:font script="Cher" typeface="Plantagenet Cherokee"/>
+        <a:font script="Yiii" typeface="Microsoft Yi Baiti"/>
+        <a:font script="Tibt" typeface="Microsoft Himalaya"/>
+        <a:font script="Thaa" typeface="MV Boli"/>
+        <a:font script="Deva" typeface="Mangal"/>
+        <a:font script="Telu" typeface="Gautami"/>
+        <a:font script="Taml" typeface="Latha"/>
+        <a:font script="Syrc" typeface="Estrangelo Edessa"/>
+        <a:font script="Orya" typeface="Kalinga"/>
+        <a:font script="Mlym" typeface="Kartika"/>
+        <a:font script="Laoo" typeface="DokChampa"/>
+        <a:font script="Sinh" typeface="Iskoola Pota"/>
+        <a:font script="Mong" typeface="Mongolian Baiti"/>
+        <a:font script="Viet" typeface="Times New Roman"/>
+        <a:font script="Uigh" typeface="Microsoft Uighur"/>
+        <a:font script="Geor" typeface="Sylfaen"/>
+      </a:majorFont>
+      <a:minorFont>
+        <a:latin typeface="Calibri"/>
+        <a:ea typeface=""/>
+        <a:cs typeface=""/>
+        <a:font script="Jpan" typeface="ＭＳ Ｐゴシック"/>
+        <a:font script="Hang" typeface="맑은 고딕"/>
+        <a:font script="Hans" typeface="宋体"/>
+        <a:font script="Hant" typeface="新細明體"/>
+        <a:font script="Arab" typeface="Arial"/>
+        <a:font script="Hebr" typeface="Arial"/>
+        <a:font script="Thai" typeface="Cordia New"/>
+        <a:font script="Ethi" typeface="Nyala"/>
+        <a:font script="Beng" typeface="Vrinda"/>
+        <a:font script="Gujr" typeface="Shruti"/>
+        <a:font script="Khmr" typeface="DaunPenh"/>
+        <a:font script="Knda" typeface="Tunga"/>
+        <a:font script="Guru" typeface="Raavi"/>
+        <a:font script="Cans" typeface="Euphemia"/>
+        <a:font script="Cher" typeface="Plantagenet Cherokee"/>
+        <a:font script="Yiii" typeface="Microsoft Yi Baiti"/>
+        <a:font script="Tibt" typeface="Microsoft Himalaya"/>
+        <a:font script="Thaa" typeface="MV Boli"/>
+        <a:font script="Deva" typeface="Mangal"/>
+        <a:font script="Telu" typeface="Gautami"/>
+        <a:font script="Taml" typeface="Latha"/>
+        <a:font script="Syrc" typeface="Estrangelo Edessa"/>
+        <a:font script="Orya" typeface="Kalinga"/>
+        <a:font script="Mlym" typeface="Kartika"/>
+        <a:font script="Laoo" typeface="DokChampa"/>
+        <a:font script="Sinh" typeface="Iskoola Pota"/>
+        <a:font script="Mong" typeface="Mongolian Baiti"/>
+        <a:font script="Viet" typeface="Arial"/>
+        <a:font script="Uigh" typeface="Microsoft Uighur"/>
+        <a:font script="Geor" typeface="Sylfaen"/>
+      </a:minorFont>
+    </a:fontScheme>
+    <a:fmtScheme name="Office">
+      <a:fillStyleLst>
+        <a:solidFill>
+          <a:schemeClr val="phClr"/>
+        </a:solidFill>
+        <a:gradFill rotWithShape="1">
+          <a:gsLst>
+            <a:gs pos="0">
+              <a:schemeClr val="phClr">
+                <a:tint val="50000"/>
+                <a:satMod val="300000"/>
+              </a:schemeClr>
+            </a:gs>
+            <a:gs pos="35000">
+              <a:schemeClr val="phClr">
+                <a:tint val="37000"/>
+                <a:satMod val="300000"/>
+              </a:schemeClr>
+            </a:gs>
+            <a:gs pos="100000">
+              <a:schemeClr val="phClr">
+                <a:tint val="15000"/>
+                <a:satMod val="350000"/>
+              </a:schemeClr>
+            </a:gs>
+          </a:gsLst>
+          <a:lin ang="16200000" scaled="1"/>
+        </a:gradFill>
+        <a:gradFill rotWithShape="1">
+          <a:gsLst>
+            <a:gs pos="0">
+              <a:schemeClr val="phClr">
+                <a:tint val="100000"/>
+                <a:shade val="100000"/>
+                <a:satMod val="130000"/>
+              </a:schemeClr>
+            </a:gs>
+            <a:gs pos="100000">
+              <a:schemeClr val="phClr">
+                <a:tint val="50000"/>
+                <a:shade val="100000"/>
+                <a:satMod val="350000"/>
+              </a:schemeClr>
+            </a:gs>
+          </a:gsLst>
+          <a:lin ang="16200000" scaled="0"/>
+        </a:gradFill>
+      </a:fillStyleLst>
+      <a:lnStyleLst>
+        <a:ln w="9525" cap="flat" cmpd="sng" algn="ctr">
+          <a:solidFill>
+            <a:schemeClr val="phClr">
+              <a:shade val="95000"/>
+              <a:satMod val="105000"/>
+            </a:schemeClr>
+          </a:solidFill>
+          <a:prstDash val="solid"/>
+        </a:ln>
+        <a:ln w="25400" cap="flat" cmpd="sng" algn="ctr">
+          <a:solidFill>
+            <a:schemeClr val="phClr"/>
+          </a:solidFill>
+          <a:prstDash val="solid"/>
+        </a:ln>
+        <a:ln w="38100" cap="flat" cmpd="sng" algn="ctr">
+          <a:solidFill>
+            <a:schemeClr val="phClr"/>
+          </a:solidFill>
+          <a:prstDash val="solid"/>
+        </a:ln>
+      </a:lnStyleLst>
+      <a:effectStyleLst>
+        <a:effectStyle>
+          <a:effectLst>
+            <a:outerShdw blurRad="40000" dist="20000" dir="5400000" rotWithShape="0">
+              <a:srgbClr val="000000">
+                <a:alpha val="38000"/>
+              </a:srgbClr>
+            </a:outerShdw>
+          </a:effectLst>
+        </a:effectStyle>
+        <a:effectStyle>
+          <a:effectLst>
+            <a:outerShdw blurRad="40000" dist="23000" dir="5400000" rotWithShape="0">
+              <a:srgbClr val="000000">
+                <a:alpha val="35000"/>
+              </a:srgbClr>
+            </a:outerShdw>
+          </a:effectLst>
+        </a:effectStyle>
+        <a:effectStyle>
+          <a:effectLst>
+            <a:outerShdw blurRad="40000" dist="23000" dir="5400000" rotWithShape="0">
+              <a:srgbClr val="000000">
+                <a:alpha val="35000"/>
+              </a:srgbClr>
+            </a:outerShdw>
+          </a:effectLst>
+          <a:scene3d>
+            <a:camera prst="orthographicFront">
+              <a:rot lat="0" lon="0" rev="0"/>
+            </a:camera>
+            <a:lightRig rig="threePt" dir="t">
+              <a:rot lat="0" lon="0" rev="1200000"/>
+            </a:lightRig>
+          </a:scene3d>
+          <a:sp3d>
+            <a:bevelT w="63500" h="25400"/>
+          </a:sp3d>
+        </a:effectStyle>
+      </a:effectStyleLst>
+      <a:bgFillStyleLst>
+        <a:solidFill>
+          <a:schemeClr val="phClr"/>
+        </a:solidFill>
+        <a:gradFill rotWithShape="1">
+          <a:gsLst>
+            <a:gs pos="0">
+              <a:schemeClr val="phClr">
+                <a:tint val="40000"/>
+                <a:satMod val="350000"/>
+              </a:schemeClr>
+            </a:gs>
+            <a:gs pos="40000">
+              <a:schemeClr val="phClr">
+                <a:tint val="45000"/>
+                <a:shade val="99000"/>
+                <a:satMod val="350000"/>
+              </a:schemeClr>
+            </a:gs>
+            <a:gs pos="100000">
+              <a:schemeClr val="phClr">
+                <a:shade val="20000"/>
+                <a:satMod val="255000"/>
+              </a:schemeClr>
+            </a:gs>
+          </a:gsLst>
+          <a:path path="circle">
+            <a:fillToRect l="50000" t="-80000" r="50000" b="180000"/>
+          </a:path>
+        </a:gradFill>
+        <a:gradFill rotWithShape="1">
+          <a:gsLst>
+            <a:gs pos="0">
+              <a:schemeClr val="phClr">
+                <a:tint val="80000"/>
+                <a:satMod val="300000"/>
+              </a:schemeClr>
+            </a:gs>
+            <a:gs pos="100000">
+              <a:schemeClr val="phClr">
+                <a:shade val="30000"/>
+                <a:satMod val="200000"/>
+              </a:schemeClr>
+            </a:gs>
+          </a:gsLst>
+          <a:path path="circle">
+            <a:fillToRect l="50000" t="50000" r="50000" b="50000"/>
+          </a:path>
+        </a:gradFill>
+      </a:bgFillStyleLst>
+    </a:fmtScheme>
+  </a:themeElements>
+  <a:objectDefaults>
+    <a:spDef>
+      <a:spPr/>
+      <a:bodyPr/>
+      <a:lstStyle/>
+      <a:style>
+        <a:lnRef idx="1">
+          <a:schemeClr val="accent1"/>
+        </a:lnRef>
+        <a:fillRef idx="3">
+          <a:schemeClr val="accent1"/>
+        </a:fillRef>
+        <a:effectRef idx="2">
+          <a:schemeClr val="accent1"/>
+        </a:effectRef>
+        <a:fontRef idx="minor">
+          <a:schemeClr val="lt1"/>
+        </a:fontRef>
+      </a:style>
+    </a:spDef>
+    <a:lnDef>
+      <a:spPr/>
+      <a:bodyPr/>
+      <a:lstStyle/>
+      <a:style>
+        <a:lnRef idx="2">
+          <a:schemeClr val="accent1"/>
+        </a:lnRef>
+        <a:fillRef idx="0">
+          <a:schemeClr val="accent1"/>
+        </a:fillRef>
+        <a:effectRef idx="1">
+          <a:schemeClr val="accent1"/>
+        </a:effectRef>
+        <a:fontRef idx="minor">
+          <a:schemeClr val="tx1"/>
+        </a:fontRef>
+      </a:style>
+    </a:lnDef>
+  </a:objectDefaults>
+  <a:extraClrSchemeLst/>
+</a:theme>
 </file>
</xml_diff>

<commit_message>
docs(demo-day): persist manual edits to the original pitch deck
</commit_message>
<xml_diff>
--- a/evidence/2026-08-22-demo-day/Nahui - Pitch Demo Day.pptx
+++ b/evidence/2026-08-22-demo-day/Nahui - Pitch Demo Day.pptx
@@ -4,19 +4,22 @@
   <p:sldMasterIdLst>
     <p:sldMasterId id="2147483648" r:id="rId1"/>
   </p:sldMasterIdLst>
+  <p:notesMasterIdLst>
+    <p:notesMasterId r:id="rId12"/>
+  </p:notesMasterIdLst>
   <p:sldIdLst>
-    <p:sldId id="256" r:id="rId7"/>
-    <p:sldId id="257" r:id="rId8"/>
-    <p:sldId id="258" r:id="rId9"/>
-    <p:sldId id="259" r:id="rId10"/>
-    <p:sldId id="260" r:id="rId11"/>
-    <p:sldId id="261" r:id="rId12"/>
-    <p:sldId id="262" r:id="rId13"/>
-    <p:sldId id="263" r:id="rId14"/>
-    <p:sldId id="264" r:id="rId15"/>
-    <p:sldId id="265" r:id="rId16"/>
+    <p:sldId id="256" r:id="rId2"/>
+    <p:sldId id="257" r:id="rId3"/>
+    <p:sldId id="258" r:id="rId4"/>
+    <p:sldId id="259" r:id="rId5"/>
+    <p:sldId id="260" r:id="rId6"/>
+    <p:sldId id="261" r:id="rId7"/>
+    <p:sldId id="262" r:id="rId8"/>
+    <p:sldId id="263" r:id="rId9"/>
+    <p:sldId id="264" r:id="rId10"/>
+    <p:sldId id="265" r:id="rId11"/>
   </p:sldIdLst>
-  <p:sldSz cx="12191695" cy="6858000" type="screen4x3"/>
+  <p:sldSz cx="12192000" cy="6858000"/>
   <p:notesSz cx="6858000" cy="9144000"/>
   <p:defaultTextStyle>
     <a:defPPr>
@@ -113,11 +116,27 @@
       </a:defRPr>
     </a:lvl9pPr>
   </p:defaultTextStyle>
+  <p:extLst>
+    <p:ext uri="{EFAFB233-063F-42B5-8137-9DF3F51BA10A}">
+      <p15:sldGuideLst xmlns:p15="http://schemas.microsoft.com/office/powerpoint/2012/main">
+        <p15:guide id="1" orient="horz" pos="2160">
+          <p15:clr>
+            <a:srgbClr val="A4A3A4"/>
+          </p15:clr>
+        </p15:guide>
+        <p15:guide id="2" pos="2880">
+          <p15:clr>
+            <a:srgbClr val="A4A3A4"/>
+          </p15:clr>
+        </p15:guide>
+      </p15:sldGuideLst>
+    </p:ext>
+  </p:extLst>
 </p:presentation>
 </file>
 
 <file path=ppt/notesMasters/notesMaster1.xml><?xml version="1.0" encoding="utf-8"?>
-<p:notesMaster xmlns:a="http://schemas.openxmlformats.org/drawingml/2006/main" xmlns:p="http://schemas.openxmlformats.org/presentationml/2006/main" xmlns:r="http://schemas.openxmlformats.org/officeDocument/2006/relationships">
+<p:notesMaster xmlns:a="http://schemas.openxmlformats.org/drawingml/2006/main" xmlns:r="http://schemas.openxmlformats.org/officeDocument/2006/relationships" xmlns:p="http://schemas.openxmlformats.org/presentationml/2006/main">
   <p:cSld>
     <p:bg>
       <p:bgRef idx="1001">
@@ -138,241 +157,16 @@
           <a:chExt cx="0" cy="0"/>
         </a:xfrm>
       </p:grpSpPr>
-      <p:sp>
-        <p:nvSpPr>
-          <p:cNvPr id="2" name="Header Placeholder 1"/>
-          <p:cNvSpPr>
-            <a:spLocks noGrp="1"/>
-          </p:cNvSpPr>
-          <p:nvPr>
-            <p:ph type="hdr" sz="quarter"/>
-          </p:nvPr>
-        </p:nvSpPr>
-        <p:spPr>
-          <a:xfrm>
-            <a:off x="0" y="0"/>
-            <a:ext cx="2971800" cy="457200"/>
-          </a:xfrm>
-          <a:prstGeom prst="rect">
-            <a:avLst/>
-          </a:prstGeom>
-        </p:spPr>
-        <p:txBody>
-          <a:bodyPr vert="horz" lIns="91440" tIns="45720" rIns="91440" bIns="45720" rtlCol="0"/>
-          <a:lstStyle>
-            <a:lvl1pPr algn="l">
-              <a:defRPr sz="1200"/>
-            </a:lvl1pPr>
-          </a:lstStyle>
-          <a:p>
-            <a:endParaRPr lang="en-US"/>
-          </a:p>
-        </p:txBody>
-      </p:sp>
-      <p:sp>
-        <p:nvSpPr>
-          <p:cNvPr id="3" name="Date Placeholder 2"/>
-          <p:cNvSpPr>
-            <a:spLocks noGrp="1"/>
-          </p:cNvSpPr>
-          <p:nvPr>
-            <p:ph type="dt" idx="1"/>
-          </p:nvPr>
-        </p:nvSpPr>
-        <p:spPr>
-          <a:xfrm>
-            <a:off x="3884613" y="0"/>
-            <a:ext cx="2971800" cy="457200"/>
-          </a:xfrm>
-          <a:prstGeom prst="rect">
-            <a:avLst/>
-          </a:prstGeom>
-        </p:spPr>
-        <p:txBody>
-          <a:bodyPr vert="horz" lIns="91440" tIns="45720" rIns="91440" bIns="45720" rtlCol="0"/>
-          <a:lstStyle>
-            <a:lvl1pPr algn="r">
-              <a:defRPr sz="1200"/>
-            </a:lvl1pPr>
-          </a:lstStyle>
-          <a:p>
-            <a:fld id="{0F89C1C7-3DCD-1040-A9CF-14679D8B5DDD}" type="datetimeFigureOut">
-              <a:rPr lang="en-US" smtClean="0"/>
-              <a:t>10/17/16</a:t>
-            </a:fld>
-            <a:endParaRPr lang="en-US"/>
-          </a:p>
-        </p:txBody>
-      </p:sp>
-      <p:sp>
-        <p:nvSpPr>
-          <p:cNvPr id="4" name="Slide Image Placeholder 3"/>
-          <p:cNvSpPr>
-            <a:spLocks noGrp="1" noRot="1" noChangeAspect="1"/>
-          </p:cNvSpPr>
-          <p:nvPr>
-            <p:ph type="sldImg" idx="2"/>
-          </p:nvPr>
-        </p:nvSpPr>
-        <p:spPr>
-          <a:xfrm>
-            <a:off x="1143000" y="685800"/>
-            <a:ext cx="4572000" cy="3429000"/>
-          </a:xfrm>
-          <a:prstGeom prst="rect">
-            <a:avLst/>
-          </a:prstGeom>
-          <a:noFill/>
-          <a:ln w="12700">
-            <a:solidFill>
-              <a:prstClr val="black"/>
-            </a:solidFill>
-          </a:ln>
-        </p:spPr>
-        <p:txBody>
-          <a:bodyPr vert="horz" lIns="91440" tIns="45720" rIns="91440" bIns="45720" rtlCol="0" anchor="ctr"/>
-          <a:lstStyle/>
-          <a:p>
-            <a:endParaRPr lang="en-US"/>
-          </a:p>
-        </p:txBody>
-      </p:sp>
-      <p:sp>
-        <p:nvSpPr>
-          <p:cNvPr id="5" name="Notes Placeholder 4"/>
-          <p:cNvSpPr>
-            <a:spLocks noGrp="1"/>
-          </p:cNvSpPr>
-          <p:nvPr>
-            <p:ph type="body" sz="quarter" idx="3"/>
-          </p:nvPr>
-        </p:nvSpPr>
-        <p:spPr>
-          <a:xfrm>
-            <a:off x="685800" y="4343400"/>
-            <a:ext cx="5486400" cy="4114800"/>
-          </a:xfrm>
-          <a:prstGeom prst="rect">
-            <a:avLst/>
-          </a:prstGeom>
-        </p:spPr>
-        <p:txBody>
-          <a:bodyPr vert="horz" lIns="91440" tIns="45720" rIns="91440" bIns="45720" rtlCol="0"/>
-          <a:lstStyle/>
-          <a:p>
-            <a:pPr lvl="0"/>
-            <a:r>
-              <a:rPr lang="en-US" smtClean="0"/>
-              <a:t>Click to edit Master text styles</a:t>
-            </a:r>
-          </a:p>
-          <a:p>
-            <a:pPr lvl="1"/>
-            <a:r>
-              <a:rPr lang="en-US" smtClean="0"/>
-              <a:t>Second level</a:t>
-            </a:r>
-          </a:p>
-          <a:p>
-            <a:pPr lvl="2"/>
-            <a:r>
-              <a:rPr lang="en-US" smtClean="0"/>
-              <a:t>Third level</a:t>
-            </a:r>
-          </a:p>
-          <a:p>
-            <a:pPr lvl="3"/>
-            <a:r>
-              <a:rPr lang="en-US" smtClean="0"/>
-              <a:t>Fourth level</a:t>
-            </a:r>
-          </a:p>
-          <a:p>
-            <a:pPr lvl="4"/>
-            <a:r>
-              <a:rPr lang="en-US" smtClean="0"/>
-              <a:t>Fifth level</a:t>
-            </a:r>
-            <a:endParaRPr lang="en-US"/>
-          </a:p>
-        </p:txBody>
-      </p:sp>
-      <p:sp>
-        <p:nvSpPr>
-          <p:cNvPr id="6" name="Footer Placeholder 5"/>
-          <p:cNvSpPr>
-            <a:spLocks noGrp="1"/>
-          </p:cNvSpPr>
-          <p:nvPr>
-            <p:ph type="ftr" sz="quarter" idx="4"/>
-          </p:nvPr>
-        </p:nvSpPr>
-        <p:spPr>
-          <a:xfrm>
-            <a:off x="0" y="8685213"/>
-            <a:ext cx="2971800" cy="457200"/>
-          </a:xfrm>
-          <a:prstGeom prst="rect">
-            <a:avLst/>
-          </a:prstGeom>
-        </p:spPr>
-        <p:txBody>
-          <a:bodyPr vert="horz" lIns="91440" tIns="45720" rIns="91440" bIns="45720" rtlCol="0" anchor="b"/>
-          <a:lstStyle>
-            <a:lvl1pPr algn="l">
-              <a:defRPr sz="1200"/>
-            </a:lvl1pPr>
-          </a:lstStyle>
-          <a:p>
-            <a:endParaRPr lang="en-US"/>
-          </a:p>
-        </p:txBody>
-      </p:sp>
-      <p:sp>
-        <p:nvSpPr>
-          <p:cNvPr id="7" name="Slide Number Placeholder 6"/>
-          <p:cNvSpPr>
-            <a:spLocks noGrp="1"/>
-          </p:cNvSpPr>
-          <p:nvPr>
-            <p:ph type="sldNum" sz="quarter" idx="5"/>
-          </p:nvPr>
-        </p:nvSpPr>
-        <p:spPr>
-          <a:xfrm>
-            <a:off x="3884613" y="8685213"/>
-            <a:ext cx="2971800" cy="457200"/>
-          </a:xfrm>
-          <a:prstGeom prst="rect">
-            <a:avLst/>
-          </a:prstGeom>
-        </p:spPr>
-        <p:txBody>
-          <a:bodyPr vert="horz" lIns="91440" tIns="45720" rIns="91440" bIns="45720" rtlCol="0" anchor="b"/>
-          <a:lstStyle>
-            <a:lvl1pPr algn="r">
-              <a:defRPr sz="1200"/>
-            </a:lvl1pPr>
-          </a:lstStyle>
-          <a:p>
-            <a:fld id="{BB5E49A5-4136-284D-997B-48E1D791AD67}" type="slidenum">
-              <a:rPr lang="en-US" smtClean="0"/>
-              <a:t>‹#›</a:t>
-            </a:fld>
-            <a:endParaRPr lang="en-US"/>
-          </a:p>
-        </p:txBody>
-      </p:sp>
     </p:spTree>
     <p:extLst>
       <p:ext uri="{BB962C8B-B14F-4D97-AF65-F5344CB8AC3E}">
-        <p14:creationId xmlns:p14="http://schemas.microsoft.com/office/powerpoint/2010/main" val="2623252185"/>
+        <p14:creationId xmlns:p14="http://schemas.microsoft.com/office/powerpoint/2010/main" val="3688498535"/>
       </p:ext>
     </p:extLst>
   </p:cSld>
   <p:clrMap bg1="lt1" tx1="dk1" bg2="lt2" tx2="dk2" accent1="accent1" accent2="accent2" accent3="accent3" accent4="accent4" accent5="accent5" accent6="accent6" hlink="hlink" folHlink="folHlink"/>
   <p:notesStyle>
-    <a:lvl1pPr marL="0" algn="l" defTabSz="457200" rtl="0" eaLnBrk="1" latinLnBrk="0" hangingPunct="1">
+    <a:lvl1pPr marL="0" algn="l" defTabSz="914400" rtl="0" eaLnBrk="1" latinLnBrk="0" hangingPunct="1">
       <a:defRPr sz="1200" kern="1200">
         <a:solidFill>
           <a:schemeClr val="tx1"/>
@@ -382,7 +176,7 @@
         <a:cs typeface="+mn-cs"/>
       </a:defRPr>
     </a:lvl1pPr>
-    <a:lvl2pPr marL="457200" algn="l" defTabSz="457200" rtl="0" eaLnBrk="1" latinLnBrk="0" hangingPunct="1">
+    <a:lvl2pPr marL="457200" algn="l" defTabSz="914400" rtl="0" eaLnBrk="1" latinLnBrk="0" hangingPunct="1">
       <a:defRPr sz="1200" kern="1200">
         <a:solidFill>
           <a:schemeClr val="tx1"/>
@@ -392,7 +186,7 @@
         <a:cs typeface="+mn-cs"/>
       </a:defRPr>
     </a:lvl2pPr>
-    <a:lvl3pPr marL="914400" algn="l" defTabSz="457200" rtl="0" eaLnBrk="1" latinLnBrk="0" hangingPunct="1">
+    <a:lvl3pPr marL="914400" algn="l" defTabSz="914400" rtl="0" eaLnBrk="1" latinLnBrk="0" hangingPunct="1">
       <a:defRPr sz="1200" kern="1200">
         <a:solidFill>
           <a:schemeClr val="tx1"/>
@@ -402,7 +196,7 @@
         <a:cs typeface="+mn-cs"/>
       </a:defRPr>
     </a:lvl3pPr>
-    <a:lvl4pPr marL="1371600" algn="l" defTabSz="457200" rtl="0" eaLnBrk="1" latinLnBrk="0" hangingPunct="1">
+    <a:lvl4pPr marL="1371600" algn="l" defTabSz="914400" rtl="0" eaLnBrk="1" latinLnBrk="0" hangingPunct="1">
       <a:defRPr sz="1200" kern="1200">
         <a:solidFill>
           <a:schemeClr val="tx1"/>
@@ -412,7 +206,7 @@
         <a:cs typeface="+mn-cs"/>
       </a:defRPr>
     </a:lvl4pPr>
-    <a:lvl5pPr marL="1828800" algn="l" defTabSz="457200" rtl="0" eaLnBrk="1" latinLnBrk="0" hangingPunct="1">
+    <a:lvl5pPr marL="1828800" algn="l" defTabSz="914400" rtl="0" eaLnBrk="1" latinLnBrk="0" hangingPunct="1">
       <a:defRPr sz="1200" kern="1200">
         <a:solidFill>
           <a:schemeClr val="tx1"/>
@@ -422,7 +216,7 @@
         <a:cs typeface="+mn-cs"/>
       </a:defRPr>
     </a:lvl5pPr>
-    <a:lvl6pPr marL="2286000" algn="l" defTabSz="457200" rtl="0" eaLnBrk="1" latinLnBrk="0" hangingPunct="1">
+    <a:lvl6pPr marL="2286000" algn="l" defTabSz="914400" rtl="0" eaLnBrk="1" latinLnBrk="0" hangingPunct="1">
       <a:defRPr sz="1200" kern="1200">
         <a:solidFill>
           <a:schemeClr val="tx1"/>
@@ -432,7 +226,7 @@
         <a:cs typeface="+mn-cs"/>
       </a:defRPr>
     </a:lvl6pPr>
-    <a:lvl7pPr marL="2743200" algn="l" defTabSz="457200" rtl="0" eaLnBrk="1" latinLnBrk="0" hangingPunct="1">
+    <a:lvl7pPr marL="2743200" algn="l" defTabSz="914400" rtl="0" eaLnBrk="1" latinLnBrk="0" hangingPunct="1">
       <a:defRPr sz="1200" kern="1200">
         <a:solidFill>
           <a:schemeClr val="tx1"/>
@@ -442,7 +236,7 @@
         <a:cs typeface="+mn-cs"/>
       </a:defRPr>
     </a:lvl7pPr>
-    <a:lvl8pPr marL="3200400" algn="l" defTabSz="457200" rtl="0" eaLnBrk="1" latinLnBrk="0" hangingPunct="1">
+    <a:lvl8pPr marL="3200400" algn="l" defTabSz="914400" rtl="0" eaLnBrk="1" latinLnBrk="0" hangingPunct="1">
       <a:defRPr sz="1200" kern="1200">
         <a:solidFill>
           <a:schemeClr val="tx1"/>
@@ -452,7 +246,7 @@
         <a:cs typeface="+mn-cs"/>
       </a:defRPr>
     </a:lvl8pPr>
-    <a:lvl9pPr marL="3657600" algn="l" defTabSz="457200" rtl="0" eaLnBrk="1" latinLnBrk="0" hangingPunct="1">
+    <a:lvl9pPr marL="3657600" algn="l" defTabSz="914400" rtl="0" eaLnBrk="1" latinLnBrk="0" hangingPunct="1">
       <a:defRPr sz="1200" kern="1200">
         <a:solidFill>
           <a:schemeClr val="tx1"/>
@@ -467,7 +261,7 @@
 </file>
 
 <file path=ppt/notesSlides/notesSlide1.xml><?xml version="1.0" encoding="utf-8"?>
-<p:notes xmlns:a="http://schemas.openxmlformats.org/drawingml/2006/main" xmlns:p="http://schemas.openxmlformats.org/presentationml/2006/main" xmlns:r="http://schemas.openxmlformats.org/officeDocument/2006/relationships">
+<p:notes xmlns:a="http://schemas.openxmlformats.org/drawingml/2006/main" xmlns:r="http://schemas.openxmlformats.org/officeDocument/2006/relationships" xmlns:p="http://schemas.openxmlformats.org/presentationml/2006/main">
   <p:cSld>
     <p:spTree>
       <p:nvGrpSpPr>
@@ -487,7 +281,7 @@
         <p:nvSpPr>
           <p:cNvPr id="2" name="Slide Image Placeholder 1"/>
           <p:cNvSpPr>
-            <a:spLocks noGrp="1"/>
+            <a:spLocks noGrp="1" noRot="1" noChangeAspect="1"/>
           </p:cNvSpPr>
           <p:nvPr>
             <p:ph type="sldImg" idx="2"/>
@@ -502,7 +296,7 @@
             <a:spLocks noGrp="1"/>
           </p:cNvSpPr>
           <p:nvPr>
-            <p:ph type="body" idx="3" sz="quarter"/>
+            <p:ph type="body" sz="quarter" idx="3"/>
           </p:nvPr>
         </p:nvSpPr>
         <p:spPr/>
@@ -514,13 +308,17 @@
               <a:t>Buenas tardes, soy Claudia y esto es Nahui.</a:t>
             </a:r>
           </a:p>
-          <a:p/>
+          <a:p>
+            <a:endParaRPr/>
+          </a:p>
           <a:p>
             <a:r>
               <a:t>Nahui es una app de registro de ventas e inteligencia de negocio para vendedoras ambulantes en México. La piloteamos con Ana, que vende ropa en bazares privados en el Estado de México.</a:t>
             </a:r>
           </a:p>
-          <a:p/>
+          <a:p>
+            <a:endParaRPr/>
+          </a:p>
           <a:p>
             <a:r>
               <a:t>La promesa es simple: registrar una venta en menos de 3 segundos, sin perder el control del negocio. Les voy a enseñar qué tan real es esto hoy, y qué tan lejos estamos todavía.</a:t>
@@ -535,7 +333,7 @@
             <a:spLocks noGrp="1"/>
           </p:cNvSpPr>
           <p:nvPr>
-            <p:ph type="sldNum" idx="5" sz="quarter"/>
+            <p:ph type="sldNum" sz="quarter" idx="5"/>
           </p:nvPr>
         </p:nvSpPr>
         <p:spPr/>
@@ -549,7 +347,7 @@
 </file>
 
 <file path=ppt/notesSlides/notesSlide10.xml><?xml version="1.0" encoding="utf-8"?>
-<p:notes xmlns:a="http://schemas.openxmlformats.org/drawingml/2006/main" xmlns:p="http://schemas.openxmlformats.org/presentationml/2006/main" xmlns:r="http://schemas.openxmlformats.org/officeDocument/2006/relationships">
+<p:notes xmlns:a="http://schemas.openxmlformats.org/drawingml/2006/main" xmlns:r="http://schemas.openxmlformats.org/officeDocument/2006/relationships" xmlns:p="http://schemas.openxmlformats.org/presentationml/2006/main">
   <p:cSld>
     <p:spTree>
       <p:nvGrpSpPr>
@@ -569,7 +367,7 @@
         <p:nvSpPr>
           <p:cNvPr id="2" name="Slide Image Placeholder 1"/>
           <p:cNvSpPr>
-            <a:spLocks noGrp="1"/>
+            <a:spLocks noGrp="1" noRot="1" noChangeAspect="1"/>
           </p:cNvSpPr>
           <p:nvPr>
             <p:ph type="sldImg" idx="2"/>
@@ -584,7 +382,7 @@
             <a:spLocks noGrp="1"/>
           </p:cNvSpPr>
           <p:nvPr>
-            <p:ph type="body" idx="3" sz="quarter"/>
+            <p:ph type="body" sz="quarter" idx="3"/>
           </p:nvPr>
         </p:nvSpPr>
         <p:spPr/>
@@ -596,7 +394,9 @@
               <a:t>Esto es Nahui hoy: un prototipo real, funcionando, probado, con una campaña real detrás que nos enseñó que el alcance no es el problema, la adopción sí. Y con un equipo de agentes que revisa, corrige y vuelve a comprobar cada cosa antes de darla por buena.</a:t>
             </a:r>
           </a:p>
-          <a:p/>
+          <a:p>
+            <a:endParaRPr/>
+          </a:p>
           <a:p>
             <a:r>
               <a:t>Todavía no lo tenemos todo resuelto, y está bien decirlo así. Ahí les dejo el demo y el repositorio. Gracias.</a:t>
@@ -611,7 +411,7 @@
             <a:spLocks noGrp="1"/>
           </p:cNvSpPr>
           <p:nvPr>
-            <p:ph type="sldNum" idx="5" sz="quarter"/>
+            <p:ph type="sldNum" sz="quarter" idx="5"/>
           </p:nvPr>
         </p:nvSpPr>
         <p:spPr/>
@@ -625,7 +425,7 @@
 </file>
 
 <file path=ppt/notesSlides/notesSlide2.xml><?xml version="1.0" encoding="utf-8"?>
-<p:notes xmlns:a="http://schemas.openxmlformats.org/drawingml/2006/main" xmlns:p="http://schemas.openxmlformats.org/presentationml/2006/main" xmlns:r="http://schemas.openxmlformats.org/officeDocument/2006/relationships">
+<p:notes xmlns:a="http://schemas.openxmlformats.org/drawingml/2006/main" xmlns:r="http://schemas.openxmlformats.org/officeDocument/2006/relationships" xmlns:p="http://schemas.openxmlformats.org/presentationml/2006/main">
   <p:cSld>
     <p:spTree>
       <p:nvGrpSpPr>
@@ -645,7 +445,7 @@
         <p:nvSpPr>
           <p:cNvPr id="2" name="Slide Image Placeholder 1"/>
           <p:cNvSpPr>
-            <a:spLocks noGrp="1"/>
+            <a:spLocks noGrp="1" noRot="1" noChangeAspect="1"/>
           </p:cNvSpPr>
           <p:nvPr>
             <p:ph type="sldImg" idx="2"/>
@@ -660,7 +460,7 @@
             <a:spLocks noGrp="1"/>
           </p:cNvSpPr>
           <p:nvPr>
-            <p:ph type="body" idx="3" sz="quarter"/>
+            <p:ph type="body" sz="quarter" idx="3"/>
           </p:nvPr>
         </p:nvSpPr>
         <p:spPr/>
@@ -672,13 +472,17 @@
               <a:t>El problema no es abstracto, es el de Ana. En un bazar el flujo de clientes es impredecible. Si registrar una venta le toma más de unos segundos, ese tiempo compite directamente con atender al cliente que sigue, y casi siempre pierde el registro, no el cliente.</a:t>
             </a:r>
           </a:p>
-          <a:p/>
+          <a:p>
+            <a:endParaRPr/>
+          </a:p>
           <a:p>
             <a:r>
               <a:t>Esa fricción no es exclusiva de Ana, se repite en cualquier vendedora que atiende de pie, sin caja registradora, sin tiempo muerto entre un cliente y el siguiente.</a:t>
             </a:r>
           </a:p>
-          <a:p/>
+          <a:p>
+            <a:endParaRPr/>
+          </a:p>
           <a:p>
             <a:r>
               <a:t>Por eso Ana limita su propio catálogo, para mantener control mental de lo que tiene. Y eso limita cuánto puede crecer.</a:t>
@@ -693,7 +497,7 @@
             <a:spLocks noGrp="1"/>
           </p:cNvSpPr>
           <p:nvPr>
-            <p:ph type="sldNum" idx="5" sz="quarter"/>
+            <p:ph type="sldNum" sz="quarter" idx="5"/>
           </p:nvPr>
         </p:nvSpPr>
         <p:spPr/>
@@ -707,7 +511,7 @@
 </file>
 
 <file path=ppt/notesSlides/notesSlide3.xml><?xml version="1.0" encoding="utf-8"?>
-<p:notes xmlns:a="http://schemas.openxmlformats.org/drawingml/2006/main" xmlns:p="http://schemas.openxmlformats.org/presentationml/2006/main" xmlns:r="http://schemas.openxmlformats.org/officeDocument/2006/relationships">
+<p:notes xmlns:a="http://schemas.openxmlformats.org/drawingml/2006/main" xmlns:r="http://schemas.openxmlformats.org/officeDocument/2006/relationships" xmlns:p="http://schemas.openxmlformats.org/presentationml/2006/main">
   <p:cSld>
     <p:spTree>
       <p:nvGrpSpPr>
@@ -727,7 +531,7 @@
         <p:nvSpPr>
           <p:cNvPr id="2" name="Slide Image Placeholder 1"/>
           <p:cNvSpPr>
-            <a:spLocks noGrp="1"/>
+            <a:spLocks noGrp="1" noRot="1" noChangeAspect="1"/>
           </p:cNvSpPr>
           <p:nvPr>
             <p:ph type="sldImg" idx="2"/>
@@ -742,7 +546,7 @@
             <a:spLocks noGrp="1"/>
           </p:cNvSpPr>
           <p:nvPr>
-            <p:ph type="body" idx="3" sz="quarter"/>
+            <p:ph type="body" sz="quarter" idx="3"/>
           </p:nvPr>
         </p:nvSpPr>
         <p:spPr/>
@@ -763,7 +567,7 @@
             <a:spLocks noGrp="1"/>
           </p:cNvSpPr>
           <p:nvPr>
-            <p:ph type="sldNum" idx="5" sz="quarter"/>
+            <p:ph type="sldNum" sz="quarter" idx="5"/>
           </p:nvPr>
         </p:nvSpPr>
         <p:spPr/>
@@ -777,7 +581,7 @@
 </file>
 
 <file path=ppt/notesSlides/notesSlide4.xml><?xml version="1.0" encoding="utf-8"?>
-<p:notes xmlns:a="http://schemas.openxmlformats.org/drawingml/2006/main" xmlns:p="http://schemas.openxmlformats.org/presentationml/2006/main" xmlns:r="http://schemas.openxmlformats.org/officeDocument/2006/relationships">
+<p:notes xmlns:a="http://schemas.openxmlformats.org/drawingml/2006/main" xmlns:r="http://schemas.openxmlformats.org/officeDocument/2006/relationships" xmlns:p="http://schemas.openxmlformats.org/presentationml/2006/main">
   <p:cSld>
     <p:spTree>
       <p:nvGrpSpPr>
@@ -797,7 +601,7 @@
         <p:nvSpPr>
           <p:cNvPr id="2" name="Slide Image Placeholder 1"/>
           <p:cNvSpPr>
-            <a:spLocks noGrp="1"/>
+            <a:spLocks noGrp="1" noRot="1" noChangeAspect="1"/>
           </p:cNvSpPr>
           <p:nvPr>
             <p:ph type="sldImg" idx="2"/>
@@ -812,7 +616,7 @@
             <a:spLocks noGrp="1"/>
           </p:cNvSpPr>
           <p:nvPr>
-            <p:ph type="body" idx="3" sz="quarter"/>
+            <p:ph type="body" sz="quarter" idx="3"/>
           </p:nvPr>
         </p:nvSpPr>
         <p:spPr/>
@@ -833,7 +637,7 @@
             <a:spLocks noGrp="1"/>
           </p:cNvSpPr>
           <p:nvPr>
-            <p:ph type="sldNum" idx="5" sz="quarter"/>
+            <p:ph type="sldNum" sz="quarter" idx="5"/>
           </p:nvPr>
         </p:nvSpPr>
         <p:spPr/>
@@ -847,7 +651,7 @@
 </file>
 
 <file path=ppt/notesSlides/notesSlide5.xml><?xml version="1.0" encoding="utf-8"?>
-<p:notes xmlns:a="http://schemas.openxmlformats.org/drawingml/2006/main" xmlns:p="http://schemas.openxmlformats.org/presentationml/2006/main" xmlns:r="http://schemas.openxmlformats.org/officeDocument/2006/relationships">
+<p:notes xmlns:a="http://schemas.openxmlformats.org/drawingml/2006/main" xmlns:r="http://schemas.openxmlformats.org/officeDocument/2006/relationships" xmlns:p="http://schemas.openxmlformats.org/presentationml/2006/main">
   <p:cSld>
     <p:spTree>
       <p:nvGrpSpPr>
@@ -867,7 +671,7 @@
         <p:nvSpPr>
           <p:cNvPr id="2" name="Slide Image Placeholder 1"/>
           <p:cNvSpPr>
-            <a:spLocks noGrp="1"/>
+            <a:spLocks noGrp="1" noRot="1" noChangeAspect="1"/>
           </p:cNvSpPr>
           <p:nvPr>
             <p:ph type="sldImg" idx="2"/>
@@ -882,7 +686,7 @@
             <a:spLocks noGrp="1"/>
           </p:cNvSpPr>
           <p:nvPr>
-            <p:ph type="body" idx="3" sz="quarter"/>
+            <p:ph type="body" sz="quarter" idx="3"/>
           </p:nvPr>
         </p:nvSpPr>
         <p:spPr/>
@@ -903,7 +707,7 @@
             <a:spLocks noGrp="1"/>
           </p:cNvSpPr>
           <p:nvPr>
-            <p:ph type="sldNum" idx="5" sz="quarter"/>
+            <p:ph type="sldNum" sz="quarter" idx="5"/>
           </p:nvPr>
         </p:nvSpPr>
         <p:spPr/>
@@ -917,7 +721,7 @@
 </file>
 
 <file path=ppt/notesSlides/notesSlide6.xml><?xml version="1.0" encoding="utf-8"?>
-<p:notes xmlns:a="http://schemas.openxmlformats.org/drawingml/2006/main" xmlns:p="http://schemas.openxmlformats.org/presentationml/2006/main" xmlns:r="http://schemas.openxmlformats.org/officeDocument/2006/relationships">
+<p:notes xmlns:a="http://schemas.openxmlformats.org/drawingml/2006/main" xmlns:r="http://schemas.openxmlformats.org/officeDocument/2006/relationships" xmlns:p="http://schemas.openxmlformats.org/presentationml/2006/main">
   <p:cSld>
     <p:spTree>
       <p:nvGrpSpPr>
@@ -937,7 +741,7 @@
         <p:nvSpPr>
           <p:cNvPr id="2" name="Slide Image Placeholder 1"/>
           <p:cNvSpPr>
-            <a:spLocks noGrp="1"/>
+            <a:spLocks noGrp="1" noRot="1" noChangeAspect="1"/>
           </p:cNvSpPr>
           <p:nvPr>
             <p:ph type="sldImg" idx="2"/>
@@ -952,7 +756,7 @@
             <a:spLocks noGrp="1"/>
           </p:cNvSpPr>
           <p:nvPr>
-            <p:ph type="body" idx="3" sz="quarter"/>
+            <p:ph type="body" sz="quarter" idx="3"/>
           </p:nvPr>
         </p:nvSpPr>
         <p:spPr/>
@@ -964,19 +768,25 @@
               <a:t>Esta es la diapositiva más difícil de todas, y también la más útil.</a:t>
             </a:r>
           </a:p>
-          <a:p/>
+          <a:p>
+            <a:endParaRPr/>
+          </a:p>
           <a:p>
             <a:r>
               <a:t>Corrimos una campaña real de Meta del 17 al 20 de agosto, tres días, 569 pesos gastados, 731 visitas a la página a 78 centavos cada una. El alcance funciona, y es barato.</a:t>
             </a:r>
           </a:p>
-          <a:p/>
+          <a:p>
+            <a:endParaRPr/>
+          </a:p>
           <a:p>
             <a:r>
               <a:t>Pero Vercel confirmó algo distinto: 583 visitantes reales llegaron al sitio, y solo 2 de ellos dispararon algún evento del recorrido del demo, registro, verificación, cuestionario. Eso es 0.34 por ciento.</a:t>
             </a:r>
           </a:p>
-          <a:p/>
+          <a:p>
+            <a:endParaRPr/>
+          </a:p>
           <a:p>
             <a:r>
               <a:t>No lo descubrimos el primer día. La instrumentación para medir esto se terminó de construir a mitad de la campaña. El alcance no es el problema. La adopción real, todavía no la tenemos, y la causa exacta todavía no está confirmada.</a:t>
@@ -991,7 +801,7 @@
             <a:spLocks noGrp="1"/>
           </p:cNvSpPr>
           <p:nvPr>
-            <p:ph type="sldNum" idx="5" sz="quarter"/>
+            <p:ph type="sldNum" sz="quarter" idx="5"/>
           </p:nvPr>
         </p:nvSpPr>
         <p:spPr/>
@@ -1005,7 +815,7 @@
 </file>
 
 <file path=ppt/notesSlides/notesSlide7.xml><?xml version="1.0" encoding="utf-8"?>
-<p:notes xmlns:a="http://schemas.openxmlformats.org/drawingml/2006/main" xmlns:p="http://schemas.openxmlformats.org/presentationml/2006/main" xmlns:r="http://schemas.openxmlformats.org/officeDocument/2006/relationships">
+<p:notes xmlns:a="http://schemas.openxmlformats.org/drawingml/2006/main" xmlns:r="http://schemas.openxmlformats.org/officeDocument/2006/relationships" xmlns:p="http://schemas.openxmlformats.org/presentationml/2006/main">
   <p:cSld>
     <p:spTree>
       <p:nvGrpSpPr>
@@ -1025,7 +835,7 @@
         <p:nvSpPr>
           <p:cNvPr id="2" name="Slide Image Placeholder 1"/>
           <p:cNvSpPr>
-            <a:spLocks noGrp="1"/>
+            <a:spLocks noGrp="1" noRot="1" noChangeAspect="1"/>
           </p:cNvSpPr>
           <p:nvPr>
             <p:ph type="sldImg" idx="2"/>
@@ -1040,7 +850,7 @@
             <a:spLocks noGrp="1"/>
           </p:cNvSpPr>
           <p:nvPr>
-            <p:ph type="body" idx="3" sz="quarter"/>
+            <p:ph type="body" sz="quarter" idx="3"/>
           </p:nvPr>
         </p:nvSpPr>
         <p:spPr/>
@@ -1052,13 +862,17 @@
               <a:t>Nahui no la construyo yo sola escribiendo código. La construye un equipo de agentes de inteligencia artificial especializados, no una sola IA generalista.</a:t>
             </a:r>
           </a:p>
-          <a:p/>
+          <a:p>
+            <a:endParaRPr/>
+          </a:p>
           <a:p>
             <a:r>
               <a:t>Cada uno tiene una sola función y su propio límite de autoridad. Architect solo lee y opina sobre el modelo del negocio. Ux-designer y ui-designer diseñan y construyen. Ux-critic y reviewer revisan antes de que algo se dé por bueno.</a:t>
             </a:r>
           </a:p>
-          <a:p/>
+          <a:p>
+            <a:endParaRPr/>
+          </a:p>
           <a:p>
             <a:r>
               <a:t>Y merchant-user-tester, el más importante de todos para mí, no tiene acceso a ningún archivo del proyecto, solo puede navegar el producto como lo haría una vendedora real que nunca lo ha visto. Main coordina y persiste todo esto, pero nunca decide en lugar de los demás.</a:t>
@@ -1073,7 +887,7 @@
             <a:spLocks noGrp="1"/>
           </p:cNvSpPr>
           <p:nvPr>
-            <p:ph type="sldNum" idx="5" sz="quarter"/>
+            <p:ph type="sldNum" sz="quarter" idx="5"/>
           </p:nvPr>
         </p:nvSpPr>
         <p:spPr/>
@@ -1087,7 +901,7 @@
 </file>
 
 <file path=ppt/notesSlides/notesSlide8.xml><?xml version="1.0" encoding="utf-8"?>
-<p:notes xmlns:a="http://schemas.openxmlformats.org/drawingml/2006/main" xmlns:p="http://schemas.openxmlformats.org/presentationml/2006/main" xmlns:r="http://schemas.openxmlformats.org/officeDocument/2006/relationships">
+<p:notes xmlns:a="http://schemas.openxmlformats.org/drawingml/2006/main" xmlns:r="http://schemas.openxmlformats.org/officeDocument/2006/relationships" xmlns:p="http://schemas.openxmlformats.org/presentationml/2006/main">
   <p:cSld>
     <p:spTree>
       <p:nvGrpSpPr>
@@ -1107,7 +921,7 @@
         <p:nvSpPr>
           <p:cNvPr id="2" name="Slide Image Placeholder 1"/>
           <p:cNvSpPr>
-            <a:spLocks noGrp="1"/>
+            <a:spLocks noGrp="1" noRot="1" noChangeAspect="1"/>
           </p:cNvSpPr>
           <p:nvPr>
             <p:ph type="sldImg" idx="2"/>
@@ -1122,7 +936,7 @@
             <a:spLocks noGrp="1"/>
           </p:cNvSpPr>
           <p:nvPr>
-            <p:ph type="body" idx="3" sz="quarter"/>
+            <p:ph type="body" sz="quarter" idx="3"/>
           </p:nvPr>
         </p:nvSpPr>
         <p:spPr/>
@@ -1134,7 +948,9 @@
               <a:t>Nada en Nahui se da por cerrado sin comprobarlo contra el producto real. Diseñamos, revisamos, construimos, y ahí es donde entra lo que de verdad importa: el hallazgo real. No una suposición, un hallazgo real, de una prueba con Ana o de una campaña de verdad.</a:t>
             </a:r>
           </a:p>
-          <a:p/>
+          <a:p>
+            <a:endParaRPr/>
+          </a:p>
           <a:p>
             <a:r>
               <a:t>Ese hallazgo dispara una corrección, y la corrección se vuelve a validar contra el producto real antes de darse por cerrada. Nunca se confía sin comprobar.</a:t>
@@ -1149,7 +965,7 @@
             <a:spLocks noGrp="1"/>
           </p:cNvSpPr>
           <p:nvPr>
-            <p:ph type="sldNum" idx="5" sz="quarter"/>
+            <p:ph type="sldNum" sz="quarter" idx="5"/>
           </p:nvPr>
         </p:nvSpPr>
         <p:spPr/>
@@ -1163,7 +979,7 @@
 </file>
 
 <file path=ppt/notesSlides/notesSlide9.xml><?xml version="1.0" encoding="utf-8"?>
-<p:notes xmlns:a="http://schemas.openxmlformats.org/drawingml/2006/main" xmlns:p="http://schemas.openxmlformats.org/presentationml/2006/main" xmlns:r="http://schemas.openxmlformats.org/officeDocument/2006/relationships">
+<p:notes xmlns:a="http://schemas.openxmlformats.org/drawingml/2006/main" xmlns:r="http://schemas.openxmlformats.org/officeDocument/2006/relationships" xmlns:p="http://schemas.openxmlformats.org/presentationml/2006/main">
   <p:cSld>
     <p:spTree>
       <p:nvGrpSpPr>
@@ -1183,7 +999,7 @@
         <p:nvSpPr>
           <p:cNvPr id="2" name="Slide Image Placeholder 1"/>
           <p:cNvSpPr>
-            <a:spLocks noGrp="1"/>
+            <a:spLocks noGrp="1" noRot="1" noChangeAspect="1"/>
           </p:cNvSpPr>
           <p:nvPr>
             <p:ph type="sldImg" idx="2"/>
@@ -1198,7 +1014,7 @@
             <a:spLocks noGrp="1"/>
           </p:cNvSpPr>
           <p:nvPr>
-            <p:ph type="body" idx="3" sz="quarter"/>
+            <p:ph type="body" sz="quarter" idx="3"/>
           </p:nvPr>
         </p:nvSpPr>
         <p:spPr/>
@@ -1210,7 +1026,9 @@
               <a:t>Esta línea de tiempo no es una lista de entregables. Cada punto existe porque resolvió un problema real que apareció en el camino, no porque estuviera planeado desde el inicio.</a:t>
             </a:r>
           </a:p>
-          <a:p/>
+          <a:p>
+            <a:endParaRPr/>
+          </a:p>
           <a:p>
             <a:r>
               <a:t>Y aquí quiero ser clara sobre algo: no soy experta en sistemas agénticos de inteligencia artificial, no sé optimizar el consumo de tokens con precisión técnica. Varias decisiones técnicas del camino tampoco las tomé sola, cambié de herramienta de diseño por recomendación directa de la maestra, y usar un equipo de agentes especializados en vez de una sola IA generalista fue algo que ella mencionó como mejor práctica. Entender cómo funciona realmente de fondo lo aprendí después, trabajando con mi propio equipo.</a:t>
@@ -1225,7 +1043,7 @@
             <a:spLocks noGrp="1"/>
           </p:cNvSpPr>
           <p:nvPr>
-            <p:ph type="sldNum" idx="5" sz="quarter"/>
+            <p:ph type="sldNum" sz="quarter" idx="5"/>
           </p:nvPr>
         </p:nvSpPr>
         <p:spPr/>
@@ -1276,10 +1094,9 @@
           <a:lstStyle/>
           <a:p>
             <a:r>
-              <a:rPr lang="en-US" smtClean="0"/>
+              <a:rPr lang="en-US"/>
               <a:t>Click to edit Master title style</a:t>
             </a:r>
-            <a:endParaRPr lang="en-US"/>
           </a:p>
         </p:txBody>
       </p:sp>
@@ -1395,10 +1212,9 @@
           </a:lstStyle>
           <a:p>
             <a:r>
-              <a:rPr lang="en-US" smtClean="0"/>
+              <a:rPr lang="en-US"/>
               <a:t>Click to edit Master subtitle style</a:t>
             </a:r>
-            <a:endParaRPr lang="en-US"/>
           </a:p>
         </p:txBody>
       </p:sp>
@@ -1419,7 +1235,7 @@
           <a:p>
             <a:fld id="{5BCAD085-E8A6-8845-BD4E-CB4CCA059FC4}" type="datetimeFigureOut">
               <a:rPr lang="en-US" smtClean="0"/>
-              <a:t>1/27/13</a:t>
+              <a:t>8/22/26</a:t>
             </a:fld>
             <a:endParaRPr lang="en-US"/>
           </a:p>
@@ -1513,10 +1329,9 @@
           <a:lstStyle/>
           <a:p>
             <a:r>
-              <a:rPr lang="en-US" smtClean="0"/>
+              <a:rPr lang="en-US"/>
               <a:t>Click to edit Master title style</a:t>
             </a:r>
-            <a:endParaRPr lang="en-US"/>
           </a:p>
         </p:txBody>
       </p:sp>
@@ -1537,38 +1352,37 @@
           <a:p>
             <a:pPr lvl="0"/>
             <a:r>
-              <a:rPr lang="en-US" smtClean="0"/>
+              <a:rPr lang="en-US"/>
               <a:t>Click to edit Master text styles</a:t>
             </a:r>
           </a:p>
           <a:p>
             <a:pPr lvl="1"/>
             <a:r>
-              <a:rPr lang="en-US" smtClean="0"/>
+              <a:rPr lang="en-US"/>
               <a:t>Second level</a:t>
             </a:r>
           </a:p>
           <a:p>
             <a:pPr lvl="2"/>
             <a:r>
-              <a:rPr lang="en-US" smtClean="0"/>
+              <a:rPr lang="en-US"/>
               <a:t>Third level</a:t>
             </a:r>
           </a:p>
           <a:p>
             <a:pPr lvl="3"/>
             <a:r>
-              <a:rPr lang="en-US" smtClean="0"/>
+              <a:rPr lang="en-US"/>
               <a:t>Fourth level</a:t>
             </a:r>
           </a:p>
           <a:p>
             <a:pPr lvl="4"/>
             <a:r>
-              <a:rPr lang="en-US" smtClean="0"/>
+              <a:rPr lang="en-US"/>
               <a:t>Fifth level</a:t>
             </a:r>
-            <a:endParaRPr lang="en-US"/>
           </a:p>
         </p:txBody>
       </p:sp>
@@ -1589,7 +1403,7 @@
           <a:p>
             <a:fld id="{5BCAD085-E8A6-8845-BD4E-CB4CCA059FC4}" type="datetimeFigureOut">
               <a:rPr lang="en-US" smtClean="0"/>
-              <a:t>1/27/13</a:t>
+              <a:t>8/22/26</a:t>
             </a:fld>
             <a:endParaRPr lang="en-US"/>
           </a:p>
@@ -1688,10 +1502,9 @@
           <a:lstStyle/>
           <a:p>
             <a:r>
-              <a:rPr lang="en-US" smtClean="0"/>
+              <a:rPr lang="en-US"/>
               <a:t>Click to edit Master title style</a:t>
             </a:r>
-            <a:endParaRPr lang="en-US"/>
           </a:p>
         </p:txBody>
       </p:sp>
@@ -1717,38 +1530,37 @@
           <a:p>
             <a:pPr lvl="0"/>
             <a:r>
-              <a:rPr lang="en-US" smtClean="0"/>
+              <a:rPr lang="en-US"/>
               <a:t>Click to edit Master text styles</a:t>
             </a:r>
           </a:p>
           <a:p>
             <a:pPr lvl="1"/>
             <a:r>
-              <a:rPr lang="en-US" smtClean="0"/>
+              <a:rPr lang="en-US"/>
               <a:t>Second level</a:t>
             </a:r>
           </a:p>
           <a:p>
             <a:pPr lvl="2"/>
             <a:r>
-              <a:rPr lang="en-US" smtClean="0"/>
+              <a:rPr lang="en-US"/>
               <a:t>Third level</a:t>
             </a:r>
           </a:p>
           <a:p>
             <a:pPr lvl="3"/>
             <a:r>
-              <a:rPr lang="en-US" smtClean="0"/>
+              <a:rPr lang="en-US"/>
               <a:t>Fourth level</a:t>
             </a:r>
           </a:p>
           <a:p>
             <a:pPr lvl="4"/>
             <a:r>
-              <a:rPr lang="en-US" smtClean="0"/>
+              <a:rPr lang="en-US"/>
               <a:t>Fifth level</a:t>
             </a:r>
-            <a:endParaRPr lang="en-US"/>
           </a:p>
         </p:txBody>
       </p:sp>
@@ -1769,7 +1581,7 @@
           <a:p>
             <a:fld id="{5BCAD085-E8A6-8845-BD4E-CB4CCA059FC4}" type="datetimeFigureOut">
               <a:rPr lang="en-US" smtClean="0"/>
-              <a:t>1/27/13</a:t>
+              <a:t>8/22/26</a:t>
             </a:fld>
             <a:endParaRPr lang="en-US"/>
           </a:p>
@@ -1863,10 +1675,9 @@
           <a:lstStyle/>
           <a:p>
             <a:r>
-              <a:rPr lang="en-US" smtClean="0"/>
+              <a:rPr lang="en-US"/>
               <a:t>Click to edit Master title style</a:t>
             </a:r>
-            <a:endParaRPr lang="en-US"/>
           </a:p>
         </p:txBody>
       </p:sp>
@@ -1887,38 +1698,37 @@
           <a:p>
             <a:pPr lvl="0"/>
             <a:r>
-              <a:rPr lang="en-US" smtClean="0"/>
+              <a:rPr lang="en-US"/>
               <a:t>Click to edit Master text styles</a:t>
             </a:r>
           </a:p>
           <a:p>
             <a:pPr lvl="1"/>
             <a:r>
-              <a:rPr lang="en-US" smtClean="0"/>
+              <a:rPr lang="en-US"/>
               <a:t>Second level</a:t>
             </a:r>
           </a:p>
           <a:p>
             <a:pPr lvl="2"/>
             <a:r>
-              <a:rPr lang="en-US" smtClean="0"/>
+              <a:rPr lang="en-US"/>
               <a:t>Third level</a:t>
             </a:r>
           </a:p>
           <a:p>
             <a:pPr lvl="3"/>
             <a:r>
-              <a:rPr lang="en-US" smtClean="0"/>
+              <a:rPr lang="en-US"/>
               <a:t>Fourth level</a:t>
             </a:r>
           </a:p>
           <a:p>
             <a:pPr lvl="4"/>
             <a:r>
-              <a:rPr lang="en-US" smtClean="0"/>
+              <a:rPr lang="en-US"/>
               <a:t>Fifth level</a:t>
             </a:r>
-            <a:endParaRPr lang="en-US"/>
           </a:p>
         </p:txBody>
       </p:sp>
@@ -1939,7 +1749,7 @@
           <a:p>
             <a:fld id="{5BCAD085-E8A6-8845-BD4E-CB4CCA059FC4}" type="datetimeFigureOut">
               <a:rPr lang="en-US" smtClean="0"/>
-              <a:t>1/27/13</a:t>
+              <a:t>8/22/26</a:t>
             </a:fld>
             <a:endParaRPr lang="en-US"/>
           </a:p>
@@ -2042,10 +1852,9 @@
           </a:lstStyle>
           <a:p>
             <a:r>
-              <a:rPr lang="en-US" smtClean="0"/>
+              <a:rPr lang="en-US"/>
               <a:t>Click to edit Master title style</a:t>
             </a:r>
-            <a:endParaRPr lang="en-US"/>
           </a:p>
         </p:txBody>
       </p:sp>
@@ -2162,7 +1971,7 @@
           <a:p>
             <a:pPr lvl="0"/>
             <a:r>
-              <a:rPr lang="en-US" smtClean="0"/>
+              <a:rPr lang="en-US"/>
               <a:t>Click to edit Master text styles</a:t>
             </a:r>
           </a:p>
@@ -2185,7 +1994,7 @@
           <a:p>
             <a:fld id="{5BCAD085-E8A6-8845-BD4E-CB4CCA059FC4}" type="datetimeFigureOut">
               <a:rPr lang="en-US" smtClean="0"/>
-              <a:t>1/27/13</a:t>
+              <a:t>8/22/26</a:t>
             </a:fld>
             <a:endParaRPr lang="en-US"/>
           </a:p>
@@ -2279,10 +2088,9 @@
           <a:lstStyle/>
           <a:p>
             <a:r>
-              <a:rPr lang="en-US" smtClean="0"/>
+              <a:rPr lang="en-US"/>
               <a:t>Click to edit Master title style</a:t>
             </a:r>
-            <a:endParaRPr lang="en-US"/>
           </a:p>
         </p:txBody>
       </p:sp>
@@ -2336,38 +2144,37 @@
           <a:p>
             <a:pPr lvl="0"/>
             <a:r>
-              <a:rPr lang="en-US" smtClean="0"/>
+              <a:rPr lang="en-US"/>
               <a:t>Click to edit Master text styles</a:t>
             </a:r>
           </a:p>
           <a:p>
             <a:pPr lvl="1"/>
             <a:r>
-              <a:rPr lang="en-US" smtClean="0"/>
+              <a:rPr lang="en-US"/>
               <a:t>Second level</a:t>
             </a:r>
           </a:p>
           <a:p>
             <a:pPr lvl="2"/>
             <a:r>
-              <a:rPr lang="en-US" smtClean="0"/>
+              <a:rPr lang="en-US"/>
               <a:t>Third level</a:t>
             </a:r>
           </a:p>
           <a:p>
             <a:pPr lvl="3"/>
             <a:r>
-              <a:rPr lang="en-US" smtClean="0"/>
+              <a:rPr lang="en-US"/>
               <a:t>Fourth level</a:t>
             </a:r>
           </a:p>
           <a:p>
             <a:pPr lvl="4"/>
             <a:r>
-              <a:rPr lang="en-US" smtClean="0"/>
+              <a:rPr lang="en-US"/>
               <a:t>Fifth level</a:t>
             </a:r>
-            <a:endParaRPr lang="en-US"/>
           </a:p>
         </p:txBody>
       </p:sp>
@@ -2421,38 +2228,37 @@
           <a:p>
             <a:pPr lvl="0"/>
             <a:r>
-              <a:rPr lang="en-US" smtClean="0"/>
+              <a:rPr lang="en-US"/>
               <a:t>Click to edit Master text styles</a:t>
             </a:r>
           </a:p>
           <a:p>
             <a:pPr lvl="1"/>
             <a:r>
-              <a:rPr lang="en-US" smtClean="0"/>
+              <a:rPr lang="en-US"/>
               <a:t>Second level</a:t>
             </a:r>
           </a:p>
           <a:p>
             <a:pPr lvl="2"/>
             <a:r>
-              <a:rPr lang="en-US" smtClean="0"/>
+              <a:rPr lang="en-US"/>
               <a:t>Third level</a:t>
             </a:r>
           </a:p>
           <a:p>
             <a:pPr lvl="3"/>
             <a:r>
-              <a:rPr lang="en-US" smtClean="0"/>
+              <a:rPr lang="en-US"/>
               <a:t>Fourth level</a:t>
             </a:r>
           </a:p>
           <a:p>
             <a:pPr lvl="4"/>
             <a:r>
-              <a:rPr lang="en-US" smtClean="0"/>
+              <a:rPr lang="en-US"/>
               <a:t>Fifth level</a:t>
             </a:r>
-            <a:endParaRPr lang="en-US"/>
           </a:p>
         </p:txBody>
       </p:sp>
@@ -2473,7 +2279,7 @@
           <a:p>
             <a:fld id="{5BCAD085-E8A6-8845-BD4E-CB4CCA059FC4}" type="datetimeFigureOut">
               <a:rPr lang="en-US" smtClean="0"/>
-              <a:t>1/27/13</a:t>
+              <a:t>8/22/26</a:t>
             </a:fld>
             <a:endParaRPr lang="en-US"/>
           </a:p>
@@ -2571,10 +2377,9 @@
           </a:lstStyle>
           <a:p>
             <a:r>
-              <a:rPr lang="en-US" smtClean="0"/>
+              <a:rPr lang="en-US"/>
               <a:t>Click to edit Master title style</a:t>
             </a:r>
-            <a:endParaRPr lang="en-US"/>
           </a:p>
         </p:txBody>
       </p:sp>
@@ -2637,7 +2442,7 @@
           <a:p>
             <a:pPr lvl="0"/>
             <a:r>
-              <a:rPr lang="en-US" smtClean="0"/>
+              <a:rPr lang="en-US"/>
               <a:t>Click to edit Master text styles</a:t>
             </a:r>
           </a:p>
@@ -2693,38 +2498,37 @@
           <a:p>
             <a:pPr lvl="0"/>
             <a:r>
-              <a:rPr lang="en-US" smtClean="0"/>
+              <a:rPr lang="en-US"/>
               <a:t>Click to edit Master text styles</a:t>
             </a:r>
           </a:p>
           <a:p>
             <a:pPr lvl="1"/>
             <a:r>
-              <a:rPr lang="en-US" smtClean="0"/>
+              <a:rPr lang="en-US"/>
               <a:t>Second level</a:t>
             </a:r>
           </a:p>
           <a:p>
             <a:pPr lvl="2"/>
             <a:r>
-              <a:rPr lang="en-US" smtClean="0"/>
+              <a:rPr lang="en-US"/>
               <a:t>Third level</a:t>
             </a:r>
           </a:p>
           <a:p>
             <a:pPr lvl="3"/>
             <a:r>
-              <a:rPr lang="en-US" smtClean="0"/>
+              <a:rPr lang="en-US"/>
               <a:t>Fourth level</a:t>
             </a:r>
           </a:p>
           <a:p>
             <a:pPr lvl="4"/>
             <a:r>
-              <a:rPr lang="en-US" smtClean="0"/>
+              <a:rPr lang="en-US"/>
               <a:t>Fifth level</a:t>
             </a:r>
-            <a:endParaRPr lang="en-US"/>
           </a:p>
         </p:txBody>
       </p:sp>
@@ -2787,7 +2591,7 @@
           <a:p>
             <a:pPr lvl="0"/>
             <a:r>
-              <a:rPr lang="en-US" smtClean="0"/>
+              <a:rPr lang="en-US"/>
               <a:t>Click to edit Master text styles</a:t>
             </a:r>
           </a:p>
@@ -2843,38 +2647,37 @@
           <a:p>
             <a:pPr lvl="0"/>
             <a:r>
-              <a:rPr lang="en-US" smtClean="0"/>
+              <a:rPr lang="en-US"/>
               <a:t>Click to edit Master text styles</a:t>
             </a:r>
           </a:p>
           <a:p>
             <a:pPr lvl="1"/>
             <a:r>
-              <a:rPr lang="en-US" smtClean="0"/>
+              <a:rPr lang="en-US"/>
               <a:t>Second level</a:t>
             </a:r>
           </a:p>
           <a:p>
             <a:pPr lvl="2"/>
             <a:r>
-              <a:rPr lang="en-US" smtClean="0"/>
+              <a:rPr lang="en-US"/>
               <a:t>Third level</a:t>
             </a:r>
           </a:p>
           <a:p>
             <a:pPr lvl="3"/>
             <a:r>
-              <a:rPr lang="en-US" smtClean="0"/>
+              <a:rPr lang="en-US"/>
               <a:t>Fourth level</a:t>
             </a:r>
           </a:p>
           <a:p>
             <a:pPr lvl="4"/>
             <a:r>
-              <a:rPr lang="en-US" smtClean="0"/>
+              <a:rPr lang="en-US"/>
               <a:t>Fifth level</a:t>
             </a:r>
-            <a:endParaRPr lang="en-US"/>
           </a:p>
         </p:txBody>
       </p:sp>
@@ -2895,7 +2698,7 @@
           <a:p>
             <a:fld id="{5BCAD085-E8A6-8845-BD4E-CB4CCA059FC4}" type="datetimeFigureOut">
               <a:rPr lang="en-US" smtClean="0"/>
-              <a:t>1/27/13</a:t>
+              <a:t>8/22/26</a:t>
             </a:fld>
             <a:endParaRPr lang="en-US"/>
           </a:p>
@@ -2989,10 +2792,9 @@
           <a:lstStyle/>
           <a:p>
             <a:r>
-              <a:rPr lang="en-US" smtClean="0"/>
+              <a:rPr lang="en-US"/>
               <a:t>Click to edit Master title style</a:t>
             </a:r>
-            <a:endParaRPr lang="en-US"/>
           </a:p>
         </p:txBody>
       </p:sp>
@@ -3013,7 +2815,7 @@
           <a:p>
             <a:fld id="{5BCAD085-E8A6-8845-BD4E-CB4CCA059FC4}" type="datetimeFigureOut">
               <a:rPr lang="en-US" smtClean="0"/>
-              <a:t>1/27/13</a:t>
+              <a:t>8/22/26</a:t>
             </a:fld>
             <a:endParaRPr lang="en-US"/>
           </a:p>
@@ -3108,7 +2910,7 @@
           <a:p>
             <a:fld id="{5BCAD085-E8A6-8845-BD4E-CB4CCA059FC4}" type="datetimeFigureOut">
               <a:rPr lang="en-US" smtClean="0"/>
-              <a:t>1/27/13</a:t>
+              <a:t>8/22/26</a:t>
             </a:fld>
             <a:endParaRPr lang="en-US"/>
           </a:p>
@@ -3211,10 +3013,9 @@
           </a:lstStyle>
           <a:p>
             <a:r>
-              <a:rPr lang="en-US" smtClean="0"/>
+              <a:rPr lang="en-US"/>
               <a:t>Click to edit Master title style</a:t>
             </a:r>
-            <a:endParaRPr lang="en-US"/>
           </a:p>
         </p:txBody>
       </p:sp>
@@ -3268,38 +3069,37 @@
           <a:p>
             <a:pPr lvl="0"/>
             <a:r>
-              <a:rPr lang="en-US" smtClean="0"/>
+              <a:rPr lang="en-US"/>
               <a:t>Click to edit Master text styles</a:t>
             </a:r>
           </a:p>
           <a:p>
             <a:pPr lvl="1"/>
             <a:r>
-              <a:rPr lang="en-US" smtClean="0"/>
+              <a:rPr lang="en-US"/>
               <a:t>Second level</a:t>
             </a:r>
           </a:p>
           <a:p>
             <a:pPr lvl="2"/>
             <a:r>
-              <a:rPr lang="en-US" smtClean="0"/>
+              <a:rPr lang="en-US"/>
               <a:t>Third level</a:t>
             </a:r>
           </a:p>
           <a:p>
             <a:pPr lvl="3"/>
             <a:r>
-              <a:rPr lang="en-US" smtClean="0"/>
+              <a:rPr lang="en-US"/>
               <a:t>Fourth level</a:t>
             </a:r>
           </a:p>
           <a:p>
             <a:pPr lvl="4"/>
             <a:r>
-              <a:rPr lang="en-US" smtClean="0"/>
+              <a:rPr lang="en-US"/>
               <a:t>Fifth level</a:t>
             </a:r>
-            <a:endParaRPr lang="en-US"/>
           </a:p>
         </p:txBody>
       </p:sp>
@@ -3362,7 +3162,7 @@
           <a:p>
             <a:pPr lvl="0"/>
             <a:r>
-              <a:rPr lang="en-US" smtClean="0"/>
+              <a:rPr lang="en-US"/>
               <a:t>Click to edit Master text styles</a:t>
             </a:r>
           </a:p>
@@ -3385,7 +3185,7 @@
           <a:p>
             <a:fld id="{5BCAD085-E8A6-8845-BD4E-CB4CCA059FC4}" type="datetimeFigureOut">
               <a:rPr lang="en-US" smtClean="0"/>
-              <a:t>1/27/13</a:t>
+              <a:t>8/22/26</a:t>
             </a:fld>
             <a:endParaRPr lang="en-US"/>
           </a:p>
@@ -3488,10 +3288,9 @@
           </a:lstStyle>
           <a:p>
             <a:r>
-              <a:rPr lang="en-US" smtClean="0"/>
+              <a:rPr lang="en-US"/>
               <a:t>Click to edit Master title style</a:t>
             </a:r>
-            <a:endParaRPr lang="en-US"/>
           </a:p>
         </p:txBody>
       </p:sp>
@@ -3615,7 +3414,7 @@
           <a:p>
             <a:pPr lvl="0"/>
             <a:r>
-              <a:rPr lang="en-US" smtClean="0"/>
+              <a:rPr lang="en-US"/>
               <a:t>Click to edit Master text styles</a:t>
             </a:r>
           </a:p>
@@ -3638,7 +3437,7 @@
           <a:p>
             <a:fld id="{5BCAD085-E8A6-8845-BD4E-CB4CCA059FC4}" type="datetimeFigureOut">
               <a:rPr lang="en-US" smtClean="0"/>
-              <a:t>1/27/13</a:t>
+              <a:t>8/22/26</a:t>
             </a:fld>
             <a:endParaRPr lang="en-US"/>
           </a:p>
@@ -3747,10 +3546,9 @@
           <a:lstStyle/>
           <a:p>
             <a:r>
-              <a:rPr lang="en-US" smtClean="0"/>
+              <a:rPr lang="en-US"/>
               <a:t>Click to edit Master title style</a:t>
             </a:r>
-            <a:endParaRPr lang="en-US"/>
           </a:p>
         </p:txBody>
       </p:sp>
@@ -3781,38 +3579,37 @@
           <a:p>
             <a:pPr lvl="0"/>
             <a:r>
-              <a:rPr lang="en-US" smtClean="0"/>
+              <a:rPr lang="en-US"/>
               <a:t>Click to edit Master text styles</a:t>
             </a:r>
           </a:p>
           <a:p>
             <a:pPr lvl="1"/>
             <a:r>
-              <a:rPr lang="en-US" smtClean="0"/>
+              <a:rPr lang="en-US"/>
               <a:t>Second level</a:t>
             </a:r>
           </a:p>
           <a:p>
             <a:pPr lvl="2"/>
             <a:r>
-              <a:rPr lang="en-US" smtClean="0"/>
+              <a:rPr lang="en-US"/>
               <a:t>Third level</a:t>
             </a:r>
           </a:p>
           <a:p>
             <a:pPr lvl="3"/>
             <a:r>
-              <a:rPr lang="en-US" smtClean="0"/>
+              <a:rPr lang="en-US"/>
               <a:t>Fourth level</a:t>
             </a:r>
           </a:p>
           <a:p>
             <a:pPr lvl="4"/>
             <a:r>
-              <a:rPr lang="en-US" smtClean="0"/>
+              <a:rPr lang="en-US"/>
               <a:t>Fifth level</a:t>
             </a:r>
-            <a:endParaRPr lang="en-US"/>
           </a:p>
         </p:txBody>
       </p:sp>
@@ -3851,7 +3648,7 @@
           <a:p>
             <a:fld id="{5BCAD085-E8A6-8845-BD4E-CB4CCA059FC4}" type="datetimeFigureOut">
               <a:rPr lang="en-US" smtClean="0"/>
-              <a:t>1/27/13</a:t>
+              <a:t>8/22/26</a:t>
             </a:fld>
             <a:endParaRPr lang="en-US"/>
           </a:p>
@@ -4210,7 +4007,7 @@
 </file>
 
 <file path=ppt/slides/slide1.xml><?xml version="1.0" encoding="utf-8"?>
-<p:sld xmlns:a="http://schemas.openxmlformats.org/drawingml/2006/main" xmlns:p="http://schemas.openxmlformats.org/presentationml/2006/main" xmlns:r="http://schemas.openxmlformats.org/officeDocument/2006/relationships">
+<p:sld xmlns:a="http://schemas.openxmlformats.org/drawingml/2006/main" xmlns:r="http://schemas.openxmlformats.org/officeDocument/2006/relationships" xmlns:p="http://schemas.openxmlformats.org/presentationml/2006/main">
   <p:cSld>
     <p:spTree>
       <p:nvGrpSpPr>
@@ -4218,7 +4015,14 @@
         <p:cNvGrpSpPr/>
         <p:nvPr/>
       </p:nvGrpSpPr>
-      <p:grpSpPr/>
+      <p:grpSpPr>
+        <a:xfrm>
+          <a:off x="0" y="0"/>
+          <a:ext cx="0" cy="0"/>
+          <a:chOff x="0" y="0"/>
+          <a:chExt cx="0" cy="0"/>
+        </a:xfrm>
+      </p:grpSpPr>
       <p:sp>
         <p:nvSpPr>
           <p:cNvPr id="2" name="Rectangle 1"/>
@@ -4260,6 +4064,7 @@
           <a:lstStyle/>
           <a:p>
             <a:pPr algn="ctr"/>
+            <a:endParaRPr/>
           </a:p>
         </p:txBody>
       </p:sp>
@@ -4389,7 +4194,7 @@
 </file>
 
 <file path=ppt/slides/slide10.xml><?xml version="1.0" encoding="utf-8"?>
-<p:sld xmlns:a="http://schemas.openxmlformats.org/drawingml/2006/main" xmlns:p="http://schemas.openxmlformats.org/presentationml/2006/main" xmlns:r="http://schemas.openxmlformats.org/officeDocument/2006/relationships">
+<p:sld xmlns:a="http://schemas.openxmlformats.org/drawingml/2006/main" xmlns:r="http://schemas.openxmlformats.org/officeDocument/2006/relationships" xmlns:p="http://schemas.openxmlformats.org/presentationml/2006/main">
   <p:cSld>
     <p:spTree>
       <p:nvGrpSpPr>
@@ -4397,7 +4202,14 @@
         <p:cNvGrpSpPr/>
         <p:nvPr/>
       </p:nvGrpSpPr>
-      <p:grpSpPr/>
+      <p:grpSpPr>
+        <a:xfrm>
+          <a:off x="0" y="0"/>
+          <a:ext cx="0" cy="0"/>
+          <a:chOff x="0" y="0"/>
+          <a:chExt cx="0" cy="0"/>
+        </a:xfrm>
+      </p:grpSpPr>
       <p:sp>
         <p:nvSpPr>
           <p:cNvPr id="2" name="Rectangle 1"/>
@@ -4439,6 +4251,7 @@
           <a:lstStyle/>
           <a:p>
             <a:pPr algn="ctr"/>
+            <a:endParaRPr/>
           </a:p>
         </p:txBody>
       </p:sp>
@@ -4490,7 +4303,7 @@
           <p:nvPr/>
         </p:nvPicPr>
         <p:blipFill>
-          <a:blip r:embed="rId2"/>
+          <a:blip r:embed="rId3"/>
           <a:stretch>
             <a:fillRect/>
           </a:stretch>
@@ -4514,7 +4327,7 @@
 </file>
 
 <file path=ppt/slides/slide2.xml><?xml version="1.0" encoding="utf-8"?>
-<p:sld xmlns:a="http://schemas.openxmlformats.org/drawingml/2006/main" xmlns:p="http://schemas.openxmlformats.org/presentationml/2006/main" xmlns:r="http://schemas.openxmlformats.org/officeDocument/2006/relationships">
+<p:sld xmlns:a="http://schemas.openxmlformats.org/drawingml/2006/main" xmlns:r="http://schemas.openxmlformats.org/officeDocument/2006/relationships" xmlns:p="http://schemas.openxmlformats.org/presentationml/2006/main">
   <p:cSld>
     <p:spTree>
       <p:nvGrpSpPr>
@@ -4522,7 +4335,735 @@
         <p:cNvGrpSpPr/>
         <p:nvPr/>
       </p:nvGrpSpPr>
-      <p:grpSpPr/>
+      <p:grpSpPr>
+        <a:xfrm>
+          <a:off x="0" y="0"/>
+          <a:ext cx="0" cy="0"/>
+          <a:chOff x="0" y="0"/>
+          <a:chExt cx="0" cy="0"/>
+        </a:xfrm>
+      </p:grpSpPr>
+      <p:sp>
+        <p:nvSpPr>
+          <p:cNvPr id="2" name="Rectangle 1"/>
+          <p:cNvSpPr/>
+          <p:nvPr/>
+        </p:nvSpPr>
+        <p:spPr>
+          <a:xfrm>
+            <a:off x="305" y="287079"/>
+            <a:ext cx="12191695" cy="6858000"/>
+          </a:xfrm>
+          <a:prstGeom prst="rect">
+            <a:avLst/>
+          </a:prstGeom>
+          <a:solidFill>
+            <a:srgbClr val="141413"/>
+          </a:solidFill>
+          <a:ln>
+            <a:noFill/>
+          </a:ln>
+          <a:effectLst/>
+        </p:spPr>
+        <p:style>
+          <a:lnRef idx="1">
+            <a:schemeClr val="accent1"/>
+          </a:lnRef>
+          <a:fillRef idx="3">
+            <a:schemeClr val="accent1"/>
+          </a:fillRef>
+          <a:effectRef idx="2">
+            <a:schemeClr val="accent1"/>
+          </a:effectRef>
+          <a:fontRef idx="minor">
+            <a:schemeClr val="lt1"/>
+          </a:fontRef>
+        </p:style>
+        <p:txBody>
+          <a:bodyPr rtlCol="0" anchor="ctr"/>
+          <a:lstStyle/>
+          <a:p>
+            <a:pPr algn="ctr"/>
+            <a:endParaRPr/>
+          </a:p>
+        </p:txBody>
+      </p:sp>
+      <p:sp>
+        <p:nvSpPr>
+          <p:cNvPr id="3" name="TextBox 2"/>
+          <p:cNvSpPr txBox="1"/>
+          <p:nvPr/>
+        </p:nvSpPr>
+        <p:spPr>
+          <a:xfrm>
+            <a:off x="323228" y="150982"/>
+            <a:ext cx="11000445" cy="1781385"/>
+          </a:xfrm>
+          <a:prstGeom prst="rect">
+            <a:avLst/>
+          </a:prstGeom>
+          <a:noFill/>
+        </p:spPr>
+        <p:txBody>
+          <a:bodyPr wrap="square" anchor="t">
+            <a:spAutoFit/>
+          </a:bodyPr>
+          <a:lstStyle/>
+          <a:p>
+            <a:pPr algn="l">
+              <a:lnSpc>
+                <a:spcPct val="105000"/>
+              </a:lnSpc>
+            </a:pPr>
+            <a:r>
+              <a:rPr sz="5400" b="1" i="0" dirty="0">
+                <a:solidFill>
+                  <a:srgbClr val="FFFFFF"/>
+                </a:solidFill>
+                <a:latin typeface="Fredoka"/>
+              </a:rPr>
+              <a:t>El </a:t>
+            </a:r>
+            <a:r>
+              <a:rPr sz="5400" b="1" i="0" dirty="0" err="1">
+                <a:solidFill>
+                  <a:srgbClr val="FFFFFF"/>
+                </a:solidFill>
+                <a:latin typeface="Fredoka"/>
+              </a:rPr>
+              <a:t>registro</a:t>
+            </a:r>
+            <a:r>
+              <a:rPr sz="5400" b="1" i="0" dirty="0">
+                <a:solidFill>
+                  <a:srgbClr val="FFFFFF"/>
+                </a:solidFill>
+                <a:latin typeface="Fredoka"/>
+              </a:rPr>
+              <a:t> le cuesta</a:t>
+            </a:r>
+            <a:r>
+              <a:rPr lang="en-US" sz="5400" b="1" i="0" dirty="0">
+                <a:solidFill>
+                  <a:srgbClr val="FFFFFF"/>
+                </a:solidFill>
+                <a:latin typeface="Fredoka"/>
+              </a:rPr>
+              <a:t> </a:t>
+            </a:r>
+            <a:r>
+              <a:rPr sz="5400" b="1" i="0" dirty="0">
+                <a:solidFill>
+                  <a:srgbClr val="FFFFFF"/>
+                </a:solidFill>
+                <a:latin typeface="Fredoka"/>
+              </a:rPr>
+              <a:t>la </a:t>
+            </a:r>
+            <a:r>
+              <a:rPr sz="5400" b="1" i="0" dirty="0" err="1">
+                <a:solidFill>
+                  <a:srgbClr val="FFFFFF"/>
+                </a:solidFill>
+                <a:latin typeface="Fredoka"/>
+              </a:rPr>
+              <a:t>siguiente</a:t>
+            </a:r>
+            <a:r>
+              <a:rPr sz="5400" b="1" i="0" dirty="0">
+                <a:solidFill>
+                  <a:srgbClr val="FFFFFF"/>
+                </a:solidFill>
+                <a:latin typeface="Fredoka"/>
+              </a:rPr>
+              <a:t> </a:t>
+            </a:r>
+            <a:r>
+              <a:rPr sz="5400" b="1" i="0" dirty="0" err="1">
+                <a:solidFill>
+                  <a:srgbClr val="FFFFFF"/>
+                </a:solidFill>
+                <a:latin typeface="Fredoka"/>
+              </a:rPr>
+              <a:t>venta</a:t>
+            </a:r>
+            <a:r>
+              <a:rPr sz="5400" b="1" i="0" dirty="0">
+                <a:solidFill>
+                  <a:srgbClr val="FFFFFF"/>
+                </a:solidFill>
+                <a:latin typeface="Fredoka"/>
+              </a:rPr>
+              <a:t>.</a:t>
+            </a:r>
+          </a:p>
+        </p:txBody>
+      </p:sp>
+      <p:sp>
+        <p:nvSpPr>
+          <p:cNvPr id="4" name="TextBox 3"/>
+          <p:cNvSpPr txBox="1"/>
+          <p:nvPr/>
+        </p:nvSpPr>
+        <p:spPr>
+          <a:xfrm>
+            <a:off x="868680" y="4937760"/>
+            <a:ext cx="7000000" cy="1097280"/>
+          </a:xfrm>
+          <a:prstGeom prst="rect">
+            <a:avLst/>
+          </a:prstGeom>
+          <a:noFill/>
+        </p:spPr>
+        <p:txBody>
+          <a:bodyPr wrap="square" anchor="t">
+            <a:spAutoFit/>
+          </a:bodyPr>
+          <a:lstStyle/>
+          <a:p>
+            <a:pPr algn="l">
+              <a:lnSpc>
+                <a:spcPct val="130000"/>
+              </a:lnSpc>
+            </a:pPr>
+            <a:r>
+              <a:rPr sz="1800" b="0" i="0" dirty="0" err="1">
+                <a:solidFill>
+                  <a:srgbClr val="C7C5C0"/>
+                </a:solidFill>
+                <a:latin typeface="Inter"/>
+              </a:rPr>
+              <a:t>Flujo</a:t>
+            </a:r>
+            <a:r>
+              <a:rPr sz="1800" b="0" i="0" dirty="0">
+                <a:solidFill>
+                  <a:srgbClr val="C7C5C0"/>
+                </a:solidFill>
+                <a:latin typeface="Inter"/>
+              </a:rPr>
+              <a:t> de </a:t>
+            </a:r>
+            <a:r>
+              <a:rPr sz="1800" b="0" i="0" dirty="0" err="1">
+                <a:solidFill>
+                  <a:srgbClr val="C7C5C0"/>
+                </a:solidFill>
+                <a:latin typeface="Inter"/>
+              </a:rPr>
+              <a:t>clientes</a:t>
+            </a:r>
+            <a:r>
+              <a:rPr sz="1800" b="0" i="0" dirty="0">
+                <a:solidFill>
+                  <a:srgbClr val="C7C5C0"/>
+                </a:solidFill>
+                <a:latin typeface="Inter"/>
+              </a:rPr>
+              <a:t> </a:t>
+            </a:r>
+            <a:r>
+              <a:rPr sz="1800" b="0" i="0" dirty="0" err="1">
+                <a:solidFill>
+                  <a:srgbClr val="C7C5C0"/>
+                </a:solidFill>
+                <a:latin typeface="Inter"/>
+              </a:rPr>
+              <a:t>impredecible</a:t>
+            </a:r>
+            <a:r>
+              <a:rPr sz="1800" b="0" i="0" dirty="0">
+                <a:solidFill>
+                  <a:srgbClr val="C7C5C0"/>
+                </a:solidFill>
+                <a:latin typeface="Inter"/>
+              </a:rPr>
+              <a:t>. Un </a:t>
+            </a:r>
+            <a:r>
+              <a:rPr sz="1800" b="0" i="0" dirty="0" err="1">
+                <a:solidFill>
+                  <a:srgbClr val="C7C5C0"/>
+                </a:solidFill>
+                <a:latin typeface="Inter"/>
+              </a:rPr>
+              <a:t>registro</a:t>
+            </a:r>
+            <a:r>
+              <a:rPr sz="1800" b="0" i="0" dirty="0">
+                <a:solidFill>
+                  <a:srgbClr val="C7C5C0"/>
+                </a:solidFill>
+                <a:latin typeface="Inter"/>
+              </a:rPr>
+              <a:t> de </a:t>
+            </a:r>
+            <a:r>
+              <a:rPr sz="1800" b="0" i="0" dirty="0" err="1">
+                <a:solidFill>
+                  <a:srgbClr val="C7C5C0"/>
+                </a:solidFill>
+                <a:latin typeface="Inter"/>
+              </a:rPr>
+              <a:t>más</a:t>
+            </a:r>
+            <a:r>
+              <a:rPr sz="1800" b="0" i="0" dirty="0">
+                <a:solidFill>
+                  <a:srgbClr val="C7C5C0"/>
+                </a:solidFill>
+                <a:latin typeface="Inter"/>
+              </a:rPr>
+              <a:t> de </a:t>
+            </a:r>
+            <a:r>
+              <a:rPr sz="1800" b="0" i="0" dirty="0" err="1">
+                <a:solidFill>
+                  <a:srgbClr val="C7C5C0"/>
+                </a:solidFill>
+                <a:latin typeface="Inter"/>
+              </a:rPr>
+              <a:t>unos</a:t>
+            </a:r>
+            <a:r>
+              <a:rPr sz="1800" b="0" i="0" dirty="0">
+                <a:solidFill>
+                  <a:srgbClr val="C7C5C0"/>
+                </a:solidFill>
+                <a:latin typeface="Inter"/>
+              </a:rPr>
+              <a:t> </a:t>
+            </a:r>
+            <a:r>
+              <a:rPr sz="1800" b="0" i="0" dirty="0" err="1">
+                <a:solidFill>
+                  <a:srgbClr val="C7C5C0"/>
+                </a:solidFill>
+                <a:latin typeface="Inter"/>
+              </a:rPr>
+              <a:t>segundos</a:t>
+            </a:r>
+            <a:r>
+              <a:rPr sz="1800" b="0" i="0" dirty="0">
+                <a:solidFill>
+                  <a:srgbClr val="C7C5C0"/>
+                </a:solidFill>
+                <a:latin typeface="Inter"/>
+              </a:rPr>
+              <a:t> </a:t>
+            </a:r>
+            <a:r>
+              <a:rPr sz="1800" b="0" i="0" dirty="0" err="1">
+                <a:solidFill>
+                  <a:srgbClr val="C7C5C0"/>
+                </a:solidFill>
+                <a:latin typeface="Inter"/>
+              </a:rPr>
+              <a:t>compite</a:t>
+            </a:r>
+            <a:r>
+              <a:rPr sz="1800" b="0" i="0" dirty="0">
+                <a:solidFill>
+                  <a:srgbClr val="C7C5C0"/>
+                </a:solidFill>
+                <a:latin typeface="Inter"/>
+              </a:rPr>
+              <a:t>
+</a:t>
+            </a:r>
+            <a:r>
+              <a:rPr sz="1800" b="0" i="0" dirty="0" err="1">
+                <a:solidFill>
+                  <a:srgbClr val="C7C5C0"/>
+                </a:solidFill>
+                <a:latin typeface="Inter"/>
+              </a:rPr>
+              <a:t>directamente</a:t>
+            </a:r>
+            <a:r>
+              <a:rPr sz="1800" b="0" i="0" dirty="0">
+                <a:solidFill>
+                  <a:srgbClr val="C7C5C0"/>
+                </a:solidFill>
+                <a:latin typeface="Inter"/>
+              </a:rPr>
+              <a:t> con </a:t>
+            </a:r>
+            <a:r>
+              <a:rPr sz="1800" b="0" i="0" dirty="0" err="1">
+                <a:solidFill>
+                  <a:srgbClr val="C7C5C0"/>
+                </a:solidFill>
+                <a:latin typeface="Inter"/>
+              </a:rPr>
+              <a:t>atender</a:t>
+            </a:r>
+            <a:r>
+              <a:rPr sz="1800" b="0" i="0" dirty="0">
+                <a:solidFill>
+                  <a:srgbClr val="C7C5C0"/>
+                </a:solidFill>
+                <a:latin typeface="Inter"/>
+              </a:rPr>
+              <a:t> a </a:t>
+            </a:r>
+            <a:r>
+              <a:rPr sz="1800" b="0" i="0" dirty="0" err="1">
+                <a:solidFill>
+                  <a:srgbClr val="C7C5C0"/>
+                </a:solidFill>
+                <a:latin typeface="Inter"/>
+              </a:rPr>
+              <a:t>quien</a:t>
+            </a:r>
+            <a:r>
+              <a:rPr sz="1800" b="0" i="0" dirty="0">
+                <a:solidFill>
+                  <a:srgbClr val="C7C5C0"/>
+                </a:solidFill>
+                <a:latin typeface="Inter"/>
+              </a:rPr>
+              <a:t> </a:t>
+            </a:r>
+            <a:r>
+              <a:rPr sz="1800" b="0" i="0" dirty="0" err="1">
+                <a:solidFill>
+                  <a:srgbClr val="C7C5C0"/>
+                </a:solidFill>
+                <a:latin typeface="Inter"/>
+              </a:rPr>
+              <a:t>llega</a:t>
+            </a:r>
+            <a:r>
+              <a:rPr sz="1800" b="0" i="0" dirty="0">
+                <a:solidFill>
+                  <a:srgbClr val="C7C5C0"/>
+                </a:solidFill>
+                <a:latin typeface="Inter"/>
+              </a:rPr>
+              <a:t> </a:t>
+            </a:r>
+            <a:r>
+              <a:rPr sz="1800" b="0" i="0" dirty="0" err="1">
+                <a:solidFill>
+                  <a:srgbClr val="C7C5C0"/>
+                </a:solidFill>
+                <a:latin typeface="Inter"/>
+              </a:rPr>
+              <a:t>después</a:t>
+            </a:r>
+            <a:r>
+              <a:rPr sz="1800" b="0" i="0" dirty="0">
+                <a:solidFill>
+                  <a:srgbClr val="C7C5C0"/>
+                </a:solidFill>
+                <a:latin typeface="Inter"/>
+              </a:rPr>
+              <a:t>, y </a:t>
+            </a:r>
+            <a:r>
+              <a:rPr sz="1800" b="0" i="0" dirty="0" err="1">
+                <a:solidFill>
+                  <a:srgbClr val="C7C5C0"/>
+                </a:solidFill>
+                <a:latin typeface="Inter"/>
+              </a:rPr>
+              <a:t>siempre</a:t>
+            </a:r>
+            <a:r>
+              <a:rPr sz="1800" b="0" i="0" dirty="0">
+                <a:solidFill>
+                  <a:srgbClr val="C7C5C0"/>
+                </a:solidFill>
+                <a:latin typeface="Inter"/>
+              </a:rPr>
+              <a:t> </a:t>
+            </a:r>
+            <a:r>
+              <a:rPr sz="1800" b="0" i="0" dirty="0" err="1">
+                <a:solidFill>
+                  <a:srgbClr val="C7C5C0"/>
+                </a:solidFill>
+                <a:latin typeface="Inter"/>
+              </a:rPr>
+              <a:t>gana</a:t>
+            </a:r>
+            <a:r>
+              <a:rPr sz="1800" b="0" i="0" dirty="0">
+                <a:solidFill>
+                  <a:srgbClr val="C7C5C0"/>
+                </a:solidFill>
+                <a:latin typeface="Inter"/>
+              </a:rPr>
+              <a:t> la </a:t>
+            </a:r>
+            <a:r>
+              <a:rPr sz="1800" b="0" i="0" dirty="0" err="1">
+                <a:solidFill>
+                  <a:srgbClr val="C7C5C0"/>
+                </a:solidFill>
+                <a:latin typeface="Inter"/>
+              </a:rPr>
+              <a:t>siguiente</a:t>
+            </a:r>
+            <a:r>
+              <a:rPr sz="1800" b="0" i="0" dirty="0">
+                <a:solidFill>
+                  <a:srgbClr val="C7C5C0"/>
+                </a:solidFill>
+                <a:latin typeface="Inter"/>
+              </a:rPr>
+              <a:t> </a:t>
+            </a:r>
+            <a:r>
+              <a:rPr sz="1800" b="0" i="0" dirty="0" err="1">
+                <a:solidFill>
+                  <a:srgbClr val="C7C5C0"/>
+                </a:solidFill>
+                <a:latin typeface="Inter"/>
+              </a:rPr>
+              <a:t>venta</a:t>
+            </a:r>
+            <a:r>
+              <a:rPr sz="1800" b="0" i="0" dirty="0">
+                <a:solidFill>
+                  <a:srgbClr val="C7C5C0"/>
+                </a:solidFill>
+                <a:latin typeface="Inter"/>
+              </a:rPr>
+              <a:t>.</a:t>
+            </a:r>
+          </a:p>
+        </p:txBody>
+      </p:sp>
+      <p:pic>
+        <p:nvPicPr>
+          <p:cNvPr id="6" name="Picture 5">
+            <a:extLst>
+              <a:ext uri="{FF2B5EF4-FFF2-40B4-BE49-F238E27FC236}">
+                <a16:creationId xmlns:a16="http://schemas.microsoft.com/office/drawing/2014/main" id="{37D2C8C3-08CA-DFEF-040E-1C32BCA44357}"/>
+              </a:ext>
+            </a:extLst>
+          </p:cNvPr>
+          <p:cNvPicPr>
+            <a:picLocks noChangeAspect="1"/>
+          </p:cNvPicPr>
+          <p:nvPr/>
+        </p:nvPicPr>
+        <p:blipFill>
+          <a:blip r:embed="rId3"/>
+          <a:stretch>
+            <a:fillRect/>
+          </a:stretch>
+        </p:blipFill>
+        <p:spPr>
+          <a:xfrm>
+            <a:off x="3216704" y="1060313"/>
+            <a:ext cx="8652068" cy="3590805"/>
+          </a:xfrm>
+          <a:prstGeom prst="rect">
+            <a:avLst/>
+          </a:prstGeom>
+        </p:spPr>
+      </p:pic>
+    </p:spTree>
+  </p:cSld>
+  <p:clrMapOvr>
+    <a:masterClrMapping/>
+  </p:clrMapOvr>
+</p:sld>
+</file>
+
+<file path=ppt/slides/slide3.xml><?xml version="1.0" encoding="utf-8"?>
+<p:sld xmlns:a="http://schemas.openxmlformats.org/drawingml/2006/main" xmlns:r="http://schemas.openxmlformats.org/officeDocument/2006/relationships" xmlns:p="http://schemas.openxmlformats.org/presentationml/2006/main">
+  <p:cSld>
+    <p:spTree>
+      <p:nvGrpSpPr>
+        <p:cNvPr id="1" name=""/>
+        <p:cNvGrpSpPr/>
+        <p:nvPr/>
+      </p:nvGrpSpPr>
+      <p:grpSpPr>
+        <a:xfrm>
+          <a:off x="0" y="0"/>
+          <a:ext cx="0" cy="0"/>
+          <a:chOff x="0" y="0"/>
+          <a:chExt cx="0" cy="0"/>
+        </a:xfrm>
+      </p:grpSpPr>
+      <p:sp>
+        <p:nvSpPr>
+          <p:cNvPr id="2" name="Rectangle 1"/>
+          <p:cNvSpPr/>
+          <p:nvPr/>
+        </p:nvSpPr>
+        <p:spPr>
+          <a:xfrm>
+            <a:off x="0" y="0"/>
+            <a:ext cx="12191695" cy="6858000"/>
+          </a:xfrm>
+          <a:prstGeom prst="rect">
+            <a:avLst/>
+          </a:prstGeom>
+          <a:solidFill>
+            <a:srgbClr val="FAF9F5"/>
+          </a:solidFill>
+          <a:ln>
+            <a:noFill/>
+          </a:ln>
+          <a:effectLst/>
+        </p:spPr>
+        <p:style>
+          <a:lnRef idx="1">
+            <a:schemeClr val="accent1"/>
+          </a:lnRef>
+          <a:fillRef idx="3">
+            <a:schemeClr val="accent1"/>
+          </a:fillRef>
+          <a:effectRef idx="2">
+            <a:schemeClr val="accent1"/>
+          </a:effectRef>
+          <a:fontRef idx="minor">
+            <a:schemeClr val="lt1"/>
+          </a:fontRef>
+        </p:style>
+        <p:txBody>
+          <a:bodyPr rtlCol="0" anchor="ctr"/>
+          <a:lstStyle/>
+          <a:p>
+            <a:pPr algn="ctr"/>
+            <a:endParaRPr/>
+          </a:p>
+        </p:txBody>
+      </p:sp>
+      <p:sp>
+        <p:nvSpPr>
+          <p:cNvPr id="3" name="TextBox 2"/>
+          <p:cNvSpPr txBox="1"/>
+          <p:nvPr/>
+        </p:nvSpPr>
+        <p:spPr>
+          <a:xfrm>
+            <a:off x="822960" y="1463040"/>
+            <a:ext cx="3931920" cy="2194560"/>
+          </a:xfrm>
+          <a:prstGeom prst="rect">
+            <a:avLst/>
+          </a:prstGeom>
+          <a:noFill/>
+        </p:spPr>
+        <p:txBody>
+          <a:bodyPr wrap="square" anchor="t">
+            <a:spAutoFit/>
+          </a:bodyPr>
+          <a:lstStyle/>
+          <a:p>
+            <a:pPr algn="l">
+              <a:lnSpc>
+                <a:spcPct val="105000"/>
+              </a:lnSpc>
+            </a:pPr>
+            <a:r>
+              <a:rPr sz="5200" b="1" i="0">
+                <a:solidFill>
+                  <a:srgbClr val="141413"/>
+                </a:solidFill>
+                <a:latin typeface="Fredoka"/>
+              </a:rPr>
+              <a:t>Así se ve
+hoy.</a:t>
+            </a:r>
+          </a:p>
+        </p:txBody>
+      </p:sp>
+      <p:sp>
+        <p:nvSpPr>
+          <p:cNvPr id="4" name="TextBox 3"/>
+          <p:cNvSpPr txBox="1"/>
+          <p:nvPr/>
+        </p:nvSpPr>
+        <p:spPr>
+          <a:xfrm>
+            <a:off x="868680" y="3383280"/>
+            <a:ext cx="3840480" cy="1097280"/>
+          </a:xfrm>
+          <a:prstGeom prst="rect">
+            <a:avLst/>
+          </a:prstGeom>
+          <a:noFill/>
+        </p:spPr>
+        <p:txBody>
+          <a:bodyPr wrap="square" anchor="t">
+            <a:spAutoFit/>
+          </a:bodyPr>
+          <a:lstStyle/>
+          <a:p>
+            <a:pPr algn="l">
+              <a:lnSpc>
+                <a:spcPct val="130000"/>
+              </a:lnSpc>
+            </a:pPr>
+            <a:r>
+              <a:rPr sz="1600" b="0" i="0">
+                <a:solidFill>
+                  <a:srgbClr val="6B6B67"/>
+                </a:solidFill>
+                <a:latin typeface="Inter"/>
+              </a:rPr>
+              <a:t>Prototipo real, funcional, probado con una vendedora real.</a:t>
+            </a:r>
+          </a:p>
+        </p:txBody>
+      </p:sp>
+      <p:pic>
+        <p:nvPicPr>
+          <p:cNvPr id="5" name="Picture 4" descr="slide-home.png"/>
+          <p:cNvPicPr>
+            <a:picLocks noChangeAspect="1"/>
+          </p:cNvPicPr>
+          <p:nvPr/>
+        </p:nvPicPr>
+        <p:blipFill>
+          <a:blip r:embed="rId3"/>
+          <a:stretch>
+            <a:fillRect/>
+          </a:stretch>
+        </p:blipFill>
+        <p:spPr>
+          <a:xfrm>
+            <a:off x="6126480" y="548640"/>
+            <a:ext cx="4360984" cy="5669280"/>
+          </a:xfrm>
+          <a:prstGeom prst="rect">
+            <a:avLst/>
+          </a:prstGeom>
+        </p:spPr>
+      </p:pic>
+    </p:spTree>
+  </p:cSld>
+  <p:clrMapOvr>
+    <a:masterClrMapping/>
+  </p:clrMapOvr>
+</p:sld>
+</file>
+
+<file path=ppt/slides/slide4.xml><?xml version="1.0" encoding="utf-8"?>
+<p:sld xmlns:a="http://schemas.openxmlformats.org/drawingml/2006/main" xmlns:r="http://schemas.openxmlformats.org/officeDocument/2006/relationships" xmlns:p="http://schemas.openxmlformats.org/presentationml/2006/main">
+  <p:cSld>
+    <p:spTree>
+      <p:nvGrpSpPr>
+        <p:cNvPr id="1" name=""/>
+        <p:cNvGrpSpPr/>
+        <p:nvPr/>
+      </p:nvGrpSpPr>
+      <p:grpSpPr>
+        <a:xfrm>
+          <a:off x="0" y="0"/>
+          <a:ext cx="0" cy="0"/>
+          <a:chOff x="0" y="0"/>
+          <a:chExt cx="0" cy="0"/>
+        </a:xfrm>
+      </p:grpSpPr>
       <p:sp>
         <p:nvSpPr>
           <p:cNvPr id="2" name="Rectangle 1"/>
@@ -4564,6 +5105,7 @@
           <a:lstStyle/>
           <a:p>
             <a:pPr algn="ctr"/>
+            <a:endParaRPr/>
           </a:p>
         </p:txBody>
       </p:sp>
@@ -4575,8 +5117,8 @@
         </p:nvSpPr>
         <p:spPr>
           <a:xfrm>
-            <a:off x="822960" y="1554480"/>
-            <a:ext cx="7315200" cy="2926080"/>
+            <a:off x="6126480" y="1463040"/>
+            <a:ext cx="3931920" cy="2194560"/>
           </a:xfrm>
           <a:prstGeom prst="rect">
             <a:avLst/>
@@ -4595,14 +5137,14 @@
               </a:lnSpc>
             </a:pPr>
             <a:r>
-              <a:rPr sz="6400" b="1" i="0">
+              <a:rPr sz="5200" b="1" i="0">
                 <a:solidFill>
                   <a:srgbClr val="FFFFFF"/>
                 </a:solidFill>
                 <a:latin typeface="Fredoka"/>
               </a:rPr>
-              <a:t>El registro le cuesta
-la siguiente venta.</a:t>
+              <a:t>Menos de
+3 segundos.</a:t>
             </a:r>
           </a:p>
         </p:txBody>
@@ -4615,8 +5157,8 @@
         </p:nvSpPr>
         <p:spPr>
           <a:xfrm>
-            <a:off x="868680" y="4937760"/>
-            <a:ext cx="7000000" cy="1097280"/>
+            <a:off x="6172200" y="3383280"/>
+            <a:ext cx="3840480" cy="1280160"/>
           </a:xfrm>
           <a:prstGeom prst="rect">
             <a:avLst/>
@@ -4635,36 +5177,35 @@
               </a:lnSpc>
             </a:pPr>
             <a:r>
-              <a:rPr sz="1800" b="0" i="0">
+              <a:rPr sz="1600" b="0" i="0">
                 <a:solidFill>
                   <a:srgbClr val="C7C5C0"/>
                 </a:solidFill>
                 <a:latin typeface="Inter"/>
               </a:rPr>
-              <a:t>Flujo de clientes impredecible. Un registro de más de unos segundos compite
-directamente con atender a quien llega después, y siempre gana la siguiente venta.</a:t>
+              <a:t>Un toque por producto. El total se arma solo, en el momento exacto de la venta.</a:t>
             </a:r>
           </a:p>
         </p:txBody>
       </p:sp>
       <p:pic>
         <p:nvPicPr>
-          <p:cNvPr id="5" name="Picture 4" descr="image.png"/>
+          <p:cNvPr id="5" name="Picture 4" descr="slide-selling.png"/>
           <p:cNvPicPr>
             <a:picLocks noChangeAspect="1"/>
           </p:cNvPicPr>
           <p:nvPr/>
         </p:nvPicPr>
         <p:blipFill>
-          <a:blip r:embed="rId2"/>
+          <a:blip r:embed="rId3"/>
           <a:stretch>
             <a:fillRect/>
           </a:stretch>
         </p:blipFill>
         <p:spPr>
           <a:xfrm>
-            <a:off x="7894015" y="2203420"/>
-            <a:ext cx="3474720" cy="2451159"/>
+            <a:off x="822960" y="548640"/>
+            <a:ext cx="4220064" cy="5669280"/>
           </a:xfrm>
           <a:prstGeom prst="rect">
             <a:avLst/>
@@ -4679,8 +5220,8 @@
 </p:sld>
 </file>
 
-<file path=ppt/slides/slide3.xml><?xml version="1.0" encoding="utf-8"?>
-<p:sld xmlns:a="http://schemas.openxmlformats.org/drawingml/2006/main" xmlns:p="http://schemas.openxmlformats.org/presentationml/2006/main" xmlns:r="http://schemas.openxmlformats.org/officeDocument/2006/relationships">
+<file path=ppt/slides/slide5.xml><?xml version="1.0" encoding="utf-8"?>
+<p:sld xmlns:a="http://schemas.openxmlformats.org/drawingml/2006/main" xmlns:r="http://schemas.openxmlformats.org/officeDocument/2006/relationships" xmlns:p="http://schemas.openxmlformats.org/presentationml/2006/main">
   <p:cSld>
     <p:spTree>
       <p:nvGrpSpPr>
@@ -4688,7 +5229,14 @@
         <p:cNvGrpSpPr/>
         <p:nvPr/>
       </p:nvGrpSpPr>
-      <p:grpSpPr/>
+      <p:grpSpPr>
+        <a:xfrm>
+          <a:off x="0" y="0"/>
+          <a:ext cx="0" cy="0"/>
+          <a:chOff x="0" y="0"/>
+          <a:chExt cx="0" cy="0"/>
+        </a:xfrm>
+      </p:grpSpPr>
       <p:sp>
         <p:nvSpPr>
           <p:cNvPr id="2" name="Rectangle 1"/>
@@ -4730,6 +5278,7 @@
           <a:lstStyle/>
           <a:p>
             <a:pPr algn="ctr"/>
+            <a:endParaRPr/>
           </a:p>
         </p:txBody>
       </p:sp>
@@ -4741,7 +5290,7 @@
         </p:nvSpPr>
         <p:spPr>
           <a:xfrm>
-            <a:off x="822960" y="1463040"/>
+            <a:off x="7300000" y="1463040"/>
             <a:ext cx="3931920" cy="2194560"/>
           </a:xfrm>
           <a:prstGeom prst="rect">
@@ -4767,8 +5316,8 @@
                 </a:solidFill>
                 <a:latin typeface="Fredoka"/>
               </a:rPr>
-              <a:t>Así se ve
-hoy.</a:t>
+              <a:t>Y queda
+guardada.</a:t>
             </a:r>
           </a:p>
         </p:txBody>
@@ -4781,8 +5330,8 @@
         </p:nvSpPr>
         <p:spPr>
           <a:xfrm>
-            <a:off x="868680" y="3383280"/>
-            <a:ext cx="3840480" cy="1097280"/>
+            <a:off x="7345720" y="3383280"/>
+            <a:ext cx="3840480" cy="1280160"/>
           </a:xfrm>
           <a:prstGeom prst="rect">
             <a:avLst/>
@@ -4807,29 +5356,29 @@
                 </a:solidFill>
                 <a:latin typeface="Inter"/>
               </a:rPr>
-              <a:t>Prototipo real, funcional, probado con una vendedora real.</a:t>
+              <a:t>Nunca más se pierde el registro de una venta, aunque llegue el siguiente cliente sin avisar.</a:t>
             </a:r>
           </a:p>
         </p:txBody>
       </p:sp>
       <p:pic>
         <p:nvPicPr>
-          <p:cNvPr id="5" name="Picture 4" descr="slide-home.png"/>
+          <p:cNvPr id="5" name="Picture 4" descr="slide-receipt.png"/>
           <p:cNvPicPr>
             <a:picLocks noChangeAspect="1"/>
           </p:cNvPicPr>
           <p:nvPr/>
         </p:nvPicPr>
         <p:blipFill>
-          <a:blip r:embed="rId2"/>
+          <a:blip r:embed="rId3"/>
           <a:stretch>
             <a:fillRect/>
           </a:stretch>
         </p:blipFill>
         <p:spPr>
           <a:xfrm>
-            <a:off x="6126480" y="548640"/>
-            <a:ext cx="4360984" cy="5669280"/>
+            <a:off x="822960" y="548640"/>
+            <a:ext cx="6229447" cy="5669280"/>
           </a:xfrm>
           <a:prstGeom prst="rect">
             <a:avLst/>
@@ -4844,8 +5393,8 @@
 </p:sld>
 </file>
 
-<file path=ppt/slides/slide4.xml><?xml version="1.0" encoding="utf-8"?>
-<p:sld xmlns:a="http://schemas.openxmlformats.org/drawingml/2006/main" xmlns:p="http://schemas.openxmlformats.org/presentationml/2006/main" xmlns:r="http://schemas.openxmlformats.org/officeDocument/2006/relationships">
+<file path=ppt/slides/slide6.xml><?xml version="1.0" encoding="utf-8"?>
+<p:sld xmlns:a="http://schemas.openxmlformats.org/drawingml/2006/main" xmlns:r="http://schemas.openxmlformats.org/officeDocument/2006/relationships" xmlns:p="http://schemas.openxmlformats.org/presentationml/2006/main">
   <p:cSld>
     <p:spTree>
       <p:nvGrpSpPr>
@@ -4853,7 +5402,14 @@
         <p:cNvGrpSpPr/>
         <p:nvPr/>
       </p:nvGrpSpPr>
-      <p:grpSpPr/>
+      <p:grpSpPr>
+        <a:xfrm>
+          <a:off x="0" y="0"/>
+          <a:ext cx="0" cy="0"/>
+          <a:chOff x="0" y="0"/>
+          <a:chExt cx="0" cy="0"/>
+        </a:xfrm>
+      </p:grpSpPr>
       <p:sp>
         <p:nvSpPr>
           <p:cNvPr id="2" name="Rectangle 1"/>
@@ -4869,7 +5425,7 @@
             <a:avLst/>
           </a:prstGeom>
           <a:solidFill>
-            <a:srgbClr val="141413"/>
+            <a:srgbClr val="C13F26"/>
           </a:solidFill>
           <a:ln>
             <a:noFill/>
@@ -4895,6 +5451,7 @@
           <a:lstStyle/>
           <a:p>
             <a:pPr algn="ctr"/>
+            <a:endParaRPr/>
           </a:p>
         </p:txBody>
       </p:sp>
@@ -4906,8 +5463,8 @@
         </p:nvSpPr>
         <p:spPr>
           <a:xfrm>
-            <a:off x="6126480" y="1463040"/>
-            <a:ext cx="3931920" cy="2194560"/>
+            <a:off x="822960" y="685800"/>
+            <a:ext cx="3474720" cy="1645920"/>
           </a:xfrm>
           <a:prstGeom prst="rect">
             <a:avLst/>
@@ -4922,18 +5479,17 @@
           <a:p>
             <a:pPr algn="l">
               <a:lnSpc>
-                <a:spcPct val="105000"/>
+                <a:spcPct val="100000"/>
               </a:lnSpc>
             </a:pPr>
             <a:r>
-              <a:rPr sz="5200" b="1" i="0">
+              <a:rPr sz="9000" b="1" i="0">
                 <a:solidFill>
                   <a:srgbClr val="FFFFFF"/>
                 </a:solidFill>
                 <a:latin typeface="Fredoka"/>
               </a:rPr>
-              <a:t>Menos de
-3 segundos.</a:t>
+              <a:t>583</a:t>
             </a:r>
           </a:p>
         </p:txBody>
@@ -4946,8 +5502,8 @@
         </p:nvSpPr>
         <p:spPr>
           <a:xfrm>
-            <a:off x="6172200" y="3383280"/>
-            <a:ext cx="3840480" cy="1280160"/>
+            <a:off x="868680" y="2286000"/>
+            <a:ext cx="3474720" cy="548640"/>
           </a:xfrm>
           <a:prstGeom prst="rect">
             <a:avLst/>
@@ -4962,39 +5518,258 @@
           <a:p>
             <a:pPr algn="l">
               <a:lnSpc>
-                <a:spcPct val="130000"/>
+                <a:spcPct val="100000"/>
               </a:lnSpc>
             </a:pPr>
             <a:r>
-              <a:rPr sz="1600" b="0" i="0">
-                <a:solidFill>
-                  <a:srgbClr val="C7C5C0"/>
+              <a:rPr sz="1800" b="0" i="0">
+                <a:solidFill>
+                  <a:srgbClr val="F3D9D1"/>
                 </a:solidFill>
                 <a:latin typeface="Inter"/>
               </a:rPr>
-              <a:t>Un toque por producto. El total se arma solo, en el momento exacto de la venta.</a:t>
+              <a:t>visitantes reales</a:t>
+            </a:r>
+          </a:p>
+        </p:txBody>
+      </p:sp>
+      <p:sp>
+        <p:nvSpPr>
+          <p:cNvPr id="5" name="TextBox 4"/>
+          <p:cNvSpPr txBox="1"/>
+          <p:nvPr/>
+        </p:nvSpPr>
+        <p:spPr>
+          <a:xfrm>
+            <a:off x="4480560" y="685800"/>
+            <a:ext cx="3474720" cy="1645920"/>
+          </a:xfrm>
+          <a:prstGeom prst="rect">
+            <a:avLst/>
+          </a:prstGeom>
+          <a:noFill/>
+        </p:spPr>
+        <p:txBody>
+          <a:bodyPr wrap="square" anchor="t">
+            <a:spAutoFit/>
+          </a:bodyPr>
+          <a:lstStyle/>
+          <a:p>
+            <a:pPr algn="l">
+              <a:lnSpc>
+                <a:spcPct val="100000"/>
+              </a:lnSpc>
+            </a:pPr>
+            <a:r>
+              <a:rPr sz="6400" b="1" i="0">
+                <a:solidFill>
+                  <a:srgbClr val="FFFFFF"/>
+                </a:solidFill>
+                <a:latin typeface="Fredoka"/>
+              </a:rPr>
+              <a:t>2 / 583</a:t>
+            </a:r>
+          </a:p>
+        </p:txBody>
+      </p:sp>
+      <p:sp>
+        <p:nvSpPr>
+          <p:cNvPr id="6" name="TextBox 5"/>
+          <p:cNvSpPr txBox="1"/>
+          <p:nvPr/>
+        </p:nvSpPr>
+        <p:spPr>
+          <a:xfrm>
+            <a:off x="4526280" y="2286000"/>
+            <a:ext cx="3474720" cy="548640"/>
+          </a:xfrm>
+          <a:prstGeom prst="rect">
+            <a:avLst/>
+          </a:prstGeom>
+          <a:noFill/>
+        </p:spPr>
+        <p:txBody>
+          <a:bodyPr wrap="square" anchor="t">
+            <a:spAutoFit/>
+          </a:bodyPr>
+          <a:lstStyle/>
+          <a:p>
+            <a:pPr algn="l">
+              <a:lnSpc>
+                <a:spcPct val="100000"/>
+              </a:lnSpc>
+            </a:pPr>
+            <a:r>
+              <a:rPr sz="1800" b="0" i="0">
+                <a:solidFill>
+                  <a:srgbClr val="F3D9D1"/>
+                </a:solidFill>
+                <a:latin typeface="Inter"/>
+              </a:rPr>
+              <a:t>probaron el demo</a:t>
+            </a:r>
+          </a:p>
+        </p:txBody>
+      </p:sp>
+      <p:sp>
+        <p:nvSpPr>
+          <p:cNvPr id="7" name="TextBox 6"/>
+          <p:cNvSpPr txBox="1"/>
+          <p:nvPr/>
+        </p:nvSpPr>
+        <p:spPr>
+          <a:xfrm>
+            <a:off x="8138160" y="685800"/>
+            <a:ext cx="3474720" cy="1645920"/>
+          </a:xfrm>
+          <a:prstGeom prst="rect">
+            <a:avLst/>
+          </a:prstGeom>
+          <a:noFill/>
+        </p:spPr>
+        <p:txBody>
+          <a:bodyPr wrap="square" anchor="t">
+            <a:spAutoFit/>
+          </a:bodyPr>
+          <a:lstStyle/>
+          <a:p>
+            <a:pPr algn="l">
+              <a:lnSpc>
+                <a:spcPct val="100000"/>
+              </a:lnSpc>
+            </a:pPr>
+            <a:r>
+              <a:rPr sz="9000" b="1" i="0">
+                <a:solidFill>
+                  <a:srgbClr val="FFFFFF"/>
+                </a:solidFill>
+                <a:latin typeface="Fredoka"/>
+              </a:rPr>
+              <a:t>0.34%</a:t>
+            </a:r>
+          </a:p>
+        </p:txBody>
+      </p:sp>
+      <p:sp>
+        <p:nvSpPr>
+          <p:cNvPr id="8" name="TextBox 7"/>
+          <p:cNvSpPr txBox="1"/>
+          <p:nvPr/>
+        </p:nvSpPr>
+        <p:spPr>
+          <a:xfrm>
+            <a:off x="8183879" y="2286000"/>
+            <a:ext cx="3474720" cy="548640"/>
+          </a:xfrm>
+          <a:prstGeom prst="rect">
+            <a:avLst/>
+          </a:prstGeom>
+          <a:noFill/>
+        </p:spPr>
+        <p:txBody>
+          <a:bodyPr wrap="square" anchor="t">
+            <a:spAutoFit/>
+          </a:bodyPr>
+          <a:lstStyle/>
+          <a:p>
+            <a:pPr algn="l">
+              <a:lnSpc>
+                <a:spcPct val="100000"/>
+              </a:lnSpc>
+            </a:pPr>
+            <a:r>
+              <a:rPr sz="1800" b="0" i="0">
+                <a:solidFill>
+                  <a:srgbClr val="F3D9D1"/>
+                </a:solidFill>
+                <a:latin typeface="Inter"/>
+              </a:rPr>
+              <a:t>de conversión real</a:t>
+            </a:r>
+          </a:p>
+        </p:txBody>
+      </p:sp>
+      <p:sp>
+        <p:nvSpPr>
+          <p:cNvPr id="9" name="TextBox 8"/>
+          <p:cNvSpPr txBox="1"/>
+          <p:nvPr/>
+        </p:nvSpPr>
+        <p:spPr>
+          <a:xfrm>
+            <a:off x="868680" y="5250000"/>
+            <a:ext cx="9601200" cy="1097280"/>
+          </a:xfrm>
+          <a:prstGeom prst="rect">
+            <a:avLst/>
+          </a:prstGeom>
+          <a:noFill/>
+        </p:spPr>
+        <p:txBody>
+          <a:bodyPr wrap="square" anchor="t">
+            <a:spAutoFit/>
+          </a:bodyPr>
+          <a:lstStyle/>
+          <a:p>
+            <a:pPr algn="l">
+              <a:lnSpc>
+                <a:spcPct val="120000"/>
+              </a:lnSpc>
+            </a:pPr>
+            <a:r>
+              <a:rPr sz="2200" b="1" i="0">
+                <a:solidFill>
+                  <a:srgbClr val="FFFFFF"/>
+                </a:solidFill>
+                <a:latin typeface="Fredoka"/>
+              </a:rPr>
+              <a:t>El alcance funciona. La adopción real todavía no, y no lo descubrí el día 1, sino a mitad de campaña.</a:t>
             </a:r>
           </a:p>
         </p:txBody>
       </p:sp>
       <p:pic>
         <p:nvPicPr>
-          <p:cNvPr id="5" name="Picture 4" descr="slide-selling.png"/>
+          <p:cNvPr id="10" name="Picture 9" descr="vercel1-chart.png"/>
           <p:cNvPicPr>
             <a:picLocks noChangeAspect="1"/>
           </p:cNvPicPr>
           <p:nvPr/>
         </p:nvPicPr>
         <p:blipFill>
-          <a:blip r:embed="rId2"/>
+          <a:blip r:embed="rId3"/>
           <a:stretch>
             <a:fillRect/>
           </a:stretch>
         </p:blipFill>
         <p:spPr>
           <a:xfrm>
-            <a:off x="822960" y="548640"/>
-            <a:ext cx="4220064" cy="5669280"/>
+            <a:off x="1093960" y="3000000"/>
+            <a:ext cx="5040588" cy="2050000"/>
+          </a:xfrm>
+          <a:prstGeom prst="rect">
+            <a:avLst/>
+          </a:prstGeom>
+        </p:spPr>
+      </p:pic>
+      <p:pic>
+        <p:nvPicPr>
+          <p:cNvPr id="11" name="Picture 10" descr="vercel2-events.png"/>
+          <p:cNvPicPr>
+            <a:picLocks noChangeAspect="1"/>
+          </p:cNvPicPr>
+          <p:nvPr/>
+        </p:nvPicPr>
+        <p:blipFill>
+          <a:blip r:embed="rId4"/>
+          <a:stretch>
+            <a:fillRect/>
+          </a:stretch>
+        </p:blipFill>
+        <p:spPr>
+          <a:xfrm>
+            <a:off x="6434548" y="3000000"/>
+            <a:ext cx="4663186" cy="2050000"/>
           </a:xfrm>
           <a:prstGeom prst="rect">
             <a:avLst/>
@@ -5009,8 +5784,8 @@
 </p:sld>
 </file>
 
-<file path=ppt/slides/slide5.xml><?xml version="1.0" encoding="utf-8"?>
-<p:sld xmlns:a="http://schemas.openxmlformats.org/drawingml/2006/main" xmlns:p="http://schemas.openxmlformats.org/presentationml/2006/main" xmlns:r="http://schemas.openxmlformats.org/officeDocument/2006/relationships">
+<file path=ppt/slides/slide7.xml><?xml version="1.0" encoding="utf-8"?>
+<p:sld xmlns:a="http://schemas.openxmlformats.org/drawingml/2006/main" xmlns:r="http://schemas.openxmlformats.org/officeDocument/2006/relationships" xmlns:p="http://schemas.openxmlformats.org/presentationml/2006/main">
   <p:cSld>
     <p:spTree>
       <p:nvGrpSpPr>
@@ -5018,7 +5793,14 @@
         <p:cNvGrpSpPr/>
         <p:nvPr/>
       </p:nvGrpSpPr>
-      <p:grpSpPr/>
+      <p:grpSpPr>
+        <a:xfrm>
+          <a:off x="0" y="0"/>
+          <a:ext cx="0" cy="0"/>
+          <a:chOff x="0" y="0"/>
+          <a:chExt cx="0" cy="0"/>
+        </a:xfrm>
+      </p:grpSpPr>
       <p:sp>
         <p:nvSpPr>
           <p:cNvPr id="2" name="Rectangle 1"/>
@@ -5060,554 +5842,7 @@
           <a:lstStyle/>
           <a:p>
             <a:pPr algn="ctr"/>
-          </a:p>
-        </p:txBody>
-      </p:sp>
-      <p:sp>
-        <p:nvSpPr>
-          <p:cNvPr id="3" name="TextBox 2"/>
-          <p:cNvSpPr txBox="1"/>
-          <p:nvPr/>
-        </p:nvSpPr>
-        <p:spPr>
-          <a:xfrm>
-            <a:off x="7300000" y="1463040"/>
-            <a:ext cx="3931920" cy="2194560"/>
-          </a:xfrm>
-          <a:prstGeom prst="rect">
-            <a:avLst/>
-          </a:prstGeom>
-          <a:noFill/>
-        </p:spPr>
-        <p:txBody>
-          <a:bodyPr wrap="square" anchor="t">
-            <a:spAutoFit/>
-          </a:bodyPr>
-          <a:lstStyle/>
-          <a:p>
-            <a:pPr algn="l">
-              <a:lnSpc>
-                <a:spcPct val="105000"/>
-              </a:lnSpc>
-            </a:pPr>
-            <a:r>
-              <a:rPr sz="5200" b="1" i="0">
-                <a:solidFill>
-                  <a:srgbClr val="141413"/>
-                </a:solidFill>
-                <a:latin typeface="Fredoka"/>
-              </a:rPr>
-              <a:t>Y queda
-guardada.</a:t>
-            </a:r>
-          </a:p>
-        </p:txBody>
-      </p:sp>
-      <p:sp>
-        <p:nvSpPr>
-          <p:cNvPr id="4" name="TextBox 3"/>
-          <p:cNvSpPr txBox="1"/>
-          <p:nvPr/>
-        </p:nvSpPr>
-        <p:spPr>
-          <a:xfrm>
-            <a:off x="7345720" y="3383280"/>
-            <a:ext cx="3840480" cy="1280160"/>
-          </a:xfrm>
-          <a:prstGeom prst="rect">
-            <a:avLst/>
-          </a:prstGeom>
-          <a:noFill/>
-        </p:spPr>
-        <p:txBody>
-          <a:bodyPr wrap="square" anchor="t">
-            <a:spAutoFit/>
-          </a:bodyPr>
-          <a:lstStyle/>
-          <a:p>
-            <a:pPr algn="l">
-              <a:lnSpc>
-                <a:spcPct val="130000"/>
-              </a:lnSpc>
-            </a:pPr>
-            <a:r>
-              <a:rPr sz="1600" b="0" i="0">
-                <a:solidFill>
-                  <a:srgbClr val="6B6B67"/>
-                </a:solidFill>
-                <a:latin typeface="Inter"/>
-              </a:rPr>
-              <a:t>Nunca más se pierde el registro de una venta, aunque llegue el siguiente cliente sin avisar.</a:t>
-            </a:r>
-          </a:p>
-        </p:txBody>
-      </p:sp>
-      <p:pic>
-        <p:nvPicPr>
-          <p:cNvPr id="5" name="Picture 4" descr="slide-receipt.png"/>
-          <p:cNvPicPr>
-            <a:picLocks noChangeAspect="1"/>
-          </p:cNvPicPr>
-          <p:nvPr/>
-        </p:nvPicPr>
-        <p:blipFill>
-          <a:blip r:embed="rId2"/>
-          <a:stretch>
-            <a:fillRect/>
-          </a:stretch>
-        </p:blipFill>
-        <p:spPr>
-          <a:xfrm>
-            <a:off x="822960" y="548640"/>
-            <a:ext cx="6229447" cy="5669280"/>
-          </a:xfrm>
-          <a:prstGeom prst="rect">
-            <a:avLst/>
-          </a:prstGeom>
-        </p:spPr>
-      </p:pic>
-    </p:spTree>
-  </p:cSld>
-  <p:clrMapOvr>
-    <a:masterClrMapping/>
-  </p:clrMapOvr>
-</p:sld>
-</file>
-
-<file path=ppt/slides/slide6.xml><?xml version="1.0" encoding="utf-8"?>
-<p:sld xmlns:a="http://schemas.openxmlformats.org/drawingml/2006/main" xmlns:p="http://schemas.openxmlformats.org/presentationml/2006/main" xmlns:r="http://schemas.openxmlformats.org/officeDocument/2006/relationships">
-  <p:cSld>
-    <p:spTree>
-      <p:nvGrpSpPr>
-        <p:cNvPr id="1" name=""/>
-        <p:cNvGrpSpPr/>
-        <p:nvPr/>
-      </p:nvGrpSpPr>
-      <p:grpSpPr/>
-      <p:sp>
-        <p:nvSpPr>
-          <p:cNvPr id="2" name="Rectangle 1"/>
-          <p:cNvSpPr/>
-          <p:nvPr/>
-        </p:nvSpPr>
-        <p:spPr>
-          <a:xfrm>
-            <a:off x="0" y="0"/>
-            <a:ext cx="12191695" cy="6858000"/>
-          </a:xfrm>
-          <a:prstGeom prst="rect">
-            <a:avLst/>
-          </a:prstGeom>
-          <a:solidFill>
-            <a:srgbClr val="C13F26"/>
-          </a:solidFill>
-          <a:ln>
-            <a:noFill/>
-          </a:ln>
-          <a:effectLst/>
-        </p:spPr>
-        <p:style>
-          <a:lnRef idx="1">
-            <a:schemeClr val="accent1"/>
-          </a:lnRef>
-          <a:fillRef idx="3">
-            <a:schemeClr val="accent1"/>
-          </a:fillRef>
-          <a:effectRef idx="2">
-            <a:schemeClr val="accent1"/>
-          </a:effectRef>
-          <a:fontRef idx="minor">
-            <a:schemeClr val="lt1"/>
-          </a:fontRef>
-        </p:style>
-        <p:txBody>
-          <a:bodyPr rtlCol="0" anchor="ctr"/>
-          <a:lstStyle/>
-          <a:p>
-            <a:pPr algn="ctr"/>
-          </a:p>
-        </p:txBody>
-      </p:sp>
-      <p:sp>
-        <p:nvSpPr>
-          <p:cNvPr id="3" name="TextBox 2"/>
-          <p:cNvSpPr txBox="1"/>
-          <p:nvPr/>
-        </p:nvSpPr>
-        <p:spPr>
-          <a:xfrm>
-            <a:off x="822960" y="685800"/>
-            <a:ext cx="3474720" cy="1645920"/>
-          </a:xfrm>
-          <a:prstGeom prst="rect">
-            <a:avLst/>
-          </a:prstGeom>
-          <a:noFill/>
-        </p:spPr>
-        <p:txBody>
-          <a:bodyPr wrap="square" anchor="t">
-            <a:spAutoFit/>
-          </a:bodyPr>
-          <a:lstStyle/>
-          <a:p>
-            <a:pPr algn="l">
-              <a:lnSpc>
-                <a:spcPct val="100000"/>
-              </a:lnSpc>
-            </a:pPr>
-            <a:r>
-              <a:rPr sz="9000" b="1" i="0">
-                <a:solidFill>
-                  <a:srgbClr val="FFFFFF"/>
-                </a:solidFill>
-                <a:latin typeface="Fredoka"/>
-              </a:rPr>
-              <a:t>583</a:t>
-            </a:r>
-          </a:p>
-        </p:txBody>
-      </p:sp>
-      <p:sp>
-        <p:nvSpPr>
-          <p:cNvPr id="4" name="TextBox 3"/>
-          <p:cNvSpPr txBox="1"/>
-          <p:nvPr/>
-        </p:nvSpPr>
-        <p:spPr>
-          <a:xfrm>
-            <a:off x="868680" y="2286000"/>
-            <a:ext cx="3474720" cy="548640"/>
-          </a:xfrm>
-          <a:prstGeom prst="rect">
-            <a:avLst/>
-          </a:prstGeom>
-          <a:noFill/>
-        </p:spPr>
-        <p:txBody>
-          <a:bodyPr wrap="square" anchor="t">
-            <a:spAutoFit/>
-          </a:bodyPr>
-          <a:lstStyle/>
-          <a:p>
-            <a:pPr algn="l">
-              <a:lnSpc>
-                <a:spcPct val="100000"/>
-              </a:lnSpc>
-            </a:pPr>
-            <a:r>
-              <a:rPr sz="1800" b="0" i="0">
-                <a:solidFill>
-                  <a:srgbClr val="F3D9D1"/>
-                </a:solidFill>
-                <a:latin typeface="Inter"/>
-              </a:rPr>
-              <a:t>visitantes reales</a:t>
-            </a:r>
-          </a:p>
-        </p:txBody>
-      </p:sp>
-      <p:sp>
-        <p:nvSpPr>
-          <p:cNvPr id="5" name="TextBox 4"/>
-          <p:cNvSpPr txBox="1"/>
-          <p:nvPr/>
-        </p:nvSpPr>
-        <p:spPr>
-          <a:xfrm>
-            <a:off x="4480560" y="685800"/>
-            <a:ext cx="3474720" cy="1645920"/>
-          </a:xfrm>
-          <a:prstGeom prst="rect">
-            <a:avLst/>
-          </a:prstGeom>
-          <a:noFill/>
-        </p:spPr>
-        <p:txBody>
-          <a:bodyPr wrap="square" anchor="t">
-            <a:spAutoFit/>
-          </a:bodyPr>
-          <a:lstStyle/>
-          <a:p>
-            <a:pPr algn="l">
-              <a:lnSpc>
-                <a:spcPct val="100000"/>
-              </a:lnSpc>
-            </a:pPr>
-            <a:r>
-              <a:rPr sz="6400" b="1" i="0">
-                <a:solidFill>
-                  <a:srgbClr val="FFFFFF"/>
-                </a:solidFill>
-                <a:latin typeface="Fredoka"/>
-              </a:rPr>
-              <a:t>2 / 583</a:t>
-            </a:r>
-          </a:p>
-        </p:txBody>
-      </p:sp>
-      <p:sp>
-        <p:nvSpPr>
-          <p:cNvPr id="6" name="TextBox 5"/>
-          <p:cNvSpPr txBox="1"/>
-          <p:nvPr/>
-        </p:nvSpPr>
-        <p:spPr>
-          <a:xfrm>
-            <a:off x="4526280" y="2286000"/>
-            <a:ext cx="3474720" cy="548640"/>
-          </a:xfrm>
-          <a:prstGeom prst="rect">
-            <a:avLst/>
-          </a:prstGeom>
-          <a:noFill/>
-        </p:spPr>
-        <p:txBody>
-          <a:bodyPr wrap="square" anchor="t">
-            <a:spAutoFit/>
-          </a:bodyPr>
-          <a:lstStyle/>
-          <a:p>
-            <a:pPr algn="l">
-              <a:lnSpc>
-                <a:spcPct val="100000"/>
-              </a:lnSpc>
-            </a:pPr>
-            <a:r>
-              <a:rPr sz="1800" b="0" i="0">
-                <a:solidFill>
-                  <a:srgbClr val="F3D9D1"/>
-                </a:solidFill>
-                <a:latin typeface="Inter"/>
-              </a:rPr>
-              <a:t>probaron el demo</a:t>
-            </a:r>
-          </a:p>
-        </p:txBody>
-      </p:sp>
-      <p:sp>
-        <p:nvSpPr>
-          <p:cNvPr id="7" name="TextBox 6"/>
-          <p:cNvSpPr txBox="1"/>
-          <p:nvPr/>
-        </p:nvSpPr>
-        <p:spPr>
-          <a:xfrm>
-            <a:off x="8138160" y="685800"/>
-            <a:ext cx="3474720" cy="1645920"/>
-          </a:xfrm>
-          <a:prstGeom prst="rect">
-            <a:avLst/>
-          </a:prstGeom>
-          <a:noFill/>
-        </p:spPr>
-        <p:txBody>
-          <a:bodyPr wrap="square" anchor="t">
-            <a:spAutoFit/>
-          </a:bodyPr>
-          <a:lstStyle/>
-          <a:p>
-            <a:pPr algn="l">
-              <a:lnSpc>
-                <a:spcPct val="100000"/>
-              </a:lnSpc>
-            </a:pPr>
-            <a:r>
-              <a:rPr sz="9000" b="1" i="0">
-                <a:solidFill>
-                  <a:srgbClr val="FFFFFF"/>
-                </a:solidFill>
-                <a:latin typeface="Fredoka"/>
-              </a:rPr>
-              <a:t>0.34%</a:t>
-            </a:r>
-          </a:p>
-        </p:txBody>
-      </p:sp>
-      <p:sp>
-        <p:nvSpPr>
-          <p:cNvPr id="8" name="TextBox 7"/>
-          <p:cNvSpPr txBox="1"/>
-          <p:nvPr/>
-        </p:nvSpPr>
-        <p:spPr>
-          <a:xfrm>
-            <a:off x="8183879" y="2286000"/>
-            <a:ext cx="3474720" cy="548640"/>
-          </a:xfrm>
-          <a:prstGeom prst="rect">
-            <a:avLst/>
-          </a:prstGeom>
-          <a:noFill/>
-        </p:spPr>
-        <p:txBody>
-          <a:bodyPr wrap="square" anchor="t">
-            <a:spAutoFit/>
-          </a:bodyPr>
-          <a:lstStyle/>
-          <a:p>
-            <a:pPr algn="l">
-              <a:lnSpc>
-                <a:spcPct val="100000"/>
-              </a:lnSpc>
-            </a:pPr>
-            <a:r>
-              <a:rPr sz="1800" b="0" i="0">
-                <a:solidFill>
-                  <a:srgbClr val="F3D9D1"/>
-                </a:solidFill>
-                <a:latin typeface="Inter"/>
-              </a:rPr>
-              <a:t>de conversión real</a:t>
-            </a:r>
-          </a:p>
-        </p:txBody>
-      </p:sp>
-      <p:sp>
-        <p:nvSpPr>
-          <p:cNvPr id="9" name="TextBox 8"/>
-          <p:cNvSpPr txBox="1"/>
-          <p:nvPr/>
-        </p:nvSpPr>
-        <p:spPr>
-          <a:xfrm>
-            <a:off x="868680" y="5250000"/>
-            <a:ext cx="9601200" cy="1097280"/>
-          </a:xfrm>
-          <a:prstGeom prst="rect">
-            <a:avLst/>
-          </a:prstGeom>
-          <a:noFill/>
-        </p:spPr>
-        <p:txBody>
-          <a:bodyPr wrap="square" anchor="t">
-            <a:spAutoFit/>
-          </a:bodyPr>
-          <a:lstStyle/>
-          <a:p>
-            <a:pPr algn="l">
-              <a:lnSpc>
-                <a:spcPct val="120000"/>
-              </a:lnSpc>
-            </a:pPr>
-            <a:r>
-              <a:rPr sz="2200" b="1" i="0">
-                <a:solidFill>
-                  <a:srgbClr val="FFFFFF"/>
-                </a:solidFill>
-                <a:latin typeface="Fredoka"/>
-              </a:rPr>
-              <a:t>El alcance funciona. La adopción real todavía no, y no lo descubrí el día 1, sino a mitad de campaña.</a:t>
-            </a:r>
-          </a:p>
-        </p:txBody>
-      </p:sp>
-      <p:pic>
-        <p:nvPicPr>
-          <p:cNvPr id="10" name="Picture 9" descr="vercel1-chart.png"/>
-          <p:cNvPicPr>
-            <a:picLocks noChangeAspect="1"/>
-          </p:cNvPicPr>
-          <p:nvPr/>
-        </p:nvPicPr>
-        <p:blipFill>
-          <a:blip r:embed="rId2"/>
-          <a:stretch>
-            <a:fillRect/>
-          </a:stretch>
-        </p:blipFill>
-        <p:spPr>
-          <a:xfrm>
-            <a:off x="1093960" y="3000000"/>
-            <a:ext cx="5040588" cy="2050000"/>
-          </a:xfrm>
-          <a:prstGeom prst="rect">
-            <a:avLst/>
-          </a:prstGeom>
-        </p:spPr>
-      </p:pic>
-      <p:pic>
-        <p:nvPicPr>
-          <p:cNvPr id="11" name="Picture 10" descr="vercel2-events.png"/>
-          <p:cNvPicPr>
-            <a:picLocks noChangeAspect="1"/>
-          </p:cNvPicPr>
-          <p:nvPr/>
-        </p:nvPicPr>
-        <p:blipFill>
-          <a:blip r:embed="rId3"/>
-          <a:stretch>
-            <a:fillRect/>
-          </a:stretch>
-        </p:blipFill>
-        <p:spPr>
-          <a:xfrm>
-            <a:off x="6434548" y="3000000"/>
-            <a:ext cx="4663186" cy="2050000"/>
-          </a:xfrm>
-          <a:prstGeom prst="rect">
-            <a:avLst/>
-          </a:prstGeom>
-        </p:spPr>
-      </p:pic>
-    </p:spTree>
-  </p:cSld>
-  <p:clrMapOvr>
-    <a:masterClrMapping/>
-  </p:clrMapOvr>
-</p:sld>
-</file>
-
-<file path=ppt/slides/slide7.xml><?xml version="1.0" encoding="utf-8"?>
-<p:sld xmlns:a="http://schemas.openxmlformats.org/drawingml/2006/main" xmlns:p="http://schemas.openxmlformats.org/presentationml/2006/main" xmlns:r="http://schemas.openxmlformats.org/officeDocument/2006/relationships">
-  <p:cSld>
-    <p:spTree>
-      <p:nvGrpSpPr>
-        <p:cNvPr id="1" name=""/>
-        <p:cNvGrpSpPr/>
-        <p:nvPr/>
-      </p:nvGrpSpPr>
-      <p:grpSpPr/>
-      <p:sp>
-        <p:nvSpPr>
-          <p:cNvPr id="2" name="Rectangle 1"/>
-          <p:cNvSpPr/>
-          <p:nvPr/>
-        </p:nvSpPr>
-        <p:spPr>
-          <a:xfrm>
-            <a:off x="0" y="0"/>
-            <a:ext cx="12191695" cy="6858000"/>
-          </a:xfrm>
-          <a:prstGeom prst="rect">
-            <a:avLst/>
-          </a:prstGeom>
-          <a:solidFill>
-            <a:srgbClr val="FAF9F5"/>
-          </a:solidFill>
-          <a:ln>
-            <a:noFill/>
-          </a:ln>
-          <a:effectLst/>
-        </p:spPr>
-        <p:style>
-          <a:lnRef idx="1">
-            <a:schemeClr val="accent1"/>
-          </a:lnRef>
-          <a:fillRef idx="3">
-            <a:schemeClr val="accent1"/>
-          </a:fillRef>
-          <a:effectRef idx="2">
-            <a:schemeClr val="accent1"/>
-          </a:effectRef>
-          <a:fontRef idx="minor">
-            <a:schemeClr val="lt1"/>
-          </a:fontRef>
-        </p:style>
-        <p:txBody>
-          <a:bodyPr rtlCol="0" anchor="ctr"/>
-          <a:lstStyle/>
-          <a:p>
-            <a:pPr algn="ctr"/>
+            <a:endParaRPr/>
           </a:p>
         </p:txBody>
       </p:sp>
@@ -5644,7 +5879,7 @@
 </file>
 
 <file path=ppt/slides/slide8.xml><?xml version="1.0" encoding="utf-8"?>
-<p:sld xmlns:a="http://schemas.openxmlformats.org/drawingml/2006/main" xmlns:p="http://schemas.openxmlformats.org/presentationml/2006/main" xmlns:r="http://schemas.openxmlformats.org/officeDocument/2006/relationships">
+<p:sld xmlns:a="http://schemas.openxmlformats.org/drawingml/2006/main" xmlns:r="http://schemas.openxmlformats.org/officeDocument/2006/relationships" xmlns:p="http://schemas.openxmlformats.org/presentationml/2006/main">
   <p:cSld>
     <p:spTree>
       <p:nvGrpSpPr>
@@ -5652,7 +5887,14 @@
         <p:cNvGrpSpPr/>
         <p:nvPr/>
       </p:nvGrpSpPr>
-      <p:grpSpPr/>
+      <p:grpSpPr>
+        <a:xfrm>
+          <a:off x="0" y="0"/>
+          <a:ext cx="0" cy="0"/>
+          <a:chOff x="0" y="0"/>
+          <a:chExt cx="0" cy="0"/>
+        </a:xfrm>
+      </p:grpSpPr>
       <p:sp>
         <p:nvSpPr>
           <p:cNvPr id="2" name="Rectangle 1"/>
@@ -5694,6 +5936,7 @@
           <a:lstStyle/>
           <a:p>
             <a:pPr algn="ctr"/>
+            <a:endParaRPr/>
           </a:p>
         </p:txBody>
       </p:sp>
@@ -5730,7 +5973,7 @@
 </file>
 
 <file path=ppt/slides/slide9.xml><?xml version="1.0" encoding="utf-8"?>
-<p:sld xmlns:a="http://schemas.openxmlformats.org/drawingml/2006/main" xmlns:p="http://schemas.openxmlformats.org/presentationml/2006/main" xmlns:r="http://schemas.openxmlformats.org/officeDocument/2006/relationships">
+<p:sld xmlns:a="http://schemas.openxmlformats.org/drawingml/2006/main" xmlns:r="http://schemas.openxmlformats.org/officeDocument/2006/relationships" xmlns:p="http://schemas.openxmlformats.org/presentationml/2006/main">
   <p:cSld>
     <p:spTree>
       <p:nvGrpSpPr>
@@ -5738,7 +5981,14 @@
         <p:cNvGrpSpPr/>
         <p:nvPr/>
       </p:nvGrpSpPr>
-      <p:grpSpPr/>
+      <p:grpSpPr>
+        <a:xfrm>
+          <a:off x="0" y="0"/>
+          <a:ext cx="0" cy="0"/>
+          <a:chOff x="0" y="0"/>
+          <a:chExt cx="0" cy="0"/>
+        </a:xfrm>
+      </p:grpSpPr>
       <p:sp>
         <p:nvSpPr>
           <p:cNvPr id="2" name="Rectangle 1"/>
@@ -5780,6 +6030,7 @@
           <a:lstStyle/>
           <a:p>
             <a:pPr algn="ctr"/>
+            <a:endParaRPr/>
           </a:p>
         </p:txBody>
       </p:sp>
@@ -5792,7 +6043,7 @@
           <p:nvPr/>
         </p:nvPicPr>
         <p:blipFill>
-          <a:blip r:embed="rId4"/>
+          <a:blip r:embed="rId3"/>
           <a:stretch>
             <a:fillRect/>
           </a:stretch>
@@ -6146,44 +6397,44 @@
         <a:sysClr val="window" lastClr="FFFFFF"/>
       </a:lt1>
       <a:dk2>
-        <a:srgbClr val="1F497D"/>
+        <a:srgbClr val="0E2841"/>
       </a:dk2>
       <a:lt2>
-        <a:srgbClr val="EEECE1"/>
+        <a:srgbClr val="E8E8E8"/>
       </a:lt2>
       <a:accent1>
-        <a:srgbClr val="4F81BD"/>
+        <a:srgbClr val="156082"/>
       </a:accent1>
       <a:accent2>
-        <a:srgbClr val="C0504D"/>
+        <a:srgbClr val="E97132"/>
       </a:accent2>
       <a:accent3>
-        <a:srgbClr val="9BBB59"/>
+        <a:srgbClr val="196B24"/>
       </a:accent3>
       <a:accent4>
-        <a:srgbClr val="8064A2"/>
+        <a:srgbClr val="0F9ED5"/>
       </a:accent4>
       <a:accent5>
-        <a:srgbClr val="4BACC6"/>
+        <a:srgbClr val="A02B93"/>
       </a:accent5>
       <a:accent6>
-        <a:srgbClr val="F79646"/>
+        <a:srgbClr val="4EA72E"/>
       </a:accent6>
       <a:hlink>
-        <a:srgbClr val="0000FF"/>
+        <a:srgbClr val="467886"/>
       </a:hlink>
       <a:folHlink>
-        <a:srgbClr val="800080"/>
+        <a:srgbClr val="96607D"/>
       </a:folHlink>
     </a:clrScheme>
     <a:fontScheme name="Office">
       <a:majorFont>
-        <a:latin typeface="Calibri"/>
+        <a:latin typeface="Aptos Display" panose="02110004020202020204"/>
         <a:ea typeface=""/>
         <a:cs typeface=""/>
-        <a:font script="Jpan" typeface="ＭＳ Ｐゴシック"/>
+        <a:font script="Jpan" typeface="游ゴシック Light"/>
         <a:font script="Hang" typeface="맑은 고딕"/>
-        <a:font script="Hans" typeface="宋体"/>
+        <a:font script="Hans" typeface="等线 Light"/>
         <a:font script="Hant" typeface="新細明體"/>
         <a:font script="Arab" typeface="Times New Roman"/>
         <a:font script="Hebr" typeface="Times New Roman"/>
@@ -6211,14 +6462,31 @@
         <a:font script="Viet" typeface="Times New Roman"/>
         <a:font script="Uigh" typeface="Microsoft Uighur"/>
         <a:font script="Geor" typeface="Sylfaen"/>
+        <a:font script="Armn" typeface="Arial"/>
+        <a:font script="Bugi" typeface="Leelawadee UI"/>
+        <a:font script="Bopo" typeface="Microsoft JhengHei"/>
+        <a:font script="Java" typeface="Javanese Text"/>
+        <a:font script="Lisu" typeface="Segoe UI"/>
+        <a:font script="Mymr" typeface="Myanmar Text"/>
+        <a:font script="Nkoo" typeface="Ebrima"/>
+        <a:font script="Olck" typeface="Nirmala UI"/>
+        <a:font script="Osma" typeface="Ebrima"/>
+        <a:font script="Phag" typeface="Phagspa"/>
+        <a:font script="Syrn" typeface="Estrangelo Edessa"/>
+        <a:font script="Syrj" typeface="Estrangelo Edessa"/>
+        <a:font script="Syre" typeface="Estrangelo Edessa"/>
+        <a:font script="Sora" typeface="Nirmala UI"/>
+        <a:font script="Tale" typeface="Microsoft Tai Le"/>
+        <a:font script="Talu" typeface="Microsoft New Tai Lue"/>
+        <a:font script="Tfng" typeface="Ebrima"/>
       </a:majorFont>
       <a:minorFont>
-        <a:latin typeface="Calibri"/>
+        <a:latin typeface="Aptos" panose="02110004020202020204"/>
         <a:ea typeface=""/>
         <a:cs typeface=""/>
-        <a:font script="Jpan" typeface="ＭＳ Ｐゴシック"/>
+        <a:font script="Jpan" typeface="游ゴシック"/>
         <a:font script="Hang" typeface="맑은 고딕"/>
-        <a:font script="Hans" typeface="宋体"/>
+        <a:font script="Hans" typeface="等线"/>
         <a:font script="Hant" typeface="新細明體"/>
         <a:font script="Arab" typeface="Arial"/>
         <a:font script="Hebr" typeface="Arial"/>
@@ -6246,6 +6514,23 @@
         <a:font script="Viet" typeface="Arial"/>
         <a:font script="Uigh" typeface="Microsoft Uighur"/>
         <a:font script="Geor" typeface="Sylfaen"/>
+        <a:font script="Armn" typeface="Arial"/>
+        <a:font script="Bugi" typeface="Leelawadee UI"/>
+        <a:font script="Bopo" typeface="Microsoft JhengHei"/>
+        <a:font script="Java" typeface="Javanese Text"/>
+        <a:font script="Lisu" typeface="Segoe UI"/>
+        <a:font script="Mymr" typeface="Myanmar Text"/>
+        <a:font script="Nkoo" typeface="Ebrima"/>
+        <a:font script="Olck" typeface="Nirmala UI"/>
+        <a:font script="Osma" typeface="Ebrima"/>
+        <a:font script="Phag" typeface="Phagspa"/>
+        <a:font script="Syrn" typeface="Estrangelo Edessa"/>
+        <a:font script="Syrj" typeface="Estrangelo Edessa"/>
+        <a:font script="Syre" typeface="Estrangelo Edessa"/>
+        <a:font script="Sora" typeface="Nirmala UI"/>
+        <a:font script="Tale" typeface="Microsoft Tai Le"/>
+        <a:font script="Talu" typeface="Microsoft New Tai Lue"/>
+        <a:font script="Tfng" typeface="Ebrima"/>
       </a:minorFont>
     </a:fontScheme>
     <a:fmtScheme name="Office">
@@ -6257,180 +6542,136 @@
           <a:gsLst>
             <a:gs pos="0">
               <a:schemeClr val="phClr">
-                <a:tint val="50000"/>
-                <a:satMod val="300000"/>
+                <a:lumMod val="110000"/>
+                <a:satMod val="105000"/>
+                <a:tint val="67000"/>
               </a:schemeClr>
             </a:gs>
-            <a:gs pos="35000">
+            <a:gs pos="50000">
               <a:schemeClr val="phClr">
-                <a:tint val="37000"/>
-                <a:satMod val="300000"/>
+                <a:lumMod val="105000"/>
+                <a:satMod val="103000"/>
+                <a:tint val="73000"/>
               </a:schemeClr>
             </a:gs>
             <a:gs pos="100000">
               <a:schemeClr val="phClr">
-                <a:tint val="15000"/>
-                <a:satMod val="350000"/>
+                <a:lumMod val="105000"/>
+                <a:satMod val="109000"/>
+                <a:tint val="81000"/>
               </a:schemeClr>
             </a:gs>
           </a:gsLst>
-          <a:lin ang="16200000" scaled="1"/>
+          <a:lin ang="5400000" scaled="0"/>
         </a:gradFill>
         <a:gradFill rotWithShape="1">
           <a:gsLst>
             <a:gs pos="0">
               <a:schemeClr val="phClr">
-                <a:tint val="100000"/>
+                <a:satMod val="103000"/>
+                <a:lumMod val="102000"/>
+                <a:tint val="94000"/>
+              </a:schemeClr>
+            </a:gs>
+            <a:gs pos="50000">
+              <a:schemeClr val="phClr">
+                <a:satMod val="110000"/>
+                <a:lumMod val="100000"/>
                 <a:shade val="100000"/>
-                <a:satMod val="130000"/>
               </a:schemeClr>
             </a:gs>
             <a:gs pos="100000">
               <a:schemeClr val="phClr">
-                <a:tint val="50000"/>
-                <a:shade val="100000"/>
-                <a:satMod val="350000"/>
+                <a:lumMod val="99000"/>
+                <a:satMod val="120000"/>
+                <a:shade val="78000"/>
               </a:schemeClr>
             </a:gs>
           </a:gsLst>
-          <a:lin ang="16200000" scaled="0"/>
+          <a:lin ang="5400000" scaled="0"/>
         </a:gradFill>
       </a:fillStyleLst>
       <a:lnStyleLst>
-        <a:ln w="9525" cap="flat" cmpd="sng" algn="ctr">
+        <a:ln w="12700" cap="flat" cmpd="sng" algn="ctr">
           <a:solidFill>
-            <a:schemeClr val="phClr">
-              <a:shade val="95000"/>
-              <a:satMod val="105000"/>
-            </a:schemeClr>
+            <a:schemeClr val="phClr"/>
           </a:solidFill>
           <a:prstDash val="solid"/>
+          <a:miter lim="800000"/>
+        </a:ln>
+        <a:ln w="19050" cap="flat" cmpd="sng" algn="ctr">
+          <a:solidFill>
+            <a:schemeClr val="phClr"/>
+          </a:solidFill>
+          <a:prstDash val="solid"/>
+          <a:miter lim="800000"/>
         </a:ln>
         <a:ln w="25400" cap="flat" cmpd="sng" algn="ctr">
           <a:solidFill>
             <a:schemeClr val="phClr"/>
           </a:solidFill>
           <a:prstDash val="solid"/>
-        </a:ln>
-        <a:ln w="38100" cap="flat" cmpd="sng" algn="ctr">
-          <a:solidFill>
-            <a:schemeClr val="phClr"/>
-          </a:solidFill>
-          <a:prstDash val="solid"/>
+          <a:miter lim="800000"/>
         </a:ln>
       </a:lnStyleLst>
       <a:effectStyleLst>
         <a:effectStyle>
+          <a:effectLst/>
+        </a:effectStyle>
+        <a:effectStyle>
+          <a:effectLst/>
+        </a:effectStyle>
+        <a:effectStyle>
           <a:effectLst>
-            <a:outerShdw blurRad="40000" dist="20000" dir="5400000" rotWithShape="0">
+            <a:outerShdw blurRad="57150" dist="19050" dir="5400000" algn="ctr" rotWithShape="0">
               <a:srgbClr val="000000">
-                <a:alpha val="38000"/>
+                <a:alpha val="63000"/>
               </a:srgbClr>
             </a:outerShdw>
           </a:effectLst>
-        </a:effectStyle>
-        <a:effectStyle>
-          <a:effectLst>
-            <a:outerShdw blurRad="40000" dist="23000" dir="5400000" rotWithShape="0">
-              <a:srgbClr val="000000">
-                <a:alpha val="35000"/>
-              </a:srgbClr>
-            </a:outerShdw>
-          </a:effectLst>
-        </a:effectStyle>
-        <a:effectStyle>
-          <a:effectLst>
-            <a:outerShdw blurRad="40000" dist="23000" dir="5400000" rotWithShape="0">
-              <a:srgbClr val="000000">
-                <a:alpha val="35000"/>
-              </a:srgbClr>
-            </a:outerShdw>
-          </a:effectLst>
-          <a:scene3d>
-            <a:camera prst="orthographicFront">
-              <a:rot lat="0" lon="0" rev="0"/>
-            </a:camera>
-            <a:lightRig rig="threePt" dir="t">
-              <a:rot lat="0" lon="0" rev="1200000"/>
-            </a:lightRig>
-          </a:scene3d>
-          <a:sp3d>
-            <a:bevelT w="63500" h="25400"/>
-          </a:sp3d>
         </a:effectStyle>
       </a:effectStyleLst>
       <a:bgFillStyleLst>
         <a:solidFill>
           <a:schemeClr val="phClr"/>
         </a:solidFill>
+        <a:solidFill>
+          <a:schemeClr val="phClr">
+            <a:tint val="95000"/>
+            <a:satMod val="170000"/>
+          </a:schemeClr>
+        </a:solidFill>
         <a:gradFill rotWithShape="1">
           <a:gsLst>
             <a:gs pos="0">
               <a:schemeClr val="phClr">
-                <a:tint val="40000"/>
-                <a:satMod val="350000"/>
+                <a:tint val="93000"/>
+                <a:satMod val="150000"/>
+                <a:shade val="98000"/>
+                <a:lumMod val="102000"/>
               </a:schemeClr>
             </a:gs>
-            <a:gs pos="40000">
+            <a:gs pos="50000">
               <a:schemeClr val="phClr">
-                <a:tint val="45000"/>
-                <a:shade val="99000"/>
-                <a:satMod val="350000"/>
+                <a:tint val="98000"/>
+                <a:satMod val="130000"/>
+                <a:shade val="90000"/>
+                <a:lumMod val="103000"/>
               </a:schemeClr>
             </a:gs>
             <a:gs pos="100000">
               <a:schemeClr val="phClr">
-                <a:shade val="20000"/>
-                <a:satMod val="255000"/>
+                <a:shade val="63000"/>
+                <a:satMod val="120000"/>
               </a:schemeClr>
             </a:gs>
           </a:gsLst>
-          <a:path path="circle">
-            <a:fillToRect l="50000" t="-80000" r="50000" b="180000"/>
-          </a:path>
-        </a:gradFill>
-        <a:gradFill rotWithShape="1">
-          <a:gsLst>
-            <a:gs pos="0">
-              <a:schemeClr val="phClr">
-                <a:tint val="80000"/>
-                <a:satMod val="300000"/>
-              </a:schemeClr>
-            </a:gs>
-            <a:gs pos="100000">
-              <a:schemeClr val="phClr">
-                <a:shade val="30000"/>
-                <a:satMod val="200000"/>
-              </a:schemeClr>
-            </a:gs>
-          </a:gsLst>
-          <a:path path="circle">
-            <a:fillToRect l="50000" t="50000" r="50000" b="50000"/>
-          </a:path>
+          <a:lin ang="5400000" scaled="0"/>
         </a:gradFill>
       </a:bgFillStyleLst>
     </a:fmtScheme>
   </a:themeElements>
   <a:objectDefaults>
-    <a:spDef>
-      <a:spPr/>
-      <a:bodyPr/>
-      <a:lstStyle/>
-      <a:style>
-        <a:lnRef idx="1">
-          <a:schemeClr val="accent1"/>
-        </a:lnRef>
-        <a:fillRef idx="3">
-          <a:schemeClr val="accent1"/>
-        </a:fillRef>
-        <a:effectRef idx="2">
-          <a:schemeClr val="accent1"/>
-        </a:effectRef>
-        <a:fontRef idx="minor">
-          <a:schemeClr val="lt1"/>
-        </a:fontRef>
-      </a:style>
-    </a:spDef>
     <a:lnDef>
       <a:spPr/>
       <a:bodyPr/>
@@ -6452,5 +6693,10 @@
     </a:lnDef>
   </a:objectDefaults>
   <a:extraClrSchemeLst/>
+  <a:extLst>
+    <a:ext uri="{05A4C25C-085E-4340-85A3-A5531E510DB2}">
+      <thm15:themeFamily xmlns:thm15="http://schemas.microsoft.com/office/thememl/2012/main" name="Office Theme" id="{2E142A2C-CD16-42D6-873A-C26D2A0506FA}" vid="{1BDDFF52-6CD6-40A5-AB3C-68EB2F1E4D0A}"/>
+    </a:ext>
+  </a:extLst>
 </a:theme>
 </file>
</xml_diff>